<commit_message>
docs(slides): frame the anomaly example as detect-then-triage, not a smoking gun
The 117x spike is real but its contents turned out to be benign Windows PowerShell module loading during development work (verified by inspecting all 110 detections in that hour), and the baseline is diluted by long quiet periods in the PC's log span. Presenting it as a dramatic detection would collapse under one audience question. The slide now states the triage outcome on it - the spike was confirmed harmless, and the feature's role is surfacing 'unusual' for a human to check, with the evidence one click away.

Co-Authored-By: Claude Fable 5 <noreply@anthropic.com>
</commit_message>
<xml_diff>
--- a/docs/presentation/pptx/hayabusa-plus.pptx
+++ b/docs/presentation/pptx/hayabusa-plus.pptx
@@ -3651,7 +3651,7 @@
         <p:spPr>
           <a:xfrm>
             <a:off x="548640" y="2240280"/>
-            <a:ext cx="2697480" cy="2743200"/>
+            <a:ext cx="2697480" cy="2606040"/>
           </a:xfrm>
           <a:prstGeom prst="roundRect">
             <a:avLst/>
@@ -3697,7 +3697,7 @@
         <p:spPr>
           <a:xfrm>
             <a:off x="548640" y="2240280"/>
-            <a:ext cx="73152" cy="2743200"/>
+            <a:ext cx="73152" cy="2606040"/>
           </a:xfrm>
           <a:prstGeom prst="rect">
             <a:avLst/>
@@ -3740,8 +3740,8 @@
         </p:nvSpPr>
         <p:spPr>
           <a:xfrm>
-            <a:off x="731520" y="2404872"/>
-            <a:ext cx="914400" cy="594360"/>
+            <a:off x="731520" y="2386584"/>
+            <a:ext cx="914400" cy="566928"/>
           </a:xfrm>
           <a:prstGeom prst="rect">
             <a:avLst/>
@@ -3760,7 +3760,7 @@
               </a:lnSpc>
             </a:pPr>
             <a:r>
-              <a:rPr sz="2800" b="0" i="0">
+              <a:rPr sz="2600" b="0" i="0">
                 <a:solidFill>
                   <a:srgbClr val="2563EB"/>
                 </a:solidFill>
@@ -3779,7 +3779,7 @@
         </p:nvSpPr>
         <p:spPr>
           <a:xfrm>
-            <a:off x="731520" y="3017520"/>
+            <a:off x="731520" y="2971800"/>
             <a:ext cx="2423160" cy="457200"/>
           </a:xfrm>
           <a:prstGeom prst="rect">
@@ -3818,7 +3818,7 @@
         </p:nvSpPr>
         <p:spPr>
           <a:xfrm>
-            <a:off x="731520" y="3520440"/>
+            <a:off x="731520" y="3456432"/>
             <a:ext cx="2331720" cy="822960"/>
           </a:xfrm>
           <a:prstGeom prst="rect">
@@ -3858,7 +3858,7 @@
         </p:nvSpPr>
         <p:spPr>
           <a:xfrm>
-            <a:off x="731520" y="4434840"/>
+            <a:off x="731520" y="4325112"/>
             <a:ext cx="2331720" cy="457200"/>
           </a:xfrm>
           <a:prstGeom prst="rect">
@@ -3898,7 +3898,7 @@
         <p:spPr>
           <a:xfrm>
             <a:off x="3429000" y="2240280"/>
-            <a:ext cx="2697480" cy="2743200"/>
+            <a:ext cx="2697480" cy="2606040"/>
           </a:xfrm>
           <a:prstGeom prst="roundRect">
             <a:avLst/>
@@ -3944,7 +3944,7 @@
         <p:spPr>
           <a:xfrm>
             <a:off x="3429000" y="2240280"/>
-            <a:ext cx="73152" cy="2743200"/>
+            <a:ext cx="73152" cy="2606040"/>
           </a:xfrm>
           <a:prstGeom prst="rect">
             <a:avLst/>
@@ -3987,8 +3987,8 @@
         </p:nvSpPr>
         <p:spPr>
           <a:xfrm>
-            <a:off x="3611880" y="2404872"/>
-            <a:ext cx="914400" cy="594360"/>
+            <a:off x="3611880" y="2386584"/>
+            <a:ext cx="914400" cy="566928"/>
           </a:xfrm>
           <a:prstGeom prst="rect">
             <a:avLst/>
@@ -4007,7 +4007,7 @@
               </a:lnSpc>
             </a:pPr>
             <a:r>
-              <a:rPr sz="2800" b="0" i="0">
+              <a:rPr sz="2600" b="0" i="0">
                 <a:solidFill>
                   <a:srgbClr val="2563EB"/>
                 </a:solidFill>
@@ -4026,7 +4026,7 @@
         </p:nvSpPr>
         <p:spPr>
           <a:xfrm>
-            <a:off x="3611880" y="3017520"/>
+            <a:off x="3611880" y="2971800"/>
             <a:ext cx="2423160" cy="457200"/>
           </a:xfrm>
           <a:prstGeom prst="rect">
@@ -4065,7 +4065,7 @@
         </p:nvSpPr>
         <p:spPr>
           <a:xfrm>
-            <a:off x="3611880" y="3520440"/>
+            <a:off x="3611880" y="3456432"/>
             <a:ext cx="2331720" cy="822960"/>
           </a:xfrm>
           <a:prstGeom prst="rect">
@@ -4105,7 +4105,7 @@
         </p:nvSpPr>
         <p:spPr>
           <a:xfrm>
-            <a:off x="3611880" y="4434840"/>
+            <a:off x="3611880" y="4325112"/>
             <a:ext cx="2331720" cy="457200"/>
           </a:xfrm>
           <a:prstGeom prst="rect">
@@ -4145,7 +4145,7 @@
         <p:spPr>
           <a:xfrm>
             <a:off x="6309360" y="2240280"/>
-            <a:ext cx="2697480" cy="2743200"/>
+            <a:ext cx="2697480" cy="2606040"/>
           </a:xfrm>
           <a:prstGeom prst="roundRect">
             <a:avLst/>
@@ -4191,7 +4191,7 @@
         <p:spPr>
           <a:xfrm>
             <a:off x="6309360" y="2240280"/>
-            <a:ext cx="73152" cy="2743200"/>
+            <a:ext cx="73152" cy="2606040"/>
           </a:xfrm>
           <a:prstGeom prst="rect">
             <a:avLst/>
@@ -4234,8 +4234,8 @@
         </p:nvSpPr>
         <p:spPr>
           <a:xfrm>
-            <a:off x="6492240" y="2404872"/>
-            <a:ext cx="914400" cy="594360"/>
+            <a:off x="6492240" y="2386584"/>
+            <a:ext cx="914400" cy="566928"/>
           </a:xfrm>
           <a:prstGeom prst="rect">
             <a:avLst/>
@@ -4254,7 +4254,7 @@
               </a:lnSpc>
             </a:pPr>
             <a:r>
-              <a:rPr sz="2800" b="0" i="0">
+              <a:rPr sz="2600" b="0" i="0">
                 <a:solidFill>
                   <a:srgbClr val="2563EB"/>
                 </a:solidFill>
@@ -4273,7 +4273,7 @@
         </p:nvSpPr>
         <p:spPr>
           <a:xfrm>
-            <a:off x="6492240" y="3017520"/>
+            <a:off x="6492240" y="2971800"/>
             <a:ext cx="2423160" cy="457200"/>
           </a:xfrm>
           <a:prstGeom prst="rect">
@@ -4312,7 +4312,7 @@
         </p:nvSpPr>
         <p:spPr>
           <a:xfrm>
-            <a:off x="6492240" y="3520440"/>
+            <a:off x="6492240" y="3456432"/>
             <a:ext cx="2331720" cy="822960"/>
           </a:xfrm>
           <a:prstGeom prst="rect">
@@ -4352,7 +4352,7 @@
         </p:nvSpPr>
         <p:spPr>
           <a:xfrm>
-            <a:off x="6492240" y="4434840"/>
+            <a:off x="6492240" y="4325112"/>
             <a:ext cx="2331720" cy="457200"/>
           </a:xfrm>
           <a:prstGeom prst="rect">
@@ -4392,7 +4392,7 @@
         <p:spPr>
           <a:xfrm>
             <a:off x="9189720" y="2240280"/>
-            <a:ext cx="2697480" cy="2743200"/>
+            <a:ext cx="2697480" cy="2606040"/>
           </a:xfrm>
           <a:prstGeom prst="roundRect">
             <a:avLst/>
@@ -4438,7 +4438,7 @@
         <p:spPr>
           <a:xfrm>
             <a:off x="9189720" y="2240280"/>
-            <a:ext cx="73152" cy="2743200"/>
+            <a:ext cx="73152" cy="2606040"/>
           </a:xfrm>
           <a:prstGeom prst="rect">
             <a:avLst/>
@@ -4481,8 +4481,8 @@
         </p:nvSpPr>
         <p:spPr>
           <a:xfrm>
-            <a:off x="9372600" y="2404872"/>
-            <a:ext cx="914400" cy="594360"/>
+            <a:off x="9372600" y="2386584"/>
+            <a:ext cx="914400" cy="566928"/>
           </a:xfrm>
           <a:prstGeom prst="rect">
             <a:avLst/>
@@ -4501,7 +4501,7 @@
               </a:lnSpc>
             </a:pPr>
             <a:r>
-              <a:rPr sz="2800" b="0" i="0">
+              <a:rPr sz="2600" b="0" i="0">
                 <a:solidFill>
                   <a:srgbClr val="2563EB"/>
                 </a:solidFill>
@@ -4520,7 +4520,7 @@
         </p:nvSpPr>
         <p:spPr>
           <a:xfrm>
-            <a:off x="9372600" y="3017520"/>
+            <a:off x="9372600" y="2971800"/>
             <a:ext cx="2423160" cy="457200"/>
           </a:xfrm>
           <a:prstGeom prst="rect">
@@ -4559,7 +4559,7 @@
         </p:nvSpPr>
         <p:spPr>
           <a:xfrm>
-            <a:off x="9372600" y="3520440"/>
+            <a:off x="9372600" y="3456432"/>
             <a:ext cx="2331720" cy="822960"/>
           </a:xfrm>
           <a:prstGeom prst="rect">
@@ -4599,7 +4599,7 @@
         </p:nvSpPr>
         <p:spPr>
           <a:xfrm>
-            <a:off x="9372600" y="4434840"/>
+            <a:off x="9372600" y="4325112"/>
             <a:ext cx="2331720" cy="457200"/>
           </a:xfrm>
           <a:prstGeom prst="rect">
@@ -4638,8 +4638,8 @@
         </p:nvSpPr>
         <p:spPr>
           <a:xfrm>
-            <a:off x="548640" y="5166360"/>
-            <a:ext cx="11064240" cy="1188720"/>
+            <a:off x="548640" y="5029200"/>
+            <a:ext cx="11064240" cy="1371600"/>
           </a:xfrm>
           <a:prstGeom prst="roundRect">
             <a:avLst/>
@@ -4684,7 +4684,7 @@
         </p:nvSpPr>
         <p:spPr>
           <a:xfrm>
-            <a:off x="868680" y="5285232"/>
+            <a:off x="868680" y="5138928"/>
             <a:ext cx="10515600" cy="365760"/>
           </a:xfrm>
           <a:prstGeom prst="rect">
@@ -4710,7 +4710,7 @@
                 </a:solidFill>
                 <a:latin typeface="Calibri"/>
               </a:rPr>
-              <a:t>💡 実例:  自分の PC を実際にスキャン → 「疑わしい PowerShell 実行」の急増を自動検出</a:t>
+              <a:t>💡 実例:  自分の PC のスキャンで、「疑わしい PowerShell 実行」の急増に自動で気づけた</a:t>
             </a:r>
           </a:p>
         </p:txBody>
@@ -4723,7 +4723,7 @@
         </p:nvSpPr>
         <p:spPr>
           <a:xfrm>
-            <a:off x="868680" y="5715000"/>
+            <a:off x="868680" y="5541264"/>
             <a:ext cx="2788920" cy="274320"/>
           </a:xfrm>
           <a:prstGeom prst="rect">
@@ -4762,7 +4762,7 @@
         </p:nvSpPr>
         <p:spPr>
           <a:xfrm>
-            <a:off x="3749039" y="5751576"/>
+            <a:off x="3749039" y="5577840"/>
             <a:ext cx="5486400" cy="201168"/>
           </a:xfrm>
           <a:prstGeom prst="roundRect">
@@ -4808,7 +4808,7 @@
         </p:nvSpPr>
         <p:spPr>
           <a:xfrm>
-            <a:off x="3749039" y="5751576"/>
+            <a:off x="3749039" y="5577840"/>
             <a:ext cx="91440" cy="201168"/>
           </a:xfrm>
           <a:prstGeom prst="roundRect">
@@ -4852,7 +4852,7 @@
         </p:nvSpPr>
         <p:spPr>
           <a:xfrm>
-            <a:off x="9372600" y="5715000"/>
+            <a:off x="9372600" y="5541264"/>
             <a:ext cx="2148840" cy="274320"/>
           </a:xfrm>
           <a:prstGeom prst="rect">
@@ -4891,7 +4891,7 @@
         </p:nvSpPr>
         <p:spPr>
           <a:xfrm>
-            <a:off x="868680" y="6053328"/>
+            <a:off x="868680" y="5870448"/>
             <a:ext cx="2788920" cy="274320"/>
           </a:xfrm>
           <a:prstGeom prst="rect">
@@ -4930,7 +4930,7 @@
         </p:nvSpPr>
         <p:spPr>
           <a:xfrm>
-            <a:off x="3749039" y="6089904"/>
+            <a:off x="3749039" y="5907024"/>
             <a:ext cx="5486400" cy="201168"/>
           </a:xfrm>
           <a:prstGeom prst="roundRect">
@@ -4976,7 +4976,7 @@
         </p:nvSpPr>
         <p:spPr>
           <a:xfrm>
-            <a:off x="3749039" y="6089904"/>
+            <a:off x="3749039" y="5907024"/>
             <a:ext cx="5486400" cy="201168"/>
           </a:xfrm>
           <a:prstGeom prst="roundRect">
@@ -5020,7 +5020,7 @@
         </p:nvSpPr>
         <p:spPr>
           <a:xfrm>
-            <a:off x="9372600" y="6053328"/>
+            <a:off x="9372600" y="5870448"/>
             <a:ext cx="2148840" cy="274320"/>
           </a:xfrm>
           <a:prstGeom prst="rect">
@@ -5054,6 +5054,45 @@
       <p:sp>
         <p:nvSpPr>
           <p:cNvPr id="40" name="TextBox 39"/>
+          <p:cNvSpPr txBox="1"/>
+          <p:nvPr/>
+        </p:nvSpPr>
+        <p:spPr>
+          <a:xfrm>
+            <a:off x="868680" y="6163056"/>
+            <a:ext cx="10515600" cy="292608"/>
+          </a:xfrm>
+          <a:prstGeom prst="rect">
+            <a:avLst/>
+          </a:prstGeom>
+          <a:noFill/>
+        </p:spPr>
+        <p:txBody>
+          <a:bodyPr wrap="square" lIns="0" rIns="0" tIns="0" bIns="0" anchor="t">
+            <a:spAutoFit/>
+          </a:bodyPr>
+          <a:lstStyle/>
+          <a:p>
+            <a:pPr algn="ctr">
+              <a:lnSpc>
+                <a:spcPct val="130000"/>
+              </a:lnSpc>
+            </a:pPr>
+            <a:r>
+              <a:rPr sz="1050" b="0" i="0">
+                <a:solidFill>
+                  <a:srgbClr val="5B6472"/>
+                </a:solidFill>
+                <a:latin typeface="Calibri"/>
+              </a:rPr>
+              <a:t>中身を確認すると無害な開発作業と判定できた。役目は「普段と違う」への気づき — 中身の確認まで同じ画面で完結します。</a:t>
+            </a:r>
+          </a:p>
+        </p:txBody>
+      </p:sp>
+      <p:sp>
+        <p:nvSpPr>
+          <p:cNvPr id="41" name="TextBox 40"/>
           <p:cNvSpPr txBox="1"/>
           <p:nvPr/>
         </p:nvSpPr>

</xml_diff>

<commit_message>
docs(slides): rebuild deck with rules-vs-behavioral comparison slide
Co-Authored-By: Claude Fable 5 <noreply@anthropic.com>
</commit_message>
<xml_diff>
--- a/docs/presentation/pptx/hayabusa-plus.pptx
+++ b/docs/presentation/pptx/hayabusa-plus.pptx
@@ -4684,8 +4684,8 @@
         </p:nvSpPr>
         <p:spPr>
           <a:xfrm>
-            <a:off x="868680" y="5138928"/>
-            <a:ext cx="10515600" cy="365760"/>
+            <a:off x="914400" y="5230368"/>
+            <a:ext cx="4937760" cy="365760"/>
           </a:xfrm>
           <a:prstGeom prst="rect">
             <a:avLst/>
@@ -4710,7 +4710,7 @@
                 </a:solidFill>
                 <a:latin typeface="Calibri"/>
               </a:rPr>
-              <a:t>💡 実例:  自分の PC のスキャンで、「疑わしい PowerShell 実行」の急増に自動で気づけた</a:t>
+              <a:t>📏 ルールによる検知 (既存の方法)</a:t>
             </a:r>
           </a:p>
         </p:txBody>
@@ -4723,58 +4723,57 @@
         </p:nvSpPr>
         <p:spPr>
           <a:xfrm>
-            <a:off x="868680" y="5541264"/>
-            <a:ext cx="2788920" cy="274320"/>
-          </a:xfrm>
-          <a:prstGeom prst="rect">
-            <a:avLst/>
-          </a:prstGeom>
-          <a:noFill/>
-        </p:spPr>
-        <p:txBody>
-          <a:bodyPr wrap="square" lIns="0" rIns="0" tIns="0" bIns="0" anchor="ctr">
+            <a:off x="914400" y="5614416"/>
+            <a:ext cx="4937760" cy="685800"/>
+          </a:xfrm>
+          <a:prstGeom prst="rect">
+            <a:avLst/>
+          </a:prstGeom>
+          <a:noFill/>
+        </p:spPr>
+        <p:txBody>
+          <a:bodyPr wrap="square" lIns="0" rIns="0" tIns="0" bIns="0" anchor="t">
             <a:spAutoFit/>
           </a:bodyPr>
           <a:lstStyle/>
           <a:p>
             <a:pPr algn="l">
               <a:lnSpc>
-                <a:spcPct val="130000"/>
-              </a:lnSpc>
-            </a:pPr>
-            <a:r>
-              <a:rPr sz="1100" b="0" i="0">
+                <a:spcPct val="140000"/>
+              </a:lnSpc>
+            </a:pPr>
+            <a:r>
+              <a:rPr sz="1150" b="0" i="0">
                 <a:solidFill>
                   <a:srgbClr val="5B6472"/>
                 </a:solidFill>
                 <a:latin typeface="Calibri"/>
               </a:rPr>
-              <a:t>平常時 (この PC の全期間平均)</a:t>
-            </a:r>
-          </a:p>
-        </p:txBody>
-      </p:sp>
-      <p:sp>
-        <p:nvSpPr>
-          <p:cNvPr id="33" name="Rounded Rectangle 32"/>
+              <a:t>事前に知っている「悪い特徴」と一致したら警告。
+既に知られている手口には確実で強い。</a:t>
+            </a:r>
+          </a:p>
+        </p:txBody>
+      </p:sp>
+      <p:sp>
+        <p:nvSpPr>
+          <p:cNvPr id="33" name="Rectangle 32"/>
           <p:cNvSpPr/>
           <p:nvPr/>
         </p:nvSpPr>
         <p:spPr>
           <a:xfrm>
-            <a:off x="3749039" y="5577840"/>
-            <a:ext cx="5486400" cy="201168"/>
-          </a:xfrm>
-          <a:prstGeom prst="roundRect">
+            <a:off x="6053328" y="5257800"/>
+            <a:ext cx="16459" cy="914400"/>
+          </a:xfrm>
+          <a:prstGeom prst="rect">
             <a:avLst/>
           </a:prstGeom>
           <a:solidFill>
-            <a:srgbClr val="FFFFFF"/>
+            <a:srgbClr val="DDE3EE"/>
           </a:solidFill>
           <a:ln>
-            <a:solidFill>
-              <a:srgbClr val="DDE3EE"/>
-            </a:solidFill>
+            <a:noFill/>
           </a:ln>
           <a:effectLst/>
         </p:spPr>
@@ -4802,45 +4801,40 @@
       </p:sp>
       <p:sp>
         <p:nvSpPr>
-          <p:cNvPr id="34" name="Rounded Rectangle 33"/>
-          <p:cNvSpPr/>
-          <p:nvPr/>
-        </p:nvSpPr>
-        <p:spPr>
-          <a:xfrm>
-            <a:off x="3749039" y="5577840"/>
-            <a:ext cx="91440" cy="201168"/>
-          </a:xfrm>
-          <a:prstGeom prst="roundRect">
-            <a:avLst/>
-          </a:prstGeom>
-          <a:solidFill>
-            <a:srgbClr val="5B6472"/>
-          </a:solidFill>
-          <a:ln>
-            <a:noFill/>
-          </a:ln>
-          <a:effectLst/>
-        </p:spPr>
-        <p:style>
-          <a:lnRef idx="1">
-            <a:schemeClr val="accent1"/>
-          </a:lnRef>
-          <a:fillRef idx="3">
-            <a:schemeClr val="accent1"/>
-          </a:fillRef>
-          <a:effectRef idx="2">
-            <a:schemeClr val="accent1"/>
-          </a:effectRef>
-          <a:fontRef idx="minor">
-            <a:schemeClr val="lt1"/>
-          </a:fontRef>
-        </p:style>
-        <p:txBody>
-          <a:bodyPr rtlCol="0" anchor="ctr"/>
-          <a:lstStyle/>
-          <a:p>
-            <a:pPr algn="ctr"/>
+          <p:cNvPr id="34" name="TextBox 33"/>
+          <p:cNvSpPr txBox="1"/>
+          <p:nvPr/>
+        </p:nvSpPr>
+        <p:spPr>
+          <a:xfrm>
+            <a:off x="6400800" y="5230368"/>
+            <a:ext cx="4937760" cy="365760"/>
+          </a:xfrm>
+          <a:prstGeom prst="rect">
+            <a:avLst/>
+          </a:prstGeom>
+          <a:noFill/>
+        </p:spPr>
+        <p:txBody>
+          <a:bodyPr wrap="square" lIns="0" rIns="0" tIns="0" bIns="0" anchor="t">
+            <a:spAutoFit/>
+          </a:bodyPr>
+          <a:lstStyle/>
+          <a:p>
+            <a:pPr algn="l">
+              <a:lnSpc>
+                <a:spcPct val="130000"/>
+              </a:lnSpc>
+            </a:pPr>
+            <a:r>
+              <a:rPr sz="1350" b="1" i="0">
+                <a:solidFill>
+                  <a:srgbClr val="1D4ED8"/>
+                </a:solidFill>
+                <a:latin typeface="Calibri"/>
+              </a:rPr>
+              <a:t>📈 振舞いによる検知 (今回自作した分析)</a:t>
+            </a:r>
           </a:p>
         </p:txBody>
       </p:sp>
@@ -4852,33 +4846,34 @@
         </p:nvSpPr>
         <p:spPr>
           <a:xfrm>
-            <a:off x="9372600" y="5541264"/>
-            <a:ext cx="2148840" cy="274320"/>
-          </a:xfrm>
-          <a:prstGeom prst="rect">
-            <a:avLst/>
-          </a:prstGeom>
-          <a:noFill/>
-        </p:spPr>
-        <p:txBody>
-          <a:bodyPr wrap="square" lIns="0" rIns="0" tIns="0" bIns="0" anchor="ctr">
+            <a:off x="6400800" y="5614416"/>
+            <a:ext cx="4937760" cy="685800"/>
+          </a:xfrm>
+          <a:prstGeom prst="rect">
+            <a:avLst/>
+          </a:prstGeom>
+          <a:noFill/>
+        </p:spPr>
+        <p:txBody>
+          <a:bodyPr wrap="square" lIns="0" rIns="0" tIns="0" bIns="0" anchor="t">
             <a:spAutoFit/>
           </a:bodyPr>
           <a:lstStyle/>
           <a:p>
             <a:pPr algn="l">
               <a:lnSpc>
-                <a:spcPct val="130000"/>
+                <a:spcPct val="140000"/>
               </a:lnSpc>
             </a:pPr>
             <a:r>
               <a:rPr sz="1150" b="0" i="0">
                 <a:solidFill>
-                  <a:srgbClr val="1F2937"/>
+                  <a:srgbClr val="5B6472"/>
                 </a:solidFill>
                 <a:latin typeface="Calibri"/>
               </a:rPr>
-              <a:t>1 時間に 約1回</a:t>
+              <a:t>「普段との違い」に反応して知らせる。
+ルールがまだ無い未知の手口への「気づき」になる。</a:t>
             </a:r>
           </a:p>
         </p:txBody>
@@ -4886,213 +4881,6 @@
       <p:sp>
         <p:nvSpPr>
           <p:cNvPr id="36" name="TextBox 35"/>
-          <p:cNvSpPr txBox="1"/>
-          <p:nvPr/>
-        </p:nvSpPr>
-        <p:spPr>
-          <a:xfrm>
-            <a:off x="868680" y="5870448"/>
-            <a:ext cx="2788920" cy="274320"/>
-          </a:xfrm>
-          <a:prstGeom prst="rect">
-            <a:avLst/>
-          </a:prstGeom>
-          <a:noFill/>
-        </p:spPr>
-        <p:txBody>
-          <a:bodyPr wrap="square" lIns="0" rIns="0" tIns="0" bIns="0" anchor="ctr">
-            <a:spAutoFit/>
-          </a:bodyPr>
-          <a:lstStyle/>
-          <a:p>
-            <a:pPr algn="l">
-              <a:lnSpc>
-                <a:spcPct val="130000"/>
-              </a:lnSpc>
-            </a:pPr>
-            <a:r>
-              <a:rPr sz="1100" b="0" i="0">
-                <a:solidFill>
-                  <a:srgbClr val="5B6472"/>
-                </a:solidFill>
-                <a:latin typeface="Calibri"/>
-              </a:rPr>
-              <a:t>ある日の 13 時台</a:t>
-            </a:r>
-          </a:p>
-        </p:txBody>
-      </p:sp>
-      <p:sp>
-        <p:nvSpPr>
-          <p:cNvPr id="37" name="Rounded Rectangle 36"/>
-          <p:cNvSpPr/>
-          <p:nvPr/>
-        </p:nvSpPr>
-        <p:spPr>
-          <a:xfrm>
-            <a:off x="3749039" y="5907024"/>
-            <a:ext cx="5486400" cy="201168"/>
-          </a:xfrm>
-          <a:prstGeom prst="roundRect">
-            <a:avLst/>
-          </a:prstGeom>
-          <a:solidFill>
-            <a:srgbClr val="FFFFFF"/>
-          </a:solidFill>
-          <a:ln>
-            <a:solidFill>
-              <a:srgbClr val="DDE3EE"/>
-            </a:solidFill>
-          </a:ln>
-          <a:effectLst/>
-        </p:spPr>
-        <p:style>
-          <a:lnRef idx="1">
-            <a:schemeClr val="accent1"/>
-          </a:lnRef>
-          <a:fillRef idx="3">
-            <a:schemeClr val="accent1"/>
-          </a:fillRef>
-          <a:effectRef idx="2">
-            <a:schemeClr val="accent1"/>
-          </a:effectRef>
-          <a:fontRef idx="minor">
-            <a:schemeClr val="lt1"/>
-          </a:fontRef>
-        </p:style>
-        <p:txBody>
-          <a:bodyPr rtlCol="0" anchor="ctr"/>
-          <a:lstStyle/>
-          <a:p>
-            <a:pPr algn="ctr"/>
-          </a:p>
-        </p:txBody>
-      </p:sp>
-      <p:sp>
-        <p:nvSpPr>
-          <p:cNvPr id="38" name="Rounded Rectangle 37"/>
-          <p:cNvSpPr/>
-          <p:nvPr/>
-        </p:nvSpPr>
-        <p:spPr>
-          <a:xfrm>
-            <a:off x="3749039" y="5907024"/>
-            <a:ext cx="5486400" cy="201168"/>
-          </a:xfrm>
-          <a:prstGeom prst="roundRect">
-            <a:avLst/>
-          </a:prstGeom>
-          <a:solidFill>
-            <a:srgbClr val="2563EB"/>
-          </a:solidFill>
-          <a:ln>
-            <a:noFill/>
-          </a:ln>
-          <a:effectLst/>
-        </p:spPr>
-        <p:style>
-          <a:lnRef idx="1">
-            <a:schemeClr val="accent1"/>
-          </a:lnRef>
-          <a:fillRef idx="3">
-            <a:schemeClr val="accent1"/>
-          </a:fillRef>
-          <a:effectRef idx="2">
-            <a:schemeClr val="accent1"/>
-          </a:effectRef>
-          <a:fontRef idx="minor">
-            <a:schemeClr val="lt1"/>
-          </a:fontRef>
-        </p:style>
-        <p:txBody>
-          <a:bodyPr rtlCol="0" anchor="ctr"/>
-          <a:lstStyle/>
-          <a:p>
-            <a:pPr algn="ctr"/>
-          </a:p>
-        </p:txBody>
-      </p:sp>
-      <p:sp>
-        <p:nvSpPr>
-          <p:cNvPr id="39" name="TextBox 38"/>
-          <p:cNvSpPr txBox="1"/>
-          <p:nvPr/>
-        </p:nvSpPr>
-        <p:spPr>
-          <a:xfrm>
-            <a:off x="9372600" y="5870448"/>
-            <a:ext cx="2148840" cy="274320"/>
-          </a:xfrm>
-          <a:prstGeom prst="rect">
-            <a:avLst/>
-          </a:prstGeom>
-          <a:noFill/>
-        </p:spPr>
-        <p:txBody>
-          <a:bodyPr wrap="square" lIns="0" rIns="0" tIns="0" bIns="0" anchor="ctr">
-            <a:spAutoFit/>
-          </a:bodyPr>
-          <a:lstStyle/>
-          <a:p>
-            <a:pPr algn="l">
-              <a:lnSpc>
-                <a:spcPct val="130000"/>
-              </a:lnSpc>
-            </a:pPr>
-            <a:r>
-              <a:rPr sz="1150" b="1" i="0">
-                <a:solidFill>
-                  <a:srgbClr val="1D4ED8"/>
-                </a:solidFill>
-                <a:latin typeface="Calibri"/>
-              </a:rPr>
-              <a:t>1 時間に 110回 (約117倍)</a:t>
-            </a:r>
-          </a:p>
-        </p:txBody>
-      </p:sp>
-      <p:sp>
-        <p:nvSpPr>
-          <p:cNvPr id="40" name="TextBox 39"/>
-          <p:cNvSpPr txBox="1"/>
-          <p:nvPr/>
-        </p:nvSpPr>
-        <p:spPr>
-          <a:xfrm>
-            <a:off x="868680" y="6163056"/>
-            <a:ext cx="10515600" cy="292608"/>
-          </a:xfrm>
-          <a:prstGeom prst="rect">
-            <a:avLst/>
-          </a:prstGeom>
-          <a:noFill/>
-        </p:spPr>
-        <p:txBody>
-          <a:bodyPr wrap="square" lIns="0" rIns="0" tIns="0" bIns="0" anchor="t">
-            <a:spAutoFit/>
-          </a:bodyPr>
-          <a:lstStyle/>
-          <a:p>
-            <a:pPr algn="ctr">
-              <a:lnSpc>
-                <a:spcPct val="130000"/>
-              </a:lnSpc>
-            </a:pPr>
-            <a:r>
-              <a:rPr sz="1050" b="0" i="0">
-                <a:solidFill>
-                  <a:srgbClr val="5B6472"/>
-                </a:solidFill>
-                <a:latin typeface="Calibri"/>
-              </a:rPr>
-              <a:t>中身を確認すると無害な開発作業と判定できた。役目は「普段と違う」への気づき — 中身の確認まで同じ画面で完結します。</a:t>
-            </a:r>
-          </a:p>
-        </p:txBody>
-      </p:sp>
-      <p:sp>
-        <p:nvSpPr>
-          <p:cNvPr id="41" name="TextBox 40"/>
           <p:cNvSpPr txBox="1"/>
           <p:nvPr/>
         </p:nvSpPr>

</xml_diff>

<commit_message>
docs(slides): add speaker notes to all 15 slides
Populate the PowerPoint notes pane with a per-slide talk script (~11-12
min total) via a SPEAKER_NOTES map + attach_notes(). Covers the lookup
internal flow (slide 8) and detection mechanics (slide 10) reviewers
asked about, plus a demo running order on slide 13.

Co-Authored-By: Claude Fable 5 <noreply@anthropic.com>
</commit_message>
<xml_diff>
--- a/docs/presentation/pptx/hayabusa-plus.pptx
+++ b/docs/presentation/pptx/hayabusa-plus.pptx
@@ -119,6 +119,1541 @@
     </a:lvl9pPr>
   </p:defaultTextStyle>
 </p:presentation>
+</file>
+
+<file path=ppt/notesMasters/notesMaster1.xml><?xml version="1.0" encoding="utf-8"?>
+<p:notesMaster xmlns:a="http://schemas.openxmlformats.org/drawingml/2006/main" xmlns:p="http://schemas.openxmlformats.org/presentationml/2006/main" xmlns:r="http://schemas.openxmlformats.org/officeDocument/2006/relationships">
+  <p:cSld>
+    <p:bg>
+      <p:bgRef idx="1001">
+        <a:schemeClr val="bg1"/>
+      </p:bgRef>
+    </p:bg>
+    <p:spTree>
+      <p:nvGrpSpPr>
+        <p:cNvPr id="1" name=""/>
+        <p:cNvGrpSpPr/>
+        <p:nvPr/>
+      </p:nvGrpSpPr>
+      <p:grpSpPr>
+        <a:xfrm>
+          <a:off x="0" y="0"/>
+          <a:ext cx="0" cy="0"/>
+          <a:chOff x="0" y="0"/>
+          <a:chExt cx="0" cy="0"/>
+        </a:xfrm>
+      </p:grpSpPr>
+      <p:sp>
+        <p:nvSpPr>
+          <p:cNvPr id="2" name="Header Placeholder 1"/>
+          <p:cNvSpPr>
+            <a:spLocks noGrp="1"/>
+          </p:cNvSpPr>
+          <p:nvPr>
+            <p:ph type="hdr" sz="quarter"/>
+          </p:nvPr>
+        </p:nvSpPr>
+        <p:spPr>
+          <a:xfrm>
+            <a:off x="0" y="0"/>
+            <a:ext cx="2971800" cy="457200"/>
+          </a:xfrm>
+          <a:prstGeom prst="rect">
+            <a:avLst/>
+          </a:prstGeom>
+        </p:spPr>
+        <p:txBody>
+          <a:bodyPr vert="horz" lIns="91440" tIns="45720" rIns="91440" bIns="45720" rtlCol="0"/>
+          <a:lstStyle>
+            <a:lvl1pPr algn="l">
+              <a:defRPr sz="1200"/>
+            </a:lvl1pPr>
+          </a:lstStyle>
+          <a:p>
+            <a:endParaRPr lang="en-US"/>
+          </a:p>
+        </p:txBody>
+      </p:sp>
+      <p:sp>
+        <p:nvSpPr>
+          <p:cNvPr id="3" name="Date Placeholder 2"/>
+          <p:cNvSpPr>
+            <a:spLocks noGrp="1"/>
+          </p:cNvSpPr>
+          <p:nvPr>
+            <p:ph type="dt" idx="1"/>
+          </p:nvPr>
+        </p:nvSpPr>
+        <p:spPr>
+          <a:xfrm>
+            <a:off x="3884613" y="0"/>
+            <a:ext cx="2971800" cy="457200"/>
+          </a:xfrm>
+          <a:prstGeom prst="rect">
+            <a:avLst/>
+          </a:prstGeom>
+        </p:spPr>
+        <p:txBody>
+          <a:bodyPr vert="horz" lIns="91440" tIns="45720" rIns="91440" bIns="45720" rtlCol="0"/>
+          <a:lstStyle>
+            <a:lvl1pPr algn="r">
+              <a:defRPr sz="1200"/>
+            </a:lvl1pPr>
+          </a:lstStyle>
+          <a:p>
+            <a:fld id="{0F89C1C7-3DCD-1040-A9CF-14679D8B5DDD}" type="datetimeFigureOut">
+              <a:rPr lang="en-US" smtClean="0"/>
+              <a:t>10/17/16</a:t>
+            </a:fld>
+            <a:endParaRPr lang="en-US"/>
+          </a:p>
+        </p:txBody>
+      </p:sp>
+      <p:sp>
+        <p:nvSpPr>
+          <p:cNvPr id="4" name="Slide Image Placeholder 3"/>
+          <p:cNvSpPr>
+            <a:spLocks noGrp="1" noRot="1" noChangeAspect="1"/>
+          </p:cNvSpPr>
+          <p:nvPr>
+            <p:ph type="sldImg" idx="2"/>
+          </p:nvPr>
+        </p:nvSpPr>
+        <p:spPr>
+          <a:xfrm>
+            <a:off x="1143000" y="685800"/>
+            <a:ext cx="4572000" cy="3429000"/>
+          </a:xfrm>
+          <a:prstGeom prst="rect">
+            <a:avLst/>
+          </a:prstGeom>
+          <a:noFill/>
+          <a:ln w="12700">
+            <a:solidFill>
+              <a:prstClr val="black"/>
+            </a:solidFill>
+          </a:ln>
+        </p:spPr>
+        <p:txBody>
+          <a:bodyPr vert="horz" lIns="91440" tIns="45720" rIns="91440" bIns="45720" rtlCol="0" anchor="ctr"/>
+          <a:lstStyle/>
+          <a:p>
+            <a:endParaRPr lang="en-US"/>
+          </a:p>
+        </p:txBody>
+      </p:sp>
+      <p:sp>
+        <p:nvSpPr>
+          <p:cNvPr id="5" name="Notes Placeholder 4"/>
+          <p:cNvSpPr>
+            <a:spLocks noGrp="1"/>
+          </p:cNvSpPr>
+          <p:nvPr>
+            <p:ph type="body" sz="quarter" idx="3"/>
+          </p:nvPr>
+        </p:nvSpPr>
+        <p:spPr>
+          <a:xfrm>
+            <a:off x="685800" y="4343400"/>
+            <a:ext cx="5486400" cy="4114800"/>
+          </a:xfrm>
+          <a:prstGeom prst="rect">
+            <a:avLst/>
+          </a:prstGeom>
+        </p:spPr>
+        <p:txBody>
+          <a:bodyPr vert="horz" lIns="91440" tIns="45720" rIns="91440" bIns="45720" rtlCol="0"/>
+          <a:lstStyle/>
+          <a:p>
+            <a:pPr lvl="0"/>
+            <a:r>
+              <a:rPr lang="en-US" smtClean="0"/>
+              <a:t>Click to edit Master text styles</a:t>
+            </a:r>
+          </a:p>
+          <a:p>
+            <a:pPr lvl="1"/>
+            <a:r>
+              <a:rPr lang="en-US" smtClean="0"/>
+              <a:t>Second level</a:t>
+            </a:r>
+          </a:p>
+          <a:p>
+            <a:pPr lvl="2"/>
+            <a:r>
+              <a:rPr lang="en-US" smtClean="0"/>
+              <a:t>Third level</a:t>
+            </a:r>
+          </a:p>
+          <a:p>
+            <a:pPr lvl="3"/>
+            <a:r>
+              <a:rPr lang="en-US" smtClean="0"/>
+              <a:t>Fourth level</a:t>
+            </a:r>
+          </a:p>
+          <a:p>
+            <a:pPr lvl="4"/>
+            <a:r>
+              <a:rPr lang="en-US" smtClean="0"/>
+              <a:t>Fifth level</a:t>
+            </a:r>
+            <a:endParaRPr lang="en-US"/>
+          </a:p>
+        </p:txBody>
+      </p:sp>
+      <p:sp>
+        <p:nvSpPr>
+          <p:cNvPr id="6" name="Footer Placeholder 5"/>
+          <p:cNvSpPr>
+            <a:spLocks noGrp="1"/>
+          </p:cNvSpPr>
+          <p:nvPr>
+            <p:ph type="ftr" sz="quarter" idx="4"/>
+          </p:nvPr>
+        </p:nvSpPr>
+        <p:spPr>
+          <a:xfrm>
+            <a:off x="0" y="8685213"/>
+            <a:ext cx="2971800" cy="457200"/>
+          </a:xfrm>
+          <a:prstGeom prst="rect">
+            <a:avLst/>
+          </a:prstGeom>
+        </p:spPr>
+        <p:txBody>
+          <a:bodyPr vert="horz" lIns="91440" tIns="45720" rIns="91440" bIns="45720" rtlCol="0" anchor="b"/>
+          <a:lstStyle>
+            <a:lvl1pPr algn="l">
+              <a:defRPr sz="1200"/>
+            </a:lvl1pPr>
+          </a:lstStyle>
+          <a:p>
+            <a:endParaRPr lang="en-US"/>
+          </a:p>
+        </p:txBody>
+      </p:sp>
+      <p:sp>
+        <p:nvSpPr>
+          <p:cNvPr id="7" name="Slide Number Placeholder 6"/>
+          <p:cNvSpPr>
+            <a:spLocks noGrp="1"/>
+          </p:cNvSpPr>
+          <p:nvPr>
+            <p:ph type="sldNum" sz="quarter" idx="5"/>
+          </p:nvPr>
+        </p:nvSpPr>
+        <p:spPr>
+          <a:xfrm>
+            <a:off x="3884613" y="8685213"/>
+            <a:ext cx="2971800" cy="457200"/>
+          </a:xfrm>
+          <a:prstGeom prst="rect">
+            <a:avLst/>
+          </a:prstGeom>
+        </p:spPr>
+        <p:txBody>
+          <a:bodyPr vert="horz" lIns="91440" tIns="45720" rIns="91440" bIns="45720" rtlCol="0" anchor="b"/>
+          <a:lstStyle>
+            <a:lvl1pPr algn="r">
+              <a:defRPr sz="1200"/>
+            </a:lvl1pPr>
+          </a:lstStyle>
+          <a:p>
+            <a:fld id="{BB5E49A5-4136-284D-997B-48E1D791AD67}" type="slidenum">
+              <a:rPr lang="en-US" smtClean="0"/>
+              <a:t>‹#›</a:t>
+            </a:fld>
+            <a:endParaRPr lang="en-US"/>
+          </a:p>
+        </p:txBody>
+      </p:sp>
+    </p:spTree>
+    <p:extLst>
+      <p:ext uri="{BB962C8B-B14F-4D97-AF65-F5344CB8AC3E}">
+        <p14:creationId xmlns:p14="http://schemas.microsoft.com/office/powerpoint/2010/main" val="2623252185"/>
+      </p:ext>
+    </p:extLst>
+  </p:cSld>
+  <p:clrMap bg1="lt1" tx1="dk1" bg2="lt2" tx2="dk2" accent1="accent1" accent2="accent2" accent3="accent3" accent4="accent4" accent5="accent5" accent6="accent6" hlink="hlink" folHlink="folHlink"/>
+  <p:notesStyle>
+    <a:lvl1pPr marL="0" algn="l" defTabSz="457200" rtl="0" eaLnBrk="1" latinLnBrk="0" hangingPunct="1">
+      <a:defRPr sz="1200" kern="1200">
+        <a:solidFill>
+          <a:schemeClr val="tx1"/>
+        </a:solidFill>
+        <a:latin typeface="+mn-lt"/>
+        <a:ea typeface="+mn-ea"/>
+        <a:cs typeface="+mn-cs"/>
+      </a:defRPr>
+    </a:lvl1pPr>
+    <a:lvl2pPr marL="457200" algn="l" defTabSz="457200" rtl="0" eaLnBrk="1" latinLnBrk="0" hangingPunct="1">
+      <a:defRPr sz="1200" kern="1200">
+        <a:solidFill>
+          <a:schemeClr val="tx1"/>
+        </a:solidFill>
+        <a:latin typeface="+mn-lt"/>
+        <a:ea typeface="+mn-ea"/>
+        <a:cs typeface="+mn-cs"/>
+      </a:defRPr>
+    </a:lvl2pPr>
+    <a:lvl3pPr marL="914400" algn="l" defTabSz="457200" rtl="0" eaLnBrk="1" latinLnBrk="0" hangingPunct="1">
+      <a:defRPr sz="1200" kern="1200">
+        <a:solidFill>
+          <a:schemeClr val="tx1"/>
+        </a:solidFill>
+        <a:latin typeface="+mn-lt"/>
+        <a:ea typeface="+mn-ea"/>
+        <a:cs typeface="+mn-cs"/>
+      </a:defRPr>
+    </a:lvl3pPr>
+    <a:lvl4pPr marL="1371600" algn="l" defTabSz="457200" rtl="0" eaLnBrk="1" latinLnBrk="0" hangingPunct="1">
+      <a:defRPr sz="1200" kern="1200">
+        <a:solidFill>
+          <a:schemeClr val="tx1"/>
+        </a:solidFill>
+        <a:latin typeface="+mn-lt"/>
+        <a:ea typeface="+mn-ea"/>
+        <a:cs typeface="+mn-cs"/>
+      </a:defRPr>
+    </a:lvl4pPr>
+    <a:lvl5pPr marL="1828800" algn="l" defTabSz="457200" rtl="0" eaLnBrk="1" latinLnBrk="0" hangingPunct="1">
+      <a:defRPr sz="1200" kern="1200">
+        <a:solidFill>
+          <a:schemeClr val="tx1"/>
+        </a:solidFill>
+        <a:latin typeface="+mn-lt"/>
+        <a:ea typeface="+mn-ea"/>
+        <a:cs typeface="+mn-cs"/>
+      </a:defRPr>
+    </a:lvl5pPr>
+    <a:lvl6pPr marL="2286000" algn="l" defTabSz="457200" rtl="0" eaLnBrk="1" latinLnBrk="0" hangingPunct="1">
+      <a:defRPr sz="1200" kern="1200">
+        <a:solidFill>
+          <a:schemeClr val="tx1"/>
+        </a:solidFill>
+        <a:latin typeface="+mn-lt"/>
+        <a:ea typeface="+mn-ea"/>
+        <a:cs typeface="+mn-cs"/>
+      </a:defRPr>
+    </a:lvl6pPr>
+    <a:lvl7pPr marL="2743200" algn="l" defTabSz="457200" rtl="0" eaLnBrk="1" latinLnBrk="0" hangingPunct="1">
+      <a:defRPr sz="1200" kern="1200">
+        <a:solidFill>
+          <a:schemeClr val="tx1"/>
+        </a:solidFill>
+        <a:latin typeface="+mn-lt"/>
+        <a:ea typeface="+mn-ea"/>
+        <a:cs typeface="+mn-cs"/>
+      </a:defRPr>
+    </a:lvl7pPr>
+    <a:lvl8pPr marL="3200400" algn="l" defTabSz="457200" rtl="0" eaLnBrk="1" latinLnBrk="0" hangingPunct="1">
+      <a:defRPr sz="1200" kern="1200">
+        <a:solidFill>
+          <a:schemeClr val="tx1"/>
+        </a:solidFill>
+        <a:latin typeface="+mn-lt"/>
+        <a:ea typeface="+mn-ea"/>
+        <a:cs typeface="+mn-cs"/>
+      </a:defRPr>
+    </a:lvl8pPr>
+    <a:lvl9pPr marL="3657600" algn="l" defTabSz="457200" rtl="0" eaLnBrk="1" latinLnBrk="0" hangingPunct="1">
+      <a:defRPr sz="1200" kern="1200">
+        <a:solidFill>
+          <a:schemeClr val="tx1"/>
+        </a:solidFill>
+        <a:latin typeface="+mn-lt"/>
+        <a:ea typeface="+mn-ea"/>
+        <a:cs typeface="+mn-cs"/>
+      </a:defRPr>
+    </a:lvl9pPr>
+  </p:notesStyle>
+</p:notesMaster>
+</file>
+
+<file path=ppt/notesSlides/notesSlide1.xml><?xml version="1.0" encoding="utf-8"?>
+<p:notes xmlns:a="http://schemas.openxmlformats.org/drawingml/2006/main" xmlns:p="http://schemas.openxmlformats.org/presentationml/2006/main" xmlns:r="http://schemas.openxmlformats.org/officeDocument/2006/relationships">
+  <p:cSld>
+    <p:spTree>
+      <p:nvGrpSpPr>
+        <p:cNvPr id="1" name=""/>
+        <p:cNvGrpSpPr/>
+        <p:nvPr/>
+      </p:nvGrpSpPr>
+      <p:grpSpPr>
+        <a:xfrm>
+          <a:off x="0" y="0"/>
+          <a:ext cx="0" cy="0"/>
+          <a:chOff x="0" y="0"/>
+          <a:chExt cx="0" cy="0"/>
+        </a:xfrm>
+      </p:grpSpPr>
+      <p:sp>
+        <p:nvSpPr>
+          <p:cNvPr id="2" name="Slide Image Placeholder 1"/>
+          <p:cNvSpPr>
+            <a:spLocks noGrp="1"/>
+          </p:cNvSpPr>
+          <p:nvPr>
+            <p:ph type="sldImg" idx="2"/>
+          </p:nvPr>
+        </p:nvSpPr>
+        <p:spPr/>
+      </p:sp>
+      <p:sp>
+        <p:nvSpPr>
+          <p:cNvPr id="3" name="Notes Placeholder 2"/>
+          <p:cNvSpPr>
+            <a:spLocks noGrp="1"/>
+          </p:cNvSpPr>
+          <p:nvPr>
+            <p:ph type="body" idx="3" sz="quarter"/>
+          </p:nvPr>
+        </p:nvSpPr>
+        <p:spPr/>
+        <p:txBody>
+          <a:bodyPr/>
+          <a:lstStyle/>
+          <a:p>
+            <a:r>
+              <a:t>本日は「OSS 解析エンジン Hayabusa の拡張による、誰でも使えるサイバー攻撃調査ツールの開発」というテーマで発表します。</a:t>
+            </a:r>
+          </a:p>
+          <a:p>
+            <a:r>
+              <a:t>一言でいうと、プロの道具を“誰でも使える形”に作り変えた研究です。</a:t>
+            </a:r>
+          </a:p>
+          <a:p>
+            <a:r>
+              <a:t>やったことは大きく 3 つ。①エンジン本体 (Rust) への新しい検知機能の追加、②攻撃を見抜く検知ルールの自作、③結果を読み解ける GUI の開発です。</a:t>
+            </a:r>
+          </a:p>
+          <a:p>
+            <a:r>
+              <a:t>成果物はすべて GitHub で公開しています。</a:t>
+            </a:r>
+          </a:p>
+        </p:txBody>
+      </p:sp>
+      <p:sp>
+        <p:nvSpPr>
+          <p:cNvPr id="4" name="Slide Number Placeholder 3"/>
+          <p:cNvSpPr>
+            <a:spLocks noGrp="1"/>
+          </p:cNvSpPr>
+          <p:nvPr>
+            <p:ph type="sldNum" idx="5" sz="quarter"/>
+          </p:nvPr>
+        </p:nvSpPr>
+        <p:spPr/>
+      </p:sp>
+    </p:spTree>
+  </p:cSld>
+  <p:clrMapOvr>
+    <a:masterClrMapping/>
+  </p:clrMapOvr>
+</p:notes>
+</file>
+
+<file path=ppt/notesSlides/notesSlide10.xml><?xml version="1.0" encoding="utf-8"?>
+<p:notes xmlns:a="http://schemas.openxmlformats.org/drawingml/2006/main" xmlns:p="http://schemas.openxmlformats.org/presentationml/2006/main" xmlns:r="http://schemas.openxmlformats.org/officeDocument/2006/relationships">
+  <p:cSld>
+    <p:spTree>
+      <p:nvGrpSpPr>
+        <p:cNvPr id="1" name=""/>
+        <p:cNvGrpSpPr/>
+        <p:nvPr/>
+      </p:nvGrpSpPr>
+      <p:grpSpPr>
+        <a:xfrm>
+          <a:off x="0" y="0"/>
+          <a:ext cx="0" cy="0"/>
+          <a:chOff x="0" y="0"/>
+          <a:chExt cx="0" cy="0"/>
+        </a:xfrm>
+      </p:grpSpPr>
+      <p:sp>
+        <p:nvSpPr>
+          <p:cNvPr id="2" name="Slide Image Placeholder 1"/>
+          <p:cNvSpPr>
+            <a:spLocks noGrp="1"/>
+          </p:cNvSpPr>
+          <p:nvPr>
+            <p:ph type="sldImg" idx="2"/>
+          </p:nvPr>
+        </p:nvSpPr>
+        <p:spPr/>
+      </p:sp>
+      <p:sp>
+        <p:nvSpPr>
+          <p:cNvPr id="3" name="Notes Placeholder 2"/>
+          <p:cNvSpPr>
+            <a:spLocks noGrp="1"/>
+          </p:cNvSpPr>
+          <p:nvPr>
+            <p:ph type="body" idx="3" sz="quarter"/>
+          </p:nvPr>
+        </p:nvSpPr>
+        <p:spPr/>
+        <p:txBody>
+          <a:bodyPr/>
+          <a:lstStyle/>
+          <a:p>
+            <a:r>
+              <a:t>では、これらが実際にログの“どこ”を見ているか。</a:t>
+            </a:r>
+          </a:p>
+          <a:p>
+            <a:r>
+              <a:t>例えばログの消去なら、プロセス起動ログで wevtutil.exe が cl (クリア) 付きで実行されたかを見ます。復元データ削除なら vssadmin の delete shadows ── これはランサムウェアの前兆です。監視の無効化は監査ポリシー変更のイベント 4719、パスワード抜き取りは rundll32 が comsvcs と MiniDump を使ったか。</a:t>
+            </a:r>
+          </a:p>
+          <a:p>
+            <a:r>
+              <a:t>共通しているのは、マルウェア本体は姿を変えられても、これらの“目的に直結した行為”は変えにくい、という点。だからそこを見るんです。</a:t>
+            </a:r>
+          </a:p>
+        </p:txBody>
+      </p:sp>
+      <p:sp>
+        <p:nvSpPr>
+          <p:cNvPr id="4" name="Slide Number Placeholder 3"/>
+          <p:cNvSpPr>
+            <a:spLocks noGrp="1"/>
+          </p:cNvSpPr>
+          <p:nvPr>
+            <p:ph type="sldNum" idx="5" sz="quarter"/>
+          </p:nvPr>
+        </p:nvSpPr>
+        <p:spPr/>
+      </p:sp>
+    </p:spTree>
+  </p:cSld>
+  <p:clrMapOvr>
+    <a:masterClrMapping/>
+  </p:clrMapOvr>
+</p:notes>
+</file>
+
+<file path=ppt/notesSlides/notesSlide11.xml><?xml version="1.0" encoding="utf-8"?>
+<p:notes xmlns:a="http://schemas.openxmlformats.org/drawingml/2006/main" xmlns:p="http://schemas.openxmlformats.org/presentationml/2006/main" xmlns:r="http://schemas.openxmlformats.org/officeDocument/2006/relationships">
+  <p:cSld>
+    <p:spTree>
+      <p:nvGrpSpPr>
+        <p:cNvPr id="1" name=""/>
+        <p:cNvGrpSpPr/>
+        <p:nvPr/>
+      </p:nvGrpSpPr>
+      <p:grpSpPr>
+        <a:xfrm>
+          <a:off x="0" y="0"/>
+          <a:ext cx="0" cy="0"/>
+          <a:chOff x="0" y="0"/>
+          <a:chExt cx="0" cy="0"/>
+        </a:xfrm>
+      </p:grpSpPr>
+      <p:sp>
+        <p:nvSpPr>
+          <p:cNvPr id="2" name="Slide Image Placeholder 1"/>
+          <p:cNvSpPr>
+            <a:spLocks noGrp="1"/>
+          </p:cNvSpPr>
+          <p:nvPr>
+            <p:ph type="sldImg" idx="2"/>
+          </p:nvPr>
+        </p:nvSpPr>
+        <p:spPr/>
+      </p:sp>
+      <p:sp>
+        <p:nvSpPr>
+          <p:cNvPr id="3" name="Notes Placeholder 2"/>
+          <p:cNvSpPr>
+            <a:spLocks noGrp="1"/>
+          </p:cNvSpPr>
+          <p:nvPr>
+            <p:ph type="body" idx="3" sz="quarter"/>
+          </p:nvPr>
+        </p:nvSpPr>
+        <p:spPr/>
+        <p:txBody>
+          <a:bodyPr/>
+          <a:lstStyle/>
+          <a:p>
+            <a:r>
+              <a:t>3 つ目、結果を読めるようにする GUI をゼロから開発しました。</a:t>
+            </a:r>
+          </a:p>
+          <a:p>
+            <a:r>
+              <a:t>検知をクリックすると「何が起きて、次にどうするか」を日本語で表示。どの PC から調べるべきかを自動採点して並べ替え、全体像はグラフで俯瞰できます。</a:t>
+            </a:r>
+          </a:p>
+          <a:p>
+            <a:r>
+              <a:t>右が実際の画面です。すべてブラウザで動き、データは外部に送りません。</a:t>
+            </a:r>
+          </a:p>
+        </p:txBody>
+      </p:sp>
+      <p:sp>
+        <p:nvSpPr>
+          <p:cNvPr id="4" name="Slide Number Placeholder 3"/>
+          <p:cNvSpPr>
+            <a:spLocks noGrp="1"/>
+          </p:cNvSpPr>
+          <p:nvPr>
+            <p:ph type="sldNum" idx="5" sz="quarter"/>
+          </p:nvPr>
+        </p:nvSpPr>
+        <p:spPr/>
+      </p:sp>
+    </p:spTree>
+  </p:cSld>
+  <p:clrMapOvr>
+    <a:masterClrMapping/>
+  </p:clrMapOvr>
+</p:notes>
+</file>
+
+<file path=ppt/notesSlides/notesSlide12.xml><?xml version="1.0" encoding="utf-8"?>
+<p:notes xmlns:a="http://schemas.openxmlformats.org/drawingml/2006/main" xmlns:p="http://schemas.openxmlformats.org/presentationml/2006/main" xmlns:r="http://schemas.openxmlformats.org/officeDocument/2006/relationships">
+  <p:cSld>
+    <p:spTree>
+      <p:nvGrpSpPr>
+        <p:cNvPr id="1" name=""/>
+        <p:cNvGrpSpPr/>
+        <p:nvPr/>
+      </p:nvGrpSpPr>
+      <p:grpSpPr>
+        <a:xfrm>
+          <a:off x="0" y="0"/>
+          <a:ext cx="0" cy="0"/>
+          <a:chOff x="0" y="0"/>
+          <a:chExt cx="0" cy="0"/>
+        </a:xfrm>
+      </p:grpSpPr>
+      <p:sp>
+        <p:nvSpPr>
+          <p:cNvPr id="2" name="Slide Image Placeholder 1"/>
+          <p:cNvSpPr>
+            <a:spLocks noGrp="1"/>
+          </p:cNvSpPr>
+          <p:nvPr>
+            <p:ph type="sldImg" idx="2"/>
+          </p:nvPr>
+        </p:nvSpPr>
+        <p:spPr/>
+      </p:sp>
+      <p:sp>
+        <p:nvSpPr>
+          <p:cNvPr id="3" name="Notes Placeholder 2"/>
+          <p:cNvSpPr>
+            <a:spLocks noGrp="1"/>
+          </p:cNvSpPr>
+          <p:nvPr>
+            <p:ph type="body" idx="3" sz="quarter"/>
+          </p:nvPr>
+        </p:nvSpPr>
+        <p:spPr/>
+        <p:txBody>
+          <a:bodyPr/>
+          <a:lstStyle/>
+          <a:p>
+            <a:r>
+              <a:t>さらに、ルールでは書けない「いつもと違う」も検出できるよう、統計分析を自作しました。</a:t>
+            </a:r>
+          </a:p>
+          <a:p>
+            <a:r>
+              <a:t>急増、複数 PC への拡散、急に静かになる、時間外の活動、の 4 種類です。</a:t>
+            </a:r>
+          </a:p>
+          <a:p>
+            <a:r>
+              <a:t>ルールは既知の手口に強い一方、振る舞い分析は“未知の手口への気づき”になる。両者を組み合わせるのが狙いです。</a:t>
+            </a:r>
+          </a:p>
+        </p:txBody>
+      </p:sp>
+      <p:sp>
+        <p:nvSpPr>
+          <p:cNvPr id="4" name="Slide Number Placeholder 3"/>
+          <p:cNvSpPr>
+            <a:spLocks noGrp="1"/>
+          </p:cNvSpPr>
+          <p:nvPr>
+            <p:ph type="sldNum" idx="5" sz="quarter"/>
+          </p:nvPr>
+        </p:nvSpPr>
+        <p:spPr/>
+      </p:sp>
+    </p:spTree>
+  </p:cSld>
+  <p:clrMapOvr>
+    <a:masterClrMapping/>
+  </p:clrMapOvr>
+</p:notes>
+</file>
+
+<file path=ppt/notesSlides/notesSlide13.xml><?xml version="1.0" encoding="utf-8"?>
+<p:notes xmlns:a="http://schemas.openxmlformats.org/drawingml/2006/main" xmlns:p="http://schemas.openxmlformats.org/presentationml/2006/main" xmlns:r="http://schemas.openxmlformats.org/officeDocument/2006/relationships">
+  <p:cSld>
+    <p:spTree>
+      <p:nvGrpSpPr>
+        <p:cNvPr id="1" name=""/>
+        <p:cNvGrpSpPr/>
+        <p:nvPr/>
+      </p:nvGrpSpPr>
+      <p:grpSpPr>
+        <a:xfrm>
+          <a:off x="0" y="0"/>
+          <a:ext cx="0" cy="0"/>
+          <a:chOff x="0" y="0"/>
+          <a:chExt cx="0" cy="0"/>
+        </a:xfrm>
+      </p:grpSpPr>
+      <p:sp>
+        <p:nvSpPr>
+          <p:cNvPr id="2" name="Slide Image Placeholder 1"/>
+          <p:cNvSpPr>
+            <a:spLocks noGrp="1"/>
+          </p:cNvSpPr>
+          <p:nvPr>
+            <p:ph type="sldImg" idx="2"/>
+          </p:nvPr>
+        </p:nvSpPr>
+        <p:spPr/>
+      </p:sp>
+      <p:sp>
+        <p:nvSpPr>
+          <p:cNvPr id="3" name="Notes Placeholder 2"/>
+          <p:cNvSpPr>
+            <a:spLocks noGrp="1"/>
+          </p:cNvSpPr>
+          <p:nvPr>
+            <p:ph type="body" idx="3" sz="quarter"/>
+          </p:nvPr>
+        </p:nvSpPr>
+        <p:spPr/>
+        <p:txBody>
+          <a:bodyPr/>
+          <a:lstStyle/>
+          <a:p>
+            <a:r>
+              <a:t>ここから実際の画面でお見せします。サンプルログを読み込んで、調査の流れを見ていただきます。</a:t>
+            </a:r>
+          </a:p>
+          <a:p>
+            <a:r>
+              <a:t>(デモ: スキャン実行 → ダッシュボードで全体把握 → 検知の日本語解説 → ホスト別の危険度ランキング、の順に見せる)</a:t>
+            </a:r>
+          </a:p>
+        </p:txBody>
+      </p:sp>
+      <p:sp>
+        <p:nvSpPr>
+          <p:cNvPr id="4" name="Slide Number Placeholder 3"/>
+          <p:cNvSpPr>
+            <a:spLocks noGrp="1"/>
+          </p:cNvSpPr>
+          <p:nvPr>
+            <p:ph type="sldNum" idx="5" sz="quarter"/>
+          </p:nvPr>
+        </p:nvSpPr>
+        <p:spPr/>
+      </p:sp>
+    </p:spTree>
+  </p:cSld>
+  <p:clrMapOvr>
+    <a:masterClrMapping/>
+  </p:clrMapOvr>
+</p:notes>
+</file>
+
+<file path=ppt/notesSlides/notesSlide14.xml><?xml version="1.0" encoding="utf-8"?>
+<p:notes xmlns:a="http://schemas.openxmlformats.org/drawingml/2006/main" xmlns:p="http://schemas.openxmlformats.org/presentationml/2006/main" xmlns:r="http://schemas.openxmlformats.org/officeDocument/2006/relationships">
+  <p:cSld>
+    <p:spTree>
+      <p:nvGrpSpPr>
+        <p:cNvPr id="1" name=""/>
+        <p:cNvGrpSpPr/>
+        <p:nvPr/>
+      </p:nvGrpSpPr>
+      <p:grpSpPr>
+        <a:xfrm>
+          <a:off x="0" y="0"/>
+          <a:ext cx="0" cy="0"/>
+          <a:chOff x="0" y="0"/>
+          <a:chExt cx="0" cy="0"/>
+        </a:xfrm>
+      </p:grpSpPr>
+      <p:sp>
+        <p:nvSpPr>
+          <p:cNvPr id="2" name="Slide Image Placeholder 1"/>
+          <p:cNvSpPr>
+            <a:spLocks noGrp="1"/>
+          </p:cNvSpPr>
+          <p:nvPr>
+            <p:ph type="sldImg" idx="2"/>
+          </p:nvPr>
+        </p:nvSpPr>
+        <p:spPr/>
+      </p:sp>
+      <p:sp>
+        <p:nvSpPr>
+          <p:cNvPr id="3" name="Notes Placeholder 2"/>
+          <p:cNvSpPr>
+            <a:spLocks noGrp="1"/>
+          </p:cNvSpPr>
+          <p:nvPr>
+            <p:ph type="body" idx="3" sz="quarter"/>
+          </p:nvPr>
+        </p:nvSpPr>
+        <p:spPr/>
+        <p:txBody>
+          <a:bodyPr/>
+          <a:lstStyle/>
+          <a:p>
+            <a:r>
+              <a:t>まとめます。エンジンに lookup という新しい文法を追加し、検知ルールを 13 本自作、結果を読み解く GUI を約 8,000 行で開発し、悪いものリスト約 8 万件を自動で取り込んで照合できるようにしました。</a:t>
+            </a:r>
+          </a:p>
+          <a:p>
+            <a:r>
+              <a:t>今後は、時間の流れを追った相関分析 (「A の後に B が起きたら怪しい」) や、AI による検知ルールの自動生成に進めたいと考えています。</a:t>
+            </a:r>
+          </a:p>
+        </p:txBody>
+      </p:sp>
+      <p:sp>
+        <p:nvSpPr>
+          <p:cNvPr id="4" name="Slide Number Placeholder 3"/>
+          <p:cNvSpPr>
+            <a:spLocks noGrp="1"/>
+          </p:cNvSpPr>
+          <p:nvPr>
+            <p:ph type="sldNum" idx="5" sz="quarter"/>
+          </p:nvPr>
+        </p:nvSpPr>
+        <p:spPr/>
+      </p:sp>
+    </p:spTree>
+  </p:cSld>
+  <p:clrMapOvr>
+    <a:masterClrMapping/>
+  </p:clrMapOvr>
+</p:notes>
+</file>
+
+<file path=ppt/notesSlides/notesSlide15.xml><?xml version="1.0" encoding="utf-8"?>
+<p:notes xmlns:a="http://schemas.openxmlformats.org/drawingml/2006/main" xmlns:p="http://schemas.openxmlformats.org/presentationml/2006/main" xmlns:r="http://schemas.openxmlformats.org/officeDocument/2006/relationships">
+  <p:cSld>
+    <p:spTree>
+      <p:nvGrpSpPr>
+        <p:cNvPr id="1" name=""/>
+        <p:cNvGrpSpPr/>
+        <p:nvPr/>
+      </p:nvGrpSpPr>
+      <p:grpSpPr>
+        <a:xfrm>
+          <a:off x="0" y="0"/>
+          <a:ext cx="0" cy="0"/>
+          <a:chOff x="0" y="0"/>
+          <a:chExt cx="0" cy="0"/>
+        </a:xfrm>
+      </p:grpSpPr>
+      <p:sp>
+        <p:nvSpPr>
+          <p:cNvPr id="2" name="Slide Image Placeholder 1"/>
+          <p:cNvSpPr>
+            <a:spLocks noGrp="1"/>
+          </p:cNvSpPr>
+          <p:nvPr>
+            <p:ph type="sldImg" idx="2"/>
+          </p:nvPr>
+        </p:nvSpPr>
+        <p:spPr/>
+      </p:sp>
+      <p:sp>
+        <p:nvSpPr>
+          <p:cNvPr id="3" name="Notes Placeholder 2"/>
+          <p:cNvSpPr>
+            <a:spLocks noGrp="1"/>
+          </p:cNvSpPr>
+          <p:nvPr>
+            <p:ph type="body" idx="3" sz="quarter"/>
+          </p:nvPr>
+        </p:nvSpPr>
+        <p:spPr/>
+        <p:txBody>
+          <a:bodyPr/>
+          <a:lstStyle/>
+          <a:p>
+            <a:r>
+              <a:t>以上です。ありがとうございました。</a:t>
+            </a:r>
+          </a:p>
+          <a:p>
+            <a:r>
+              <a:t>成果物はすべて GitHub で公開しているので、お手元の Windows PC のログでぜひ一度試してみてください。ご質問・フィードバックをお願いします。</a:t>
+            </a:r>
+          </a:p>
+        </p:txBody>
+      </p:sp>
+      <p:sp>
+        <p:nvSpPr>
+          <p:cNvPr id="4" name="Slide Number Placeholder 3"/>
+          <p:cNvSpPr>
+            <a:spLocks noGrp="1"/>
+          </p:cNvSpPr>
+          <p:nvPr>
+            <p:ph type="sldNum" idx="5" sz="quarter"/>
+          </p:nvPr>
+        </p:nvSpPr>
+        <p:spPr/>
+      </p:sp>
+    </p:spTree>
+  </p:cSld>
+  <p:clrMapOvr>
+    <a:masterClrMapping/>
+  </p:clrMapOvr>
+</p:notes>
+</file>
+
+<file path=ppt/notesSlides/notesSlide2.xml><?xml version="1.0" encoding="utf-8"?>
+<p:notes xmlns:a="http://schemas.openxmlformats.org/drawingml/2006/main" xmlns:p="http://schemas.openxmlformats.org/presentationml/2006/main" xmlns:r="http://schemas.openxmlformats.org/officeDocument/2006/relationships">
+  <p:cSld>
+    <p:spTree>
+      <p:nvGrpSpPr>
+        <p:cNvPr id="1" name=""/>
+        <p:cNvGrpSpPr/>
+        <p:nvPr/>
+      </p:nvGrpSpPr>
+      <p:grpSpPr>
+        <a:xfrm>
+          <a:off x="0" y="0"/>
+          <a:ext cx="0" cy="0"/>
+          <a:chOff x="0" y="0"/>
+          <a:chExt cx="0" cy="0"/>
+        </a:xfrm>
+      </p:grpSpPr>
+      <p:sp>
+        <p:nvSpPr>
+          <p:cNvPr id="2" name="Slide Image Placeholder 1"/>
+          <p:cNvSpPr>
+            <a:spLocks noGrp="1"/>
+          </p:cNvSpPr>
+          <p:nvPr>
+            <p:ph type="sldImg" idx="2"/>
+          </p:nvPr>
+        </p:nvSpPr>
+        <p:spPr/>
+      </p:sp>
+      <p:sp>
+        <p:nvSpPr>
+          <p:cNvPr id="3" name="Notes Placeholder 2"/>
+          <p:cNvSpPr>
+            <a:spLocks noGrp="1"/>
+          </p:cNvSpPr>
+          <p:nvPr>
+            <p:ph type="body" idx="3" sz="quarter"/>
+          </p:nvPr>
+        </p:nvSpPr>
+        <p:spPr/>
+        <p:txBody>
+          <a:bodyPr/>
+          <a:lstStyle/>
+          <a:p>
+            <a:r>
+              <a:t>まず背景から。もし皆さんの会社がサイバー攻撃を受けたら、どうしますか。</a:t>
+            </a:r>
+          </a:p>
+          <a:p>
+            <a:r>
+              <a:t>知りたいのは「どこから侵入されたか」「誰に何をされたか」「被害はどこまで広がったか」。しかもこれを“素早く”知る必要があります。対応が遅れるほど被害は広がるからです。</a:t>
+            </a:r>
+          </a:p>
+        </p:txBody>
+      </p:sp>
+      <p:sp>
+        <p:nvSpPr>
+          <p:cNvPr id="4" name="Slide Number Placeholder 3"/>
+          <p:cNvSpPr>
+            <a:spLocks noGrp="1"/>
+          </p:cNvSpPr>
+          <p:nvPr>
+            <p:ph type="sldNum" idx="5" sz="quarter"/>
+          </p:nvPr>
+        </p:nvSpPr>
+        <p:spPr/>
+      </p:sp>
+    </p:spTree>
+  </p:cSld>
+  <p:clrMapOvr>
+    <a:masterClrMapping/>
+  </p:clrMapOvr>
+</p:notes>
+</file>
+
+<file path=ppt/notesSlides/notesSlide3.xml><?xml version="1.0" encoding="utf-8"?>
+<p:notes xmlns:a="http://schemas.openxmlformats.org/drawingml/2006/main" xmlns:p="http://schemas.openxmlformats.org/presentationml/2006/main" xmlns:r="http://schemas.openxmlformats.org/officeDocument/2006/relationships">
+  <p:cSld>
+    <p:spTree>
+      <p:nvGrpSpPr>
+        <p:cNvPr id="1" name=""/>
+        <p:cNvGrpSpPr/>
+        <p:nvPr/>
+      </p:nvGrpSpPr>
+      <p:grpSpPr>
+        <a:xfrm>
+          <a:off x="0" y="0"/>
+          <a:ext cx="0" cy="0"/>
+          <a:chOff x="0" y="0"/>
+          <a:chExt cx="0" cy="0"/>
+        </a:xfrm>
+      </p:grpSpPr>
+      <p:sp>
+        <p:nvSpPr>
+          <p:cNvPr id="2" name="Slide Image Placeholder 1"/>
+          <p:cNvSpPr>
+            <a:spLocks noGrp="1"/>
+          </p:cNvSpPr>
+          <p:nvPr>
+            <p:ph type="sldImg" idx="2"/>
+          </p:nvPr>
+        </p:nvSpPr>
+        <p:spPr/>
+      </p:sp>
+      <p:sp>
+        <p:nvSpPr>
+          <p:cNvPr id="3" name="Notes Placeholder 2"/>
+          <p:cNvSpPr>
+            <a:spLocks noGrp="1"/>
+          </p:cNvSpPr>
+          <p:nvPr>
+            <p:ph type="body" idx="3" sz="quarter"/>
+          </p:nvPr>
+        </p:nvSpPr>
+        <p:spPr/>
+        <p:txBody>
+          <a:bodyPr/>
+          <a:lstStyle/>
+          <a:p>
+            <a:r>
+              <a:t>その答えは、実は Windows が残しているログの中にあります。ログオン、プロセス起動、通信 ── 攻撃の痕跡はすべて記録されている。</a:t>
+            </a:r>
+          </a:p>
+          <a:p>
+            <a:r>
+              <a:t>ただ問題は“量”です。たった 1 台の PC でも数万件。これを人間が 1 件ずつ読むのは現実的に不可能で、専門家が時間をかけても見落とします。</a:t>
+            </a:r>
+          </a:p>
+        </p:txBody>
+      </p:sp>
+      <p:sp>
+        <p:nvSpPr>
+          <p:cNvPr id="4" name="Slide Number Placeholder 3"/>
+          <p:cNvSpPr>
+            <a:spLocks noGrp="1"/>
+          </p:cNvSpPr>
+          <p:nvPr>
+            <p:ph type="sldNum" idx="5" sz="quarter"/>
+          </p:nvPr>
+        </p:nvSpPr>
+        <p:spPr/>
+      </p:sp>
+    </p:spTree>
+  </p:cSld>
+  <p:clrMapOvr>
+    <a:masterClrMapping/>
+  </p:clrMapOvr>
+</p:notes>
+</file>
+
+<file path=ppt/notesSlides/notesSlide4.xml><?xml version="1.0" encoding="utf-8"?>
+<p:notes xmlns:a="http://schemas.openxmlformats.org/drawingml/2006/main" xmlns:p="http://schemas.openxmlformats.org/presentationml/2006/main" xmlns:r="http://schemas.openxmlformats.org/officeDocument/2006/relationships">
+  <p:cSld>
+    <p:spTree>
+      <p:nvGrpSpPr>
+        <p:cNvPr id="1" name=""/>
+        <p:cNvGrpSpPr/>
+        <p:nvPr/>
+      </p:nvGrpSpPr>
+      <p:grpSpPr>
+        <a:xfrm>
+          <a:off x="0" y="0"/>
+          <a:ext cx="0" cy="0"/>
+          <a:chOff x="0" y="0"/>
+          <a:chExt cx="0" cy="0"/>
+        </a:xfrm>
+      </p:grpSpPr>
+      <p:sp>
+        <p:nvSpPr>
+          <p:cNvPr id="2" name="Slide Image Placeholder 1"/>
+          <p:cNvSpPr>
+            <a:spLocks noGrp="1"/>
+          </p:cNvSpPr>
+          <p:nvPr>
+            <p:ph type="sldImg" idx="2"/>
+          </p:nvPr>
+        </p:nvSpPr>
+        <p:spPr/>
+      </p:sp>
+      <p:sp>
+        <p:nvSpPr>
+          <p:cNvPr id="3" name="Notes Placeholder 2"/>
+          <p:cNvSpPr>
+            <a:spLocks noGrp="1"/>
+          </p:cNvSpPr>
+          <p:nvPr>
+            <p:ph type="body" idx="3" sz="quarter"/>
+          </p:nvPr>
+        </p:nvSpPr>
+        <p:spPr/>
+        <p:txBody>
+          <a:bodyPr/>
+          <a:lstStyle/>
+          <a:p>
+            <a:r>
+              <a:t>そこで土台にしたのが、日本の Yamato Security が公開している無料ツール Hayabusa です。世界中の研究者が作った約 5,000 本の攻撃パターンと、数万件のログを数十秒で照合できる、実績あるツールです。</a:t>
+            </a:r>
+          </a:p>
+          <a:p>
+            <a:r>
+              <a:t>ただ弱点があって、黒い画面でコマンドを打つ必要があり、結果は CSV 数万行、しかも英語と専門用語。「で、次どうすれば?」は教えてくれない。</a:t>
+            </a:r>
+          </a:p>
+          <a:p>
+            <a:r>
+              <a:t>つまり“強力だが専門家にしか使えない”。ここを出発点にしました。</a:t>
+            </a:r>
+          </a:p>
+        </p:txBody>
+      </p:sp>
+      <p:sp>
+        <p:nvSpPr>
+          <p:cNvPr id="4" name="Slide Number Placeholder 3"/>
+          <p:cNvSpPr>
+            <a:spLocks noGrp="1"/>
+          </p:cNvSpPr>
+          <p:nvPr>
+            <p:ph type="sldNum" idx="5" sz="quarter"/>
+          </p:nvPr>
+        </p:nvSpPr>
+        <p:spPr/>
+      </p:sp>
+    </p:spTree>
+  </p:cSld>
+  <p:clrMapOvr>
+    <a:masterClrMapping/>
+  </p:clrMapOvr>
+</p:notes>
+</file>
+
+<file path=ppt/notesSlides/notesSlide5.xml><?xml version="1.0" encoding="utf-8"?>
+<p:notes xmlns:a="http://schemas.openxmlformats.org/drawingml/2006/main" xmlns:p="http://schemas.openxmlformats.org/presentationml/2006/main" xmlns:r="http://schemas.openxmlformats.org/officeDocument/2006/relationships">
+  <p:cSld>
+    <p:spTree>
+      <p:nvGrpSpPr>
+        <p:cNvPr id="1" name=""/>
+        <p:cNvGrpSpPr/>
+        <p:nvPr/>
+      </p:nvGrpSpPr>
+      <p:grpSpPr>
+        <a:xfrm>
+          <a:off x="0" y="0"/>
+          <a:ext cx="0" cy="0"/>
+          <a:chOff x="0" y="0"/>
+          <a:chExt cx="0" cy="0"/>
+        </a:xfrm>
+      </p:grpSpPr>
+      <p:sp>
+        <p:nvSpPr>
+          <p:cNvPr id="2" name="Slide Image Placeholder 1"/>
+          <p:cNvSpPr>
+            <a:spLocks noGrp="1"/>
+          </p:cNvSpPr>
+          <p:nvPr>
+            <p:ph type="sldImg" idx="2"/>
+          </p:nvPr>
+        </p:nvSpPr>
+        <p:spPr/>
+      </p:sp>
+      <p:sp>
+        <p:nvSpPr>
+          <p:cNvPr id="3" name="Notes Placeholder 2"/>
+          <p:cNvSpPr>
+            <a:spLocks noGrp="1"/>
+          </p:cNvSpPr>
+          <p:nvPr>
+            <p:ph type="body" idx="3" sz="quarter"/>
+          </p:nvPr>
+        </p:nvSpPr>
+        <p:spPr/>
+        <p:txBody>
+          <a:bodyPr/>
+          <a:lstStyle/>
+          <a:p>
+            <a:r>
+              <a:t>目的は明確で、この「専門家の道具」を「誰でも使える調査プラットフォーム」にすることです。</a:t>
+            </a:r>
+          </a:p>
+          <a:p>
+            <a:r>
+              <a:t>方針は 3 つ。①見つける力を強くする (エンジン改造とルール自作)、②結果を読めるようにする (GUI)、③手元だけで完結させる (データを外に出さない・追加ソフト不要)。</a:t>
+            </a:r>
+          </a:p>
+          <a:p>
+            <a:r>
+              <a:t>この 3 つが、この後の発表の章立てになります。</a:t>
+            </a:r>
+          </a:p>
+        </p:txBody>
+      </p:sp>
+      <p:sp>
+        <p:nvSpPr>
+          <p:cNvPr id="4" name="Slide Number Placeholder 3"/>
+          <p:cNvSpPr>
+            <a:spLocks noGrp="1"/>
+          </p:cNvSpPr>
+          <p:nvPr>
+            <p:ph type="sldNum" idx="5" sz="quarter"/>
+          </p:nvPr>
+        </p:nvSpPr>
+        <p:spPr/>
+      </p:sp>
+    </p:spTree>
+  </p:cSld>
+  <p:clrMapOvr>
+    <a:masterClrMapping/>
+  </p:clrMapOvr>
+</p:notes>
+</file>
+
+<file path=ppt/notesSlides/notesSlide6.xml><?xml version="1.0" encoding="utf-8"?>
+<p:notes xmlns:a="http://schemas.openxmlformats.org/drawingml/2006/main" xmlns:p="http://schemas.openxmlformats.org/presentationml/2006/main" xmlns:r="http://schemas.openxmlformats.org/officeDocument/2006/relationships">
+  <p:cSld>
+    <p:spTree>
+      <p:nvGrpSpPr>
+        <p:cNvPr id="1" name=""/>
+        <p:cNvGrpSpPr/>
+        <p:nvPr/>
+      </p:nvGrpSpPr>
+      <p:grpSpPr>
+        <a:xfrm>
+          <a:off x="0" y="0"/>
+          <a:ext cx="0" cy="0"/>
+          <a:chOff x="0" y="0"/>
+          <a:chExt cx="0" cy="0"/>
+        </a:xfrm>
+      </p:grpSpPr>
+      <p:sp>
+        <p:nvSpPr>
+          <p:cNvPr id="2" name="Slide Image Placeholder 1"/>
+          <p:cNvSpPr>
+            <a:spLocks noGrp="1"/>
+          </p:cNvSpPr>
+          <p:nvPr>
+            <p:ph type="sldImg" idx="2"/>
+          </p:nvPr>
+        </p:nvSpPr>
+        <p:spPr/>
+      </p:sp>
+      <p:sp>
+        <p:nvSpPr>
+          <p:cNvPr id="3" name="Notes Placeholder 2"/>
+          <p:cNvSpPr>
+            <a:spLocks noGrp="1"/>
+          </p:cNvSpPr>
+          <p:nvPr>
+            <p:ph type="body" idx="3" sz="quarter"/>
+          </p:nvPr>
+        </p:nvSpPr>
+        <p:spPr/>
+        <p:txBody>
+          <a:bodyPr/>
+          <a:lstStyle/>
+          <a:p>
+            <a:r>
+              <a:t>全体像です。グレーが既存の Hayabusa、青が私が開発した部分です。</a:t>
+            </a:r>
+          </a:p>
+          <a:p>
+            <a:r>
+              <a:t>ログがエンジンで解析され、GUI を通して人が読む、という流れ。エンジンには中身を改造して新機能を追加し、下から「自作の検知ルール 13 本」と「悪いものリスト約 8 万件」を注ぎ込んでいます。GUI はゼロから約 8,000 行で作りました。</a:t>
+            </a:r>
+          </a:p>
+          <a:p>
+            <a:r>
+              <a:t>では順に説明します。</a:t>
+            </a:r>
+          </a:p>
+        </p:txBody>
+      </p:sp>
+      <p:sp>
+        <p:nvSpPr>
+          <p:cNvPr id="4" name="Slide Number Placeholder 3"/>
+          <p:cNvSpPr>
+            <a:spLocks noGrp="1"/>
+          </p:cNvSpPr>
+          <p:nvPr>
+            <p:ph type="sldNum" idx="5" sz="quarter"/>
+          </p:nvPr>
+        </p:nvSpPr>
+        <p:spPr/>
+      </p:sp>
+    </p:spTree>
+  </p:cSld>
+  <p:clrMapOvr>
+    <a:masterClrMapping/>
+  </p:clrMapOvr>
+</p:notes>
+</file>
+
+<file path=ppt/notesSlides/notesSlide7.xml><?xml version="1.0" encoding="utf-8"?>
+<p:notes xmlns:a="http://schemas.openxmlformats.org/drawingml/2006/main" xmlns:p="http://schemas.openxmlformats.org/presentationml/2006/main" xmlns:r="http://schemas.openxmlformats.org/officeDocument/2006/relationships">
+  <p:cSld>
+    <p:spTree>
+      <p:nvGrpSpPr>
+        <p:cNvPr id="1" name=""/>
+        <p:cNvGrpSpPr/>
+        <p:nvPr/>
+      </p:nvGrpSpPr>
+      <p:grpSpPr>
+        <a:xfrm>
+          <a:off x="0" y="0"/>
+          <a:ext cx="0" cy="0"/>
+          <a:chOff x="0" y="0"/>
+          <a:chExt cx="0" cy="0"/>
+        </a:xfrm>
+      </p:grpSpPr>
+      <p:sp>
+        <p:nvSpPr>
+          <p:cNvPr id="2" name="Slide Image Placeholder 1"/>
+          <p:cNvSpPr>
+            <a:spLocks noGrp="1"/>
+          </p:cNvSpPr>
+          <p:nvPr>
+            <p:ph type="sldImg" idx="2"/>
+          </p:nvPr>
+        </p:nvSpPr>
+        <p:spPr/>
+      </p:sp>
+      <p:sp>
+        <p:nvSpPr>
+          <p:cNvPr id="3" name="Notes Placeholder 2"/>
+          <p:cNvSpPr>
+            <a:spLocks noGrp="1"/>
+          </p:cNvSpPr>
+          <p:nvPr>
+            <p:ph type="body" idx="3" sz="quarter"/>
+          </p:nvPr>
+        </p:nvSpPr>
+        <p:spPr/>
+        <p:txBody>
+          <a:bodyPr/>
+          <a:lstStyle/>
+          <a:p>
+            <a:r>
+              <a:t>1 つ目、エンジン本体の改造です。Hayabusa の「ルールの書き方」自体を拡張しました。</a:t>
+            </a:r>
+          </a:p>
+          <a:p>
+            <a:r>
+              <a:t>具体的には、ルールに 1 行「このリストに載っていたら警告して」と書ける lookup という機能を、Rust のソースコードに追加しました。</a:t>
+            </a:r>
+          </a:p>
+          <a:p>
+            <a:r>
+              <a:t>これで世界中で共有されている悪性ハッシュや URL のリスト約 8 万件を、ルールを書き換えずにそのまま検知に使えます。このリストの出どころと処理の流れを、次のページで説明します。</a:t>
+            </a:r>
+          </a:p>
+        </p:txBody>
+      </p:sp>
+      <p:sp>
+        <p:nvSpPr>
+          <p:cNvPr id="4" name="Slide Number Placeholder 3"/>
+          <p:cNvSpPr>
+            <a:spLocks noGrp="1"/>
+          </p:cNvSpPr>
+          <p:nvPr>
+            <p:ph type="sldNum" idx="5" sz="quarter"/>
+          </p:nvPr>
+        </p:nvSpPr>
+        <p:spPr/>
+      </p:sp>
+    </p:spTree>
+  </p:cSld>
+  <p:clrMapOvr>
+    <a:masterClrMapping/>
+  </p:clrMapOvr>
+</p:notes>
+</file>
+
+<file path=ppt/notesSlides/notesSlide8.xml><?xml version="1.0" encoding="utf-8"?>
+<p:notes xmlns:a="http://schemas.openxmlformats.org/drawingml/2006/main" xmlns:p="http://schemas.openxmlformats.org/presentationml/2006/main" xmlns:r="http://schemas.openxmlformats.org/officeDocument/2006/relationships">
+  <p:cSld>
+    <p:spTree>
+      <p:nvGrpSpPr>
+        <p:cNvPr id="1" name=""/>
+        <p:cNvGrpSpPr/>
+        <p:nvPr/>
+      </p:nvGrpSpPr>
+      <p:grpSpPr>
+        <a:xfrm>
+          <a:off x="0" y="0"/>
+          <a:ext cx="0" cy="0"/>
+          <a:chOff x="0" y="0"/>
+          <a:chExt cx="0" cy="0"/>
+        </a:xfrm>
+      </p:grpSpPr>
+      <p:sp>
+        <p:nvSpPr>
+          <p:cNvPr id="2" name="Slide Image Placeholder 1"/>
+          <p:cNvSpPr>
+            <a:spLocks noGrp="1"/>
+          </p:cNvSpPr>
+          <p:nvPr>
+            <p:ph type="sldImg" idx="2"/>
+          </p:nvPr>
+        </p:nvSpPr>
+        <p:spPr/>
+      </p:sp>
+      <p:sp>
+        <p:nvSpPr>
+          <p:cNvPr id="3" name="Notes Placeholder 2"/>
+          <p:cNvSpPr>
+            <a:spLocks noGrp="1"/>
+          </p:cNvSpPr>
+          <p:nvPr>
+            <p:ph type="body" idx="3" sz="quarter"/>
+          </p:nvPr>
+        </p:nvSpPr>
+        <p:spPr/>
+        <p:txBody>
+          <a:bodyPr/>
+          <a:lstStyle/>
+          <a:p>
+            <a:r>
+              <a:t>これが lookup の内部フローです。例として、悪用される脆弱ドライバの検知 (BYOVD) を追います。</a:t>
+            </a:r>
+          </a:p>
+          <a:p>
+            <a:r>
+              <a:t>まず出どころは loldrivers.io。世界中の研究者が集めた“悪用されるドライバ”のハッシュ一覧です。これを取得してテキストに整形し、1,929 件のリストとして保存します。</a:t>
+            </a:r>
+          </a:p>
+          <a:p>
+            <a:r>
+              <a:t>エンジンは起動時に一度だけこれをメモリに読み込み、あとはログ 1 件ごとに、ドライバ読込イベントのハッシュをこの表と照合。一致すれば攻撃の痕跡として critical で通知します。</a:t>
+            </a:r>
+          </a:p>
+          <a:p>
+            <a:r>
+              <a:t>ポイントは、リストが増えても照合速度は一定で、リストを更新するだけで最新の脅威に追従できることです。</a:t>
+            </a:r>
+          </a:p>
+        </p:txBody>
+      </p:sp>
+      <p:sp>
+        <p:nvSpPr>
+          <p:cNvPr id="4" name="Slide Number Placeholder 3"/>
+          <p:cNvSpPr>
+            <a:spLocks noGrp="1"/>
+          </p:cNvSpPr>
+          <p:nvPr>
+            <p:ph type="sldNum" idx="5" sz="quarter"/>
+          </p:nvPr>
+        </p:nvSpPr>
+        <p:spPr/>
+      </p:sp>
+    </p:spTree>
+  </p:cSld>
+  <p:clrMapOvr>
+    <a:masterClrMapping/>
+  </p:clrMapOvr>
+</p:notes>
+</file>
+
+<file path=ppt/notesSlides/notesSlide9.xml><?xml version="1.0" encoding="utf-8"?>
+<p:notes xmlns:a="http://schemas.openxmlformats.org/drawingml/2006/main" xmlns:p="http://schemas.openxmlformats.org/presentationml/2006/main" xmlns:r="http://schemas.openxmlformats.org/officeDocument/2006/relationships">
+  <p:cSld>
+    <p:spTree>
+      <p:nvGrpSpPr>
+        <p:cNvPr id="1" name=""/>
+        <p:cNvGrpSpPr/>
+        <p:nvPr/>
+      </p:nvGrpSpPr>
+      <p:grpSpPr>
+        <a:xfrm>
+          <a:off x="0" y="0"/>
+          <a:ext cx="0" cy="0"/>
+          <a:chOff x="0" y="0"/>
+          <a:chExt cx="0" cy="0"/>
+        </a:xfrm>
+      </p:grpSpPr>
+      <p:sp>
+        <p:nvSpPr>
+          <p:cNvPr id="2" name="Slide Image Placeholder 1"/>
+          <p:cNvSpPr>
+            <a:spLocks noGrp="1"/>
+          </p:cNvSpPr>
+          <p:nvPr>
+            <p:ph type="sldImg" idx="2"/>
+          </p:nvPr>
+        </p:nvSpPr>
+        <p:spPr/>
+      </p:sp>
+      <p:sp>
+        <p:nvSpPr>
+          <p:cNvPr id="3" name="Notes Placeholder 2"/>
+          <p:cNvSpPr>
+            <a:spLocks noGrp="1"/>
+          </p:cNvSpPr>
+          <p:nvPr>
+            <p:ph type="body" idx="3" sz="quarter"/>
+          </p:nvPr>
+        </p:nvSpPr>
+        <p:spPr/>
+        <p:txBody>
+          <a:bodyPr/>
+          <a:lstStyle/>
+          <a:p>
+            <a:r>
+              <a:t>2 つ目、検知ルールを 13 本自作しました。</a:t>
+            </a:r>
+          </a:p>
+          <a:p>
+            <a:r>
+              <a:t>着眼点は「攻撃者は必ず証拠隠しをする。なら、消す行為そのものを検知すればいい」。代表的な 4 つが、ログの消去、復元データの削除、監視の無効化、パスワードの抜き取りです。</a:t>
+            </a:r>
+          </a:p>
+          <a:p>
+            <a:r>
+              <a:t>誤検知を減らすため、1 つの特徴では鳴らさず、複数の特徴が同時に揃ったときだけ警告する設計にしています。</a:t>
+            </a:r>
+          </a:p>
+        </p:txBody>
+      </p:sp>
+      <p:sp>
+        <p:nvSpPr>
+          <p:cNvPr id="4" name="Slide Number Placeholder 3"/>
+          <p:cNvSpPr>
+            <a:spLocks noGrp="1"/>
+          </p:cNvSpPr>
+          <p:nvPr>
+            <p:ph type="sldNum" idx="5" sz="quarter"/>
+          </p:nvPr>
+        </p:nvSpPr>
+        <p:spPr/>
+      </p:sp>
+    </p:spTree>
+  </p:cSld>
+  <p:clrMapOvr>
+    <a:masterClrMapping/>
+  </p:clrMapOvr>
+</p:notes>
 </file>
 
 <file path=ppt/slideLayouts/slideLayout1.xml><?xml version="1.0" encoding="utf-8"?>
@@ -18434,4 +19969,324 @@
   </a:objectDefaults>
   <a:extraClrSchemeLst/>
 </a:theme>
+</file>
+
+<file path=ppt/theme/theme2.xml><?xml version="1.0" encoding="utf-8"?>
+<a:theme xmlns:a="http://schemas.openxmlformats.org/drawingml/2006/main" name="Office Theme">
+  <a:themeElements>
+    <a:clrScheme name="Office">
+      <a:dk1>
+        <a:sysClr val="windowText" lastClr="000000"/>
+      </a:dk1>
+      <a:lt1>
+        <a:sysClr val="window" lastClr="FFFFFF"/>
+      </a:lt1>
+      <a:dk2>
+        <a:srgbClr val="1F497D"/>
+      </a:dk2>
+      <a:lt2>
+        <a:srgbClr val="EEECE1"/>
+      </a:lt2>
+      <a:accent1>
+        <a:srgbClr val="4F81BD"/>
+      </a:accent1>
+      <a:accent2>
+        <a:srgbClr val="C0504D"/>
+      </a:accent2>
+      <a:accent3>
+        <a:srgbClr val="9BBB59"/>
+      </a:accent3>
+      <a:accent4>
+        <a:srgbClr val="8064A2"/>
+      </a:accent4>
+      <a:accent5>
+        <a:srgbClr val="4BACC6"/>
+      </a:accent5>
+      <a:accent6>
+        <a:srgbClr val="F79646"/>
+      </a:accent6>
+      <a:hlink>
+        <a:srgbClr val="0000FF"/>
+      </a:hlink>
+      <a:folHlink>
+        <a:srgbClr val="800080"/>
+      </a:folHlink>
+    </a:clrScheme>
+    <a:fontScheme name="Office">
+      <a:majorFont>
+        <a:latin typeface="Calibri"/>
+        <a:ea typeface=""/>
+        <a:cs typeface=""/>
+        <a:font script="Jpan" typeface="ＭＳ Ｐゴシック"/>
+        <a:font script="Hang" typeface="맑은 고딕"/>
+        <a:font script="Hans" typeface="宋体"/>
+        <a:font script="Hant" typeface="新細明體"/>
+        <a:font script="Arab" typeface="Times New Roman"/>
+        <a:font script="Hebr" typeface="Times New Roman"/>
+        <a:font script="Thai" typeface="Angsana New"/>
+        <a:font script="Ethi" typeface="Nyala"/>
+        <a:font script="Beng" typeface="Vrinda"/>
+        <a:font script="Gujr" typeface="Shruti"/>
+        <a:font script="Khmr" typeface="MoolBoran"/>
+        <a:font script="Knda" typeface="Tunga"/>
+        <a:font script="Guru" typeface="Raavi"/>
+        <a:font script="Cans" typeface="Euphemia"/>
+        <a:font script="Cher" typeface="Plantagenet Cherokee"/>
+        <a:font script="Yiii" typeface="Microsoft Yi Baiti"/>
+        <a:font script="Tibt" typeface="Microsoft Himalaya"/>
+        <a:font script="Thaa" typeface="MV Boli"/>
+        <a:font script="Deva" typeface="Mangal"/>
+        <a:font script="Telu" typeface="Gautami"/>
+        <a:font script="Taml" typeface="Latha"/>
+        <a:font script="Syrc" typeface="Estrangelo Edessa"/>
+        <a:font script="Orya" typeface="Kalinga"/>
+        <a:font script="Mlym" typeface="Kartika"/>
+        <a:font script="Laoo" typeface="DokChampa"/>
+        <a:font script="Sinh" typeface="Iskoola Pota"/>
+        <a:font script="Mong" typeface="Mongolian Baiti"/>
+        <a:font script="Viet" typeface="Times New Roman"/>
+        <a:font script="Uigh" typeface="Microsoft Uighur"/>
+        <a:font script="Geor" typeface="Sylfaen"/>
+      </a:majorFont>
+      <a:minorFont>
+        <a:latin typeface="Calibri"/>
+        <a:ea typeface=""/>
+        <a:cs typeface=""/>
+        <a:font script="Jpan" typeface="ＭＳ Ｐゴシック"/>
+        <a:font script="Hang" typeface="맑은 고딕"/>
+        <a:font script="Hans" typeface="宋体"/>
+        <a:font script="Hant" typeface="新細明體"/>
+        <a:font script="Arab" typeface="Arial"/>
+        <a:font script="Hebr" typeface="Arial"/>
+        <a:font script="Thai" typeface="Cordia New"/>
+        <a:font script="Ethi" typeface="Nyala"/>
+        <a:font script="Beng" typeface="Vrinda"/>
+        <a:font script="Gujr" typeface="Shruti"/>
+        <a:font script="Khmr" typeface="DaunPenh"/>
+        <a:font script="Knda" typeface="Tunga"/>
+        <a:font script="Guru" typeface="Raavi"/>
+        <a:font script="Cans" typeface="Euphemia"/>
+        <a:font script="Cher" typeface="Plantagenet Cherokee"/>
+        <a:font script="Yiii" typeface="Microsoft Yi Baiti"/>
+        <a:font script="Tibt" typeface="Microsoft Himalaya"/>
+        <a:font script="Thaa" typeface="MV Boli"/>
+        <a:font script="Deva" typeface="Mangal"/>
+        <a:font script="Telu" typeface="Gautami"/>
+        <a:font script="Taml" typeface="Latha"/>
+        <a:font script="Syrc" typeface="Estrangelo Edessa"/>
+        <a:font script="Orya" typeface="Kalinga"/>
+        <a:font script="Mlym" typeface="Kartika"/>
+        <a:font script="Laoo" typeface="DokChampa"/>
+        <a:font script="Sinh" typeface="Iskoola Pota"/>
+        <a:font script="Mong" typeface="Mongolian Baiti"/>
+        <a:font script="Viet" typeface="Arial"/>
+        <a:font script="Uigh" typeface="Microsoft Uighur"/>
+        <a:font script="Geor" typeface="Sylfaen"/>
+      </a:minorFont>
+    </a:fontScheme>
+    <a:fmtScheme name="Office">
+      <a:fillStyleLst>
+        <a:solidFill>
+          <a:schemeClr val="phClr"/>
+        </a:solidFill>
+        <a:gradFill rotWithShape="1">
+          <a:gsLst>
+            <a:gs pos="0">
+              <a:schemeClr val="phClr">
+                <a:tint val="50000"/>
+                <a:satMod val="300000"/>
+              </a:schemeClr>
+            </a:gs>
+            <a:gs pos="35000">
+              <a:schemeClr val="phClr">
+                <a:tint val="37000"/>
+                <a:satMod val="300000"/>
+              </a:schemeClr>
+            </a:gs>
+            <a:gs pos="100000">
+              <a:schemeClr val="phClr">
+                <a:tint val="15000"/>
+                <a:satMod val="350000"/>
+              </a:schemeClr>
+            </a:gs>
+          </a:gsLst>
+          <a:lin ang="16200000" scaled="1"/>
+        </a:gradFill>
+        <a:gradFill rotWithShape="1">
+          <a:gsLst>
+            <a:gs pos="0">
+              <a:schemeClr val="phClr">
+                <a:tint val="100000"/>
+                <a:shade val="100000"/>
+                <a:satMod val="130000"/>
+              </a:schemeClr>
+            </a:gs>
+            <a:gs pos="100000">
+              <a:schemeClr val="phClr">
+                <a:tint val="50000"/>
+                <a:shade val="100000"/>
+                <a:satMod val="350000"/>
+              </a:schemeClr>
+            </a:gs>
+          </a:gsLst>
+          <a:lin ang="16200000" scaled="0"/>
+        </a:gradFill>
+      </a:fillStyleLst>
+      <a:lnStyleLst>
+        <a:ln w="9525" cap="flat" cmpd="sng" algn="ctr">
+          <a:solidFill>
+            <a:schemeClr val="phClr">
+              <a:shade val="95000"/>
+              <a:satMod val="105000"/>
+            </a:schemeClr>
+          </a:solidFill>
+          <a:prstDash val="solid"/>
+        </a:ln>
+        <a:ln w="25400" cap="flat" cmpd="sng" algn="ctr">
+          <a:solidFill>
+            <a:schemeClr val="phClr"/>
+          </a:solidFill>
+          <a:prstDash val="solid"/>
+        </a:ln>
+        <a:ln w="38100" cap="flat" cmpd="sng" algn="ctr">
+          <a:solidFill>
+            <a:schemeClr val="phClr"/>
+          </a:solidFill>
+          <a:prstDash val="solid"/>
+        </a:ln>
+      </a:lnStyleLst>
+      <a:effectStyleLst>
+        <a:effectStyle>
+          <a:effectLst>
+            <a:outerShdw blurRad="40000" dist="20000" dir="5400000" rotWithShape="0">
+              <a:srgbClr val="000000">
+                <a:alpha val="38000"/>
+              </a:srgbClr>
+            </a:outerShdw>
+          </a:effectLst>
+        </a:effectStyle>
+        <a:effectStyle>
+          <a:effectLst>
+            <a:outerShdw blurRad="40000" dist="23000" dir="5400000" rotWithShape="0">
+              <a:srgbClr val="000000">
+                <a:alpha val="35000"/>
+              </a:srgbClr>
+            </a:outerShdw>
+          </a:effectLst>
+        </a:effectStyle>
+        <a:effectStyle>
+          <a:effectLst>
+            <a:outerShdw blurRad="40000" dist="23000" dir="5400000" rotWithShape="0">
+              <a:srgbClr val="000000">
+                <a:alpha val="35000"/>
+              </a:srgbClr>
+            </a:outerShdw>
+          </a:effectLst>
+          <a:scene3d>
+            <a:camera prst="orthographicFront">
+              <a:rot lat="0" lon="0" rev="0"/>
+            </a:camera>
+            <a:lightRig rig="threePt" dir="t">
+              <a:rot lat="0" lon="0" rev="1200000"/>
+            </a:lightRig>
+          </a:scene3d>
+          <a:sp3d>
+            <a:bevelT w="63500" h="25400"/>
+          </a:sp3d>
+        </a:effectStyle>
+      </a:effectStyleLst>
+      <a:bgFillStyleLst>
+        <a:solidFill>
+          <a:schemeClr val="phClr"/>
+        </a:solidFill>
+        <a:gradFill rotWithShape="1">
+          <a:gsLst>
+            <a:gs pos="0">
+              <a:schemeClr val="phClr">
+                <a:tint val="40000"/>
+                <a:satMod val="350000"/>
+              </a:schemeClr>
+            </a:gs>
+            <a:gs pos="40000">
+              <a:schemeClr val="phClr">
+                <a:tint val="45000"/>
+                <a:shade val="99000"/>
+                <a:satMod val="350000"/>
+              </a:schemeClr>
+            </a:gs>
+            <a:gs pos="100000">
+              <a:schemeClr val="phClr">
+                <a:shade val="20000"/>
+                <a:satMod val="255000"/>
+              </a:schemeClr>
+            </a:gs>
+          </a:gsLst>
+          <a:path path="circle">
+            <a:fillToRect l="50000" t="-80000" r="50000" b="180000"/>
+          </a:path>
+        </a:gradFill>
+        <a:gradFill rotWithShape="1">
+          <a:gsLst>
+            <a:gs pos="0">
+              <a:schemeClr val="phClr">
+                <a:tint val="80000"/>
+                <a:satMod val="300000"/>
+              </a:schemeClr>
+            </a:gs>
+            <a:gs pos="100000">
+              <a:schemeClr val="phClr">
+                <a:shade val="30000"/>
+                <a:satMod val="200000"/>
+              </a:schemeClr>
+            </a:gs>
+          </a:gsLst>
+          <a:path path="circle">
+            <a:fillToRect l="50000" t="50000" r="50000" b="50000"/>
+          </a:path>
+        </a:gradFill>
+      </a:bgFillStyleLst>
+    </a:fmtScheme>
+  </a:themeElements>
+  <a:objectDefaults>
+    <a:spDef>
+      <a:spPr/>
+      <a:bodyPr/>
+      <a:lstStyle/>
+      <a:style>
+        <a:lnRef idx="1">
+          <a:schemeClr val="accent1"/>
+        </a:lnRef>
+        <a:fillRef idx="3">
+          <a:schemeClr val="accent1"/>
+        </a:fillRef>
+        <a:effectRef idx="2">
+          <a:schemeClr val="accent1"/>
+        </a:effectRef>
+        <a:fontRef idx="minor">
+          <a:schemeClr val="lt1"/>
+        </a:fontRef>
+      </a:style>
+    </a:spDef>
+    <a:lnDef>
+      <a:spPr/>
+      <a:bodyPr/>
+      <a:lstStyle/>
+      <a:style>
+        <a:lnRef idx="2">
+          <a:schemeClr val="accent1"/>
+        </a:lnRef>
+        <a:fillRef idx="0">
+          <a:schemeClr val="accent1"/>
+        </a:fillRef>
+        <a:effectRef idx="1">
+          <a:schemeClr val="accent1"/>
+        </a:effectRef>
+        <a:fontRef idx="minor">
+          <a:schemeClr val="tx1"/>
+        </a:fontRef>
+      </a:style>
+    </a:lnDef>
+  </a:objectDefaults>
+  <a:extraClrSchemeLst/>
+</a:theme>
 </file>
</xml_diff>

<commit_message>
docs: add 13-rule appendix slide + fix README count 11->13, naturalize wording
Reviewers are likely to ask about all 13 bundled rules, and the prior
wording was stiff/jargon-heavy.

- Slides: add an appendix slide (after slide 15) listing all 13 rules in
  attack-flow order (enter/move -> steal/persist -> blind defenses ->
  erase evidence), with plain-Japanese one-liners and red/orange dots
  matching each rule's real critical/high level. Add a Q&A speaker note.
- README: the rule table said '11 本' but rules-custom/ has 13 (anti_
  forensics_clear_then_change and wmi_persistence_filter_to_consumer were
  missing). Add both, fix the count in all three places, correct the
  level breakdown to critical 8 / high 5, and reword every '検知対象'
  line into natural Japanese.

Co-Authored-By: Claude Fable 5 <noreply@anthropic.com>
</commit_message>
<xml_diff>
--- a/docs/presentation/pptx/hayabusa-plus.pptx
+++ b/docs/presentation/pptx/hayabusa-plus.pptx
@@ -20,6 +20,7 @@
     <p:sldId id="268" r:id="rId19"/>
     <p:sldId id="269" r:id="rId20"/>
     <p:sldId id="270" r:id="rId21"/>
+    <p:sldId id="271" r:id="rId22"/>
   </p:sldIdLst>
   <p:sldSz cx="12191695" cy="6858000" type="screen4x3"/>
   <p:notesSz cx="6858000" cy="9144000"/>
@@ -997,6 +998,86 @@
           <a:p>
             <a:r>
               <a:t>成果物はすべて GitHub で公開しているので、お手元の Windows PC のログでぜひ一度試してみてください。ご質問・フィードバックをお願いします。</a:t>
+            </a:r>
+          </a:p>
+        </p:txBody>
+      </p:sp>
+      <p:sp>
+        <p:nvSpPr>
+          <p:cNvPr id="4" name="Slide Number Placeholder 3"/>
+          <p:cNvSpPr>
+            <a:spLocks noGrp="1"/>
+          </p:cNvSpPr>
+          <p:nvPr>
+            <p:ph type="sldNum" idx="5" sz="quarter"/>
+          </p:nvPr>
+        </p:nvSpPr>
+        <p:spPr/>
+      </p:sp>
+    </p:spTree>
+  </p:cSld>
+  <p:clrMapOvr>
+    <a:masterClrMapping/>
+  </p:clrMapOvr>
+</p:notes>
+</file>
+
+<file path=ppt/notesSlides/notesSlide16.xml><?xml version="1.0" encoding="utf-8"?>
+<p:notes xmlns:a="http://schemas.openxmlformats.org/drawingml/2006/main" xmlns:p="http://schemas.openxmlformats.org/presentationml/2006/main" xmlns:r="http://schemas.openxmlformats.org/officeDocument/2006/relationships">
+  <p:cSld>
+    <p:spTree>
+      <p:nvGrpSpPr>
+        <p:cNvPr id="1" name=""/>
+        <p:cNvGrpSpPr/>
+        <p:nvPr/>
+      </p:nvGrpSpPr>
+      <p:grpSpPr>
+        <a:xfrm>
+          <a:off x="0" y="0"/>
+          <a:ext cx="0" cy="0"/>
+          <a:chOff x="0" y="0"/>
+          <a:chExt cx="0" cy="0"/>
+        </a:xfrm>
+      </p:grpSpPr>
+      <p:sp>
+        <p:nvSpPr>
+          <p:cNvPr id="2" name="Slide Image Placeholder 1"/>
+          <p:cNvSpPr>
+            <a:spLocks noGrp="1"/>
+          </p:cNvSpPr>
+          <p:nvPr>
+            <p:ph type="sldImg" idx="2"/>
+          </p:nvPr>
+        </p:nvSpPr>
+        <p:spPr/>
+      </p:sp>
+      <p:sp>
+        <p:nvSpPr>
+          <p:cNvPr id="3" name="Notes Placeholder 2"/>
+          <p:cNvSpPr>
+            <a:spLocks noGrp="1"/>
+          </p:cNvSpPr>
+          <p:nvPr>
+            <p:ph type="body" idx="3" sz="quarter"/>
+          </p:nvPr>
+        </p:nvSpPr>
+        <p:spPr/>
+        <p:txBody>
+          <a:bodyPr/>
+          <a:lstStyle/>
+          <a:p>
+            <a:r>
+              <a:t>(付録・Q&amp;A 用) 「13 本って具体的には?」と聞かれたら、このスライドを出してください。</a:t>
+            </a:r>
+          </a:p>
+          <a:p>
+            <a:r>
+              <a:t>本編では代表的な 4 種類を紹介しましたが、実際は攻撃の流れに沿って 13 本を用意しています。「①外から入って動く → ②盗んで住み着く → ③監視を無力化 → ④証拠を消す」という順番で、それぞれの段階で出る特徴を捕まえます。</a:t>
+            </a:r>
+          </a:p>
+          <a:p>
+            <a:r>
+              <a:t>赤が critical、橙が high です。気になるルールがあれば個別に説明できます。</a:t>
             </a:r>
           </a:p>
         </p:txBody>
@@ -10785,6 +10866,1946 @@
                 <a:latin typeface="Calibri"/>
               </a:rPr>
               <a:t>お手元の Windows PC のログで、ぜひ一度。</a:t>
+            </a:r>
+          </a:p>
+        </p:txBody>
+      </p:sp>
+    </p:spTree>
+  </p:cSld>
+  <p:clrMapOvr>
+    <a:masterClrMapping/>
+  </p:clrMapOvr>
+</p:sld>
+</file>
+
+<file path=ppt/slides/slide16.xml><?xml version="1.0" encoding="utf-8"?>
+<p:sld xmlns:a="http://schemas.openxmlformats.org/drawingml/2006/main" xmlns:p="http://schemas.openxmlformats.org/presentationml/2006/main" xmlns:r="http://schemas.openxmlformats.org/officeDocument/2006/relationships">
+  <p:cSld>
+    <p:spTree>
+      <p:nvGrpSpPr>
+        <p:cNvPr id="1" name=""/>
+        <p:cNvGrpSpPr/>
+        <p:nvPr/>
+      </p:nvGrpSpPr>
+      <p:grpSpPr/>
+      <p:sp>
+        <p:nvSpPr>
+          <p:cNvPr id="2" name="Rectangle 1"/>
+          <p:cNvSpPr/>
+          <p:nvPr/>
+        </p:nvSpPr>
+        <p:spPr>
+          <a:xfrm>
+            <a:off x="0" y="0"/>
+            <a:ext cx="12191695" cy="6858000"/>
+          </a:xfrm>
+          <a:prstGeom prst="rect">
+            <a:avLst/>
+          </a:prstGeom>
+          <a:solidFill>
+            <a:srgbClr val="F4F6FA"/>
+          </a:solidFill>
+          <a:ln>
+            <a:noFill/>
+          </a:ln>
+          <a:effectLst/>
+        </p:spPr>
+        <p:style>
+          <a:lnRef idx="1">
+            <a:schemeClr val="accent1"/>
+          </a:lnRef>
+          <a:fillRef idx="3">
+            <a:schemeClr val="accent1"/>
+          </a:fillRef>
+          <a:effectRef idx="2">
+            <a:schemeClr val="accent1"/>
+          </a:effectRef>
+          <a:fontRef idx="minor">
+            <a:schemeClr val="lt1"/>
+          </a:fontRef>
+        </p:style>
+        <p:txBody>
+          <a:bodyPr rtlCol="0" anchor="ctr"/>
+          <a:lstStyle/>
+          <a:p>
+            <a:pPr algn="ctr"/>
+          </a:p>
+        </p:txBody>
+      </p:sp>
+      <p:sp>
+        <p:nvSpPr>
+          <p:cNvPr id="3" name="TextBox 2"/>
+          <p:cNvSpPr txBox="1"/>
+          <p:nvPr/>
+        </p:nvSpPr>
+        <p:spPr>
+          <a:xfrm>
+            <a:off x="548640" y="347472"/>
+            <a:ext cx="10972800" cy="274320"/>
+          </a:xfrm>
+          <a:prstGeom prst="rect">
+            <a:avLst/>
+          </a:prstGeom>
+          <a:noFill/>
+        </p:spPr>
+        <p:txBody>
+          <a:bodyPr wrap="square" lIns="0" rIns="0" tIns="0" bIns="0" anchor="t">
+            <a:spAutoFit/>
+          </a:bodyPr>
+          <a:lstStyle/>
+          <a:p>
+            <a:pPr algn="l">
+              <a:lnSpc>
+                <a:spcPct val="130000"/>
+              </a:lnSpc>
+            </a:pPr>
+            <a:r>
+              <a:rPr sz="1100" b="1" i="0">
+                <a:solidFill>
+                  <a:srgbClr val="2563EB"/>
+                </a:solidFill>
+                <a:latin typeface="Calibri"/>
+              </a:rPr>
+              <a:t>Q&amp;A 用   — 攻撃の流れに沿って整理</a:t>
+            </a:r>
+          </a:p>
+        </p:txBody>
+      </p:sp>
+      <p:sp>
+        <p:nvSpPr>
+          <p:cNvPr id="4" name="TextBox 3"/>
+          <p:cNvSpPr txBox="1"/>
+          <p:nvPr/>
+        </p:nvSpPr>
+        <p:spPr>
+          <a:xfrm>
+            <a:off x="548640" y="621792"/>
+            <a:ext cx="11155680" cy="640080"/>
+          </a:xfrm>
+          <a:prstGeom prst="rect">
+            <a:avLst/>
+          </a:prstGeom>
+          <a:noFill/>
+        </p:spPr>
+        <p:txBody>
+          <a:bodyPr wrap="square" lIns="0" rIns="0" tIns="0" bIns="0" anchor="t">
+            <a:spAutoFit/>
+          </a:bodyPr>
+          <a:lstStyle/>
+          <a:p>
+            <a:pPr algn="l">
+              <a:lnSpc>
+                <a:spcPct val="130000"/>
+              </a:lnSpc>
+            </a:pPr>
+            <a:r>
+              <a:rPr sz="2800" b="1" i="0">
+                <a:solidFill>
+                  <a:srgbClr val="1F2937"/>
+                </a:solidFill>
+                <a:latin typeface="Cambria"/>
+              </a:rPr>
+              <a:t>付録: 同梱している検知ルール 13 本</a:t>
+            </a:r>
+          </a:p>
+        </p:txBody>
+      </p:sp>
+      <p:sp>
+        <p:nvSpPr>
+          <p:cNvPr id="5" name="Oval 4"/>
+          <p:cNvSpPr/>
+          <p:nvPr/>
+        </p:nvSpPr>
+        <p:spPr>
+          <a:xfrm>
+            <a:off x="8275320" y="502920"/>
+            <a:ext cx="146304" cy="146304"/>
+          </a:xfrm>
+          <a:prstGeom prst="ellipse">
+            <a:avLst/>
+          </a:prstGeom>
+          <a:solidFill>
+            <a:srgbClr val="DC2626"/>
+          </a:solidFill>
+          <a:ln>
+            <a:noFill/>
+          </a:ln>
+          <a:effectLst/>
+        </p:spPr>
+        <p:style>
+          <a:lnRef idx="1">
+            <a:schemeClr val="accent1"/>
+          </a:lnRef>
+          <a:fillRef idx="3">
+            <a:schemeClr val="accent1"/>
+          </a:fillRef>
+          <a:effectRef idx="2">
+            <a:schemeClr val="accent1"/>
+          </a:effectRef>
+          <a:fontRef idx="minor">
+            <a:schemeClr val="lt1"/>
+          </a:fontRef>
+        </p:style>
+        <p:txBody>
+          <a:bodyPr rtlCol="0" anchor="ctr"/>
+          <a:lstStyle/>
+          <a:p>
+            <a:pPr algn="ctr"/>
+          </a:p>
+        </p:txBody>
+      </p:sp>
+      <p:sp>
+        <p:nvSpPr>
+          <p:cNvPr id="6" name="TextBox 5"/>
+          <p:cNvSpPr txBox="1"/>
+          <p:nvPr/>
+        </p:nvSpPr>
+        <p:spPr>
+          <a:xfrm>
+            <a:off x="8485632" y="457200"/>
+            <a:ext cx="1554480" cy="274320"/>
+          </a:xfrm>
+          <a:prstGeom prst="rect">
+            <a:avLst/>
+          </a:prstGeom>
+          <a:noFill/>
+        </p:spPr>
+        <p:txBody>
+          <a:bodyPr wrap="square" lIns="0" rIns="0" tIns="0" bIns="0" anchor="ctr">
+            <a:spAutoFit/>
+          </a:bodyPr>
+          <a:lstStyle/>
+          <a:p>
+            <a:pPr algn="l">
+              <a:lnSpc>
+                <a:spcPct val="130000"/>
+              </a:lnSpc>
+            </a:pPr>
+            <a:r>
+              <a:rPr sz="1000" b="0" i="0">
+                <a:solidFill>
+                  <a:srgbClr val="5B6472"/>
+                </a:solidFill>
+                <a:latin typeface="Calibri"/>
+              </a:rPr>
+              <a:t>critical (最重要)</a:t>
+            </a:r>
+          </a:p>
+        </p:txBody>
+      </p:sp>
+      <p:sp>
+        <p:nvSpPr>
+          <p:cNvPr id="7" name="Oval 6"/>
+          <p:cNvSpPr/>
+          <p:nvPr/>
+        </p:nvSpPr>
+        <p:spPr>
+          <a:xfrm>
+            <a:off x="10149840" y="502920"/>
+            <a:ext cx="146304" cy="146304"/>
+          </a:xfrm>
+          <a:prstGeom prst="ellipse">
+            <a:avLst/>
+          </a:prstGeom>
+          <a:solidFill>
+            <a:srgbClr val="EA580C"/>
+          </a:solidFill>
+          <a:ln>
+            <a:noFill/>
+          </a:ln>
+          <a:effectLst/>
+        </p:spPr>
+        <p:style>
+          <a:lnRef idx="1">
+            <a:schemeClr val="accent1"/>
+          </a:lnRef>
+          <a:fillRef idx="3">
+            <a:schemeClr val="accent1"/>
+          </a:fillRef>
+          <a:effectRef idx="2">
+            <a:schemeClr val="accent1"/>
+          </a:effectRef>
+          <a:fontRef idx="minor">
+            <a:schemeClr val="lt1"/>
+          </a:fontRef>
+        </p:style>
+        <p:txBody>
+          <a:bodyPr rtlCol="0" anchor="ctr"/>
+          <a:lstStyle/>
+          <a:p>
+            <a:pPr algn="ctr"/>
+          </a:p>
+        </p:txBody>
+      </p:sp>
+      <p:sp>
+        <p:nvSpPr>
+          <p:cNvPr id="8" name="TextBox 7"/>
+          <p:cNvSpPr txBox="1"/>
+          <p:nvPr/>
+        </p:nvSpPr>
+        <p:spPr>
+          <a:xfrm>
+            <a:off x="10360152" y="457200"/>
+            <a:ext cx="1280160" cy="274320"/>
+          </a:xfrm>
+          <a:prstGeom prst="rect">
+            <a:avLst/>
+          </a:prstGeom>
+          <a:noFill/>
+        </p:spPr>
+        <p:txBody>
+          <a:bodyPr wrap="square" lIns="0" rIns="0" tIns="0" bIns="0" anchor="ctr">
+            <a:spAutoFit/>
+          </a:bodyPr>
+          <a:lstStyle/>
+          <a:p>
+            <a:pPr algn="l">
+              <a:lnSpc>
+                <a:spcPct val="130000"/>
+              </a:lnSpc>
+            </a:pPr>
+            <a:r>
+              <a:rPr sz="1000" b="0" i="0">
+                <a:solidFill>
+                  <a:srgbClr val="5B6472"/>
+                </a:solidFill>
+                <a:latin typeface="Calibri"/>
+              </a:rPr>
+              <a:t>high (重要)</a:t>
+            </a:r>
+          </a:p>
+        </p:txBody>
+      </p:sp>
+      <p:sp>
+        <p:nvSpPr>
+          <p:cNvPr id="9" name="Rounded Rectangle 8"/>
+          <p:cNvSpPr/>
+          <p:nvPr/>
+        </p:nvSpPr>
+        <p:spPr>
+          <a:xfrm>
+            <a:off x="548640" y="1783080"/>
+            <a:ext cx="5349240" cy="2240280"/>
+          </a:xfrm>
+          <a:prstGeom prst="roundRect">
+            <a:avLst/>
+          </a:prstGeom>
+          <a:solidFill>
+            <a:srgbClr val="FFFFFF"/>
+          </a:solidFill>
+          <a:ln w="9525">
+            <a:solidFill>
+              <a:srgbClr val="DDE3EE"/>
+            </a:solidFill>
+          </a:ln>
+          <a:effectLst/>
+        </p:spPr>
+        <p:style>
+          <a:lnRef idx="1">
+            <a:schemeClr val="accent1"/>
+          </a:lnRef>
+          <a:fillRef idx="3">
+            <a:schemeClr val="accent1"/>
+          </a:fillRef>
+          <a:effectRef idx="2">
+            <a:schemeClr val="accent1"/>
+          </a:effectRef>
+          <a:fontRef idx="minor">
+            <a:schemeClr val="lt1"/>
+          </a:fontRef>
+        </p:style>
+        <p:txBody>
+          <a:bodyPr rtlCol="0" anchor="ctr"/>
+          <a:lstStyle/>
+          <a:p>
+            <a:pPr algn="ctr"/>
+          </a:p>
+        </p:txBody>
+      </p:sp>
+      <p:sp>
+        <p:nvSpPr>
+          <p:cNvPr id="10" name="Rectangle 9"/>
+          <p:cNvSpPr/>
+          <p:nvPr/>
+        </p:nvSpPr>
+        <p:spPr>
+          <a:xfrm>
+            <a:off x="548640" y="1783080"/>
+            <a:ext cx="73152" cy="2240280"/>
+          </a:xfrm>
+          <a:prstGeom prst="rect">
+            <a:avLst/>
+          </a:prstGeom>
+          <a:solidFill>
+            <a:srgbClr val="2563EB"/>
+          </a:solidFill>
+          <a:ln>
+            <a:noFill/>
+          </a:ln>
+          <a:effectLst/>
+        </p:spPr>
+        <p:style>
+          <a:lnRef idx="1">
+            <a:schemeClr val="accent1"/>
+          </a:lnRef>
+          <a:fillRef idx="3">
+            <a:schemeClr val="accent1"/>
+          </a:fillRef>
+          <a:effectRef idx="2">
+            <a:schemeClr val="accent1"/>
+          </a:effectRef>
+          <a:fontRef idx="minor">
+            <a:schemeClr val="lt1"/>
+          </a:fontRef>
+        </p:style>
+        <p:txBody>
+          <a:bodyPr rtlCol="0" anchor="ctr"/>
+          <a:lstStyle/>
+          <a:p>
+            <a:pPr algn="ctr"/>
+          </a:p>
+        </p:txBody>
+      </p:sp>
+      <p:sp>
+        <p:nvSpPr>
+          <p:cNvPr id="11" name="TextBox 10"/>
+          <p:cNvSpPr txBox="1"/>
+          <p:nvPr/>
+        </p:nvSpPr>
+        <p:spPr>
+          <a:xfrm>
+            <a:off x="804672" y="1929384"/>
+            <a:ext cx="4937759" cy="411480"/>
+          </a:xfrm>
+          <a:prstGeom prst="rect">
+            <a:avLst/>
+          </a:prstGeom>
+          <a:noFill/>
+        </p:spPr>
+        <p:txBody>
+          <a:bodyPr wrap="square" lIns="0" rIns="0" tIns="0" bIns="0" anchor="t">
+            <a:spAutoFit/>
+          </a:bodyPr>
+          <a:lstStyle/>
+          <a:p>
+            <a:pPr algn="l">
+              <a:lnSpc>
+                <a:spcPct val="130000"/>
+              </a:lnSpc>
+            </a:pPr>
+            <a:r>
+              <a:rPr sz="1400" b="1" i="0">
+                <a:solidFill>
+                  <a:srgbClr val="1D4ED8"/>
+                </a:solidFill>
+                <a:latin typeface="Cambria"/>
+              </a:rPr>
+              <a:t>① 外から入る・動く・つながる</a:t>
+            </a:r>
+          </a:p>
+        </p:txBody>
+      </p:sp>
+      <p:sp>
+        <p:nvSpPr>
+          <p:cNvPr id="12" name="Oval 11"/>
+          <p:cNvSpPr/>
+          <p:nvPr/>
+        </p:nvSpPr>
+        <p:spPr>
+          <a:xfrm>
+            <a:off x="822959" y="2505456"/>
+            <a:ext cx="109728" cy="109728"/>
+          </a:xfrm>
+          <a:prstGeom prst="ellipse">
+            <a:avLst/>
+          </a:prstGeom>
+          <a:solidFill>
+            <a:srgbClr val="DC2626"/>
+          </a:solidFill>
+          <a:ln>
+            <a:noFill/>
+          </a:ln>
+          <a:effectLst/>
+        </p:spPr>
+        <p:style>
+          <a:lnRef idx="1">
+            <a:schemeClr val="accent1"/>
+          </a:lnRef>
+          <a:fillRef idx="3">
+            <a:schemeClr val="accent1"/>
+          </a:fillRef>
+          <a:effectRef idx="2">
+            <a:schemeClr val="accent1"/>
+          </a:effectRef>
+          <a:fontRef idx="minor">
+            <a:schemeClr val="lt1"/>
+          </a:fontRef>
+        </p:style>
+        <p:txBody>
+          <a:bodyPr rtlCol="0" anchor="ctr"/>
+          <a:lstStyle/>
+          <a:p>
+            <a:pPr algn="ctr"/>
+          </a:p>
+        </p:txBody>
+      </p:sp>
+      <p:sp>
+        <p:nvSpPr>
+          <p:cNvPr id="13" name="TextBox 12"/>
+          <p:cNvSpPr txBox="1"/>
+          <p:nvPr/>
+        </p:nvSpPr>
+        <p:spPr>
+          <a:xfrm>
+            <a:off x="1042416" y="2441448"/>
+            <a:ext cx="4636007" cy="365760"/>
+          </a:xfrm>
+          <a:prstGeom prst="rect">
+            <a:avLst/>
+          </a:prstGeom>
+          <a:noFill/>
+        </p:spPr>
+        <p:txBody>
+          <a:bodyPr wrap="square" lIns="0" rIns="0" tIns="0" bIns="0" anchor="t">
+            <a:spAutoFit/>
+          </a:bodyPr>
+          <a:lstStyle/>
+          <a:p>
+            <a:pPr algn="l">
+              <a:lnSpc>
+                <a:spcPct val="110000"/>
+              </a:lnSpc>
+            </a:pPr>
+            <a:r>
+              <a:rPr sz="1050" b="0" i="0">
+                <a:solidFill>
+                  <a:srgbClr val="1F2937"/>
+                </a:solidFill>
+                <a:latin typeface="Calibri"/>
+              </a:rPr>
+              <a:t>既知のマルウェアそのものが実行された (MalwareBazaar 照合)</a:t>
+            </a:r>
+          </a:p>
+        </p:txBody>
+      </p:sp>
+      <p:sp>
+        <p:nvSpPr>
+          <p:cNvPr id="14" name="Oval 13"/>
+          <p:cNvSpPr/>
+          <p:nvPr/>
+        </p:nvSpPr>
+        <p:spPr>
+          <a:xfrm>
+            <a:off x="822959" y="2889503"/>
+            <a:ext cx="109728" cy="109728"/>
+          </a:xfrm>
+          <a:prstGeom prst="ellipse">
+            <a:avLst/>
+          </a:prstGeom>
+          <a:solidFill>
+            <a:srgbClr val="DC2626"/>
+          </a:solidFill>
+          <a:ln>
+            <a:noFill/>
+          </a:ln>
+          <a:effectLst/>
+        </p:spPr>
+        <p:style>
+          <a:lnRef idx="1">
+            <a:schemeClr val="accent1"/>
+          </a:lnRef>
+          <a:fillRef idx="3">
+            <a:schemeClr val="accent1"/>
+          </a:fillRef>
+          <a:effectRef idx="2">
+            <a:schemeClr val="accent1"/>
+          </a:effectRef>
+          <a:fontRef idx="minor">
+            <a:schemeClr val="lt1"/>
+          </a:fontRef>
+        </p:style>
+        <p:txBody>
+          <a:bodyPr rtlCol="0" anchor="ctr"/>
+          <a:lstStyle/>
+          <a:p>
+            <a:pPr algn="ctr"/>
+          </a:p>
+        </p:txBody>
+      </p:sp>
+      <p:sp>
+        <p:nvSpPr>
+          <p:cNvPr id="15" name="TextBox 14"/>
+          <p:cNvSpPr txBox="1"/>
+          <p:nvPr/>
+        </p:nvSpPr>
+        <p:spPr>
+          <a:xfrm>
+            <a:off x="1042416" y="2825496"/>
+            <a:ext cx="4636007" cy="365760"/>
+          </a:xfrm>
+          <a:prstGeom prst="rect">
+            <a:avLst/>
+          </a:prstGeom>
+          <a:noFill/>
+        </p:spPr>
+        <p:txBody>
+          <a:bodyPr wrap="square" lIns="0" rIns="0" tIns="0" bIns="0" anchor="t">
+            <a:spAutoFit/>
+          </a:bodyPr>
+          <a:lstStyle/>
+          <a:p>
+            <a:pPr algn="l">
+              <a:lnSpc>
+                <a:spcPct val="110000"/>
+              </a:lnSpc>
+            </a:pPr>
+            <a:r>
+              <a:rPr sz="1050" b="0" i="0">
+                <a:solidFill>
+                  <a:srgbClr val="1F2937"/>
+                </a:solidFill>
+                <a:latin typeface="Calibri"/>
+              </a:rPr>
+              <a:t>指令サーバ (C2) として知られる場所への通信 (URLhaus 照合)</a:t>
+            </a:r>
+          </a:p>
+        </p:txBody>
+      </p:sp>
+      <p:sp>
+        <p:nvSpPr>
+          <p:cNvPr id="16" name="Oval 15"/>
+          <p:cNvSpPr/>
+          <p:nvPr/>
+        </p:nvSpPr>
+        <p:spPr>
+          <a:xfrm>
+            <a:off x="822959" y="3273551"/>
+            <a:ext cx="109728" cy="109728"/>
+          </a:xfrm>
+          <a:prstGeom prst="ellipse">
+            <a:avLst/>
+          </a:prstGeom>
+          <a:solidFill>
+            <a:srgbClr val="DC2626"/>
+          </a:solidFill>
+          <a:ln>
+            <a:noFill/>
+          </a:ln>
+          <a:effectLst/>
+        </p:spPr>
+        <p:style>
+          <a:lnRef idx="1">
+            <a:schemeClr val="accent1"/>
+          </a:lnRef>
+          <a:fillRef idx="3">
+            <a:schemeClr val="accent1"/>
+          </a:fillRef>
+          <a:effectRef idx="2">
+            <a:schemeClr val="accent1"/>
+          </a:effectRef>
+          <a:fontRef idx="minor">
+            <a:schemeClr val="lt1"/>
+          </a:fontRef>
+        </p:style>
+        <p:txBody>
+          <a:bodyPr rtlCol="0" anchor="ctr"/>
+          <a:lstStyle/>
+          <a:p>
+            <a:pPr algn="ctr"/>
+          </a:p>
+        </p:txBody>
+      </p:sp>
+      <p:sp>
+        <p:nvSpPr>
+          <p:cNvPr id="17" name="TextBox 16"/>
+          <p:cNvSpPr txBox="1"/>
+          <p:nvPr/>
+        </p:nvSpPr>
+        <p:spPr>
+          <a:xfrm>
+            <a:off x="1042416" y="3209544"/>
+            <a:ext cx="4636007" cy="365760"/>
+          </a:xfrm>
+          <a:prstGeom prst="rect">
+            <a:avLst/>
+          </a:prstGeom>
+          <a:noFill/>
+        </p:spPr>
+        <p:txBody>
+          <a:bodyPr wrap="square" lIns="0" rIns="0" tIns="0" bIns="0" anchor="t">
+            <a:spAutoFit/>
+          </a:bodyPr>
+          <a:lstStyle/>
+          <a:p>
+            <a:pPr algn="l">
+              <a:lnSpc>
+                <a:spcPct val="110000"/>
+              </a:lnSpc>
+            </a:pPr>
+            <a:r>
+              <a:rPr sz="1050" b="0" i="0">
+                <a:solidFill>
+                  <a:srgbClr val="1F2937"/>
+                </a:solidFill>
+                <a:latin typeface="Calibri"/>
+              </a:rPr>
+              <a:t>正規ツール certutil を悪用して外部からファイルを取得</a:t>
+            </a:r>
+          </a:p>
+        </p:txBody>
+      </p:sp>
+      <p:sp>
+        <p:nvSpPr>
+          <p:cNvPr id="18" name="Oval 17"/>
+          <p:cNvSpPr/>
+          <p:nvPr/>
+        </p:nvSpPr>
+        <p:spPr>
+          <a:xfrm>
+            <a:off x="822959" y="3657599"/>
+            <a:ext cx="109728" cy="109728"/>
+          </a:xfrm>
+          <a:prstGeom prst="ellipse">
+            <a:avLst/>
+          </a:prstGeom>
+          <a:solidFill>
+            <a:srgbClr val="DC2626"/>
+          </a:solidFill>
+          <a:ln>
+            <a:noFill/>
+          </a:ln>
+          <a:effectLst/>
+        </p:spPr>
+        <p:style>
+          <a:lnRef idx="1">
+            <a:schemeClr val="accent1"/>
+          </a:lnRef>
+          <a:fillRef idx="3">
+            <a:schemeClr val="accent1"/>
+          </a:fillRef>
+          <a:effectRef idx="2">
+            <a:schemeClr val="accent1"/>
+          </a:effectRef>
+          <a:fontRef idx="minor">
+            <a:schemeClr val="lt1"/>
+          </a:fontRef>
+        </p:style>
+        <p:txBody>
+          <a:bodyPr rtlCol="0" anchor="ctr"/>
+          <a:lstStyle/>
+          <a:p>
+            <a:pPr algn="ctr"/>
+          </a:p>
+        </p:txBody>
+      </p:sp>
+      <p:sp>
+        <p:nvSpPr>
+          <p:cNvPr id="19" name="TextBox 18"/>
+          <p:cNvSpPr txBox="1"/>
+          <p:nvPr/>
+        </p:nvSpPr>
+        <p:spPr>
+          <a:xfrm>
+            <a:off x="1042416" y="3593591"/>
+            <a:ext cx="4636007" cy="365760"/>
+          </a:xfrm>
+          <a:prstGeom prst="rect">
+            <a:avLst/>
+          </a:prstGeom>
+          <a:noFill/>
+        </p:spPr>
+        <p:txBody>
+          <a:bodyPr wrap="square" lIns="0" rIns="0" tIns="0" bIns="0" anchor="t">
+            <a:spAutoFit/>
+          </a:bodyPr>
+          <a:lstStyle/>
+          <a:p>
+            <a:pPr algn="l">
+              <a:lnSpc>
+                <a:spcPct val="110000"/>
+              </a:lnSpc>
+            </a:pPr>
+            <a:r>
+              <a:rPr sz="1050" b="0" i="0">
+                <a:solidFill>
+                  <a:srgbClr val="1F2937"/>
+                </a:solidFill>
+                <a:latin typeface="Calibri"/>
+              </a:rPr>
+              <a:t>悪用が知られた脆弱ドライバの読み込み (LOLDrivers 照合)</a:t>
+            </a:r>
+          </a:p>
+        </p:txBody>
+      </p:sp>
+      <p:sp>
+        <p:nvSpPr>
+          <p:cNvPr id="20" name="Rounded Rectangle 19"/>
+          <p:cNvSpPr/>
+          <p:nvPr/>
+        </p:nvSpPr>
+        <p:spPr>
+          <a:xfrm>
+            <a:off x="6291072" y="1783080"/>
+            <a:ext cx="5349240" cy="2240280"/>
+          </a:xfrm>
+          <a:prstGeom prst="roundRect">
+            <a:avLst/>
+          </a:prstGeom>
+          <a:solidFill>
+            <a:srgbClr val="FFFFFF"/>
+          </a:solidFill>
+          <a:ln w="9525">
+            <a:solidFill>
+              <a:srgbClr val="DDE3EE"/>
+            </a:solidFill>
+          </a:ln>
+          <a:effectLst/>
+        </p:spPr>
+        <p:style>
+          <a:lnRef idx="1">
+            <a:schemeClr val="accent1"/>
+          </a:lnRef>
+          <a:fillRef idx="3">
+            <a:schemeClr val="accent1"/>
+          </a:fillRef>
+          <a:effectRef idx="2">
+            <a:schemeClr val="accent1"/>
+          </a:effectRef>
+          <a:fontRef idx="minor">
+            <a:schemeClr val="lt1"/>
+          </a:fontRef>
+        </p:style>
+        <p:txBody>
+          <a:bodyPr rtlCol="0" anchor="ctr"/>
+          <a:lstStyle/>
+          <a:p>
+            <a:pPr algn="ctr"/>
+          </a:p>
+        </p:txBody>
+      </p:sp>
+      <p:sp>
+        <p:nvSpPr>
+          <p:cNvPr id="21" name="Rectangle 20"/>
+          <p:cNvSpPr/>
+          <p:nvPr/>
+        </p:nvSpPr>
+        <p:spPr>
+          <a:xfrm>
+            <a:off x="6291072" y="1783080"/>
+            <a:ext cx="73152" cy="2240280"/>
+          </a:xfrm>
+          <a:prstGeom prst="rect">
+            <a:avLst/>
+          </a:prstGeom>
+          <a:solidFill>
+            <a:srgbClr val="2563EB"/>
+          </a:solidFill>
+          <a:ln>
+            <a:noFill/>
+          </a:ln>
+          <a:effectLst/>
+        </p:spPr>
+        <p:style>
+          <a:lnRef idx="1">
+            <a:schemeClr val="accent1"/>
+          </a:lnRef>
+          <a:fillRef idx="3">
+            <a:schemeClr val="accent1"/>
+          </a:fillRef>
+          <a:effectRef idx="2">
+            <a:schemeClr val="accent1"/>
+          </a:effectRef>
+          <a:fontRef idx="minor">
+            <a:schemeClr val="lt1"/>
+          </a:fontRef>
+        </p:style>
+        <p:txBody>
+          <a:bodyPr rtlCol="0" anchor="ctr"/>
+          <a:lstStyle/>
+          <a:p>
+            <a:pPr algn="ctr"/>
+          </a:p>
+        </p:txBody>
+      </p:sp>
+      <p:sp>
+        <p:nvSpPr>
+          <p:cNvPr id="22" name="TextBox 21"/>
+          <p:cNvSpPr txBox="1"/>
+          <p:nvPr/>
+        </p:nvSpPr>
+        <p:spPr>
+          <a:xfrm>
+            <a:off x="6547104" y="1929384"/>
+            <a:ext cx="4937759" cy="411480"/>
+          </a:xfrm>
+          <a:prstGeom prst="rect">
+            <a:avLst/>
+          </a:prstGeom>
+          <a:noFill/>
+        </p:spPr>
+        <p:txBody>
+          <a:bodyPr wrap="square" lIns="0" rIns="0" tIns="0" bIns="0" anchor="t">
+            <a:spAutoFit/>
+          </a:bodyPr>
+          <a:lstStyle/>
+          <a:p>
+            <a:pPr algn="l">
+              <a:lnSpc>
+                <a:spcPct val="130000"/>
+              </a:lnSpc>
+            </a:pPr>
+            <a:r>
+              <a:rPr sz="1400" b="1" i="0">
+                <a:solidFill>
+                  <a:srgbClr val="1D4ED8"/>
+                </a:solidFill>
+                <a:latin typeface="Cambria"/>
+              </a:rPr>
+              <a:t>② 盗む・住み着く</a:t>
+            </a:r>
+          </a:p>
+        </p:txBody>
+      </p:sp>
+      <p:sp>
+        <p:nvSpPr>
+          <p:cNvPr id="23" name="Oval 22"/>
+          <p:cNvSpPr/>
+          <p:nvPr/>
+        </p:nvSpPr>
+        <p:spPr>
+          <a:xfrm>
+            <a:off x="6565392" y="2505456"/>
+            <a:ext cx="109728" cy="109728"/>
+          </a:xfrm>
+          <a:prstGeom prst="ellipse">
+            <a:avLst/>
+          </a:prstGeom>
+          <a:solidFill>
+            <a:srgbClr val="DC2626"/>
+          </a:solidFill>
+          <a:ln>
+            <a:noFill/>
+          </a:ln>
+          <a:effectLst/>
+        </p:spPr>
+        <p:style>
+          <a:lnRef idx="1">
+            <a:schemeClr val="accent1"/>
+          </a:lnRef>
+          <a:fillRef idx="3">
+            <a:schemeClr val="accent1"/>
+          </a:fillRef>
+          <a:effectRef idx="2">
+            <a:schemeClr val="accent1"/>
+          </a:effectRef>
+          <a:fontRef idx="minor">
+            <a:schemeClr val="lt1"/>
+          </a:fontRef>
+        </p:style>
+        <p:txBody>
+          <a:bodyPr rtlCol="0" anchor="ctr"/>
+          <a:lstStyle/>
+          <a:p>
+            <a:pPr algn="ctr"/>
+          </a:p>
+        </p:txBody>
+      </p:sp>
+      <p:sp>
+        <p:nvSpPr>
+          <p:cNvPr id="24" name="TextBox 23"/>
+          <p:cNvSpPr txBox="1"/>
+          <p:nvPr/>
+        </p:nvSpPr>
+        <p:spPr>
+          <a:xfrm>
+            <a:off x="6784848" y="2441448"/>
+            <a:ext cx="4636007" cy="365760"/>
+          </a:xfrm>
+          <a:prstGeom prst="rect">
+            <a:avLst/>
+          </a:prstGeom>
+          <a:noFill/>
+        </p:spPr>
+        <p:txBody>
+          <a:bodyPr wrap="square" lIns="0" rIns="0" tIns="0" bIns="0" anchor="t">
+            <a:spAutoFit/>
+          </a:bodyPr>
+          <a:lstStyle/>
+          <a:p>
+            <a:pPr algn="l">
+              <a:lnSpc>
+                <a:spcPct val="110000"/>
+              </a:lnSpc>
+            </a:pPr>
+            <a:r>
+              <a:rPr sz="1050" b="0" i="0">
+                <a:solidFill>
+                  <a:srgbClr val="1F2937"/>
+                </a:solidFill>
+                <a:latin typeface="Calibri"/>
+              </a:rPr>
+              <a:t>ログイン情報の抜き取り (LSASS のメモリダンプ)</a:t>
+            </a:r>
+          </a:p>
+        </p:txBody>
+      </p:sp>
+      <p:sp>
+        <p:nvSpPr>
+          <p:cNvPr id="25" name="Oval 24"/>
+          <p:cNvSpPr/>
+          <p:nvPr/>
+        </p:nvSpPr>
+        <p:spPr>
+          <a:xfrm>
+            <a:off x="6565392" y="2889503"/>
+            <a:ext cx="109728" cy="109728"/>
+          </a:xfrm>
+          <a:prstGeom prst="ellipse">
+            <a:avLst/>
+          </a:prstGeom>
+          <a:solidFill>
+            <a:srgbClr val="EA580C"/>
+          </a:solidFill>
+          <a:ln>
+            <a:noFill/>
+          </a:ln>
+          <a:effectLst/>
+        </p:spPr>
+        <p:style>
+          <a:lnRef idx="1">
+            <a:schemeClr val="accent1"/>
+          </a:lnRef>
+          <a:fillRef idx="3">
+            <a:schemeClr val="accent1"/>
+          </a:fillRef>
+          <a:effectRef idx="2">
+            <a:schemeClr val="accent1"/>
+          </a:effectRef>
+          <a:fontRef idx="minor">
+            <a:schemeClr val="lt1"/>
+          </a:fontRef>
+        </p:style>
+        <p:txBody>
+          <a:bodyPr rtlCol="0" anchor="ctr"/>
+          <a:lstStyle/>
+          <a:p>
+            <a:pPr algn="ctr"/>
+          </a:p>
+        </p:txBody>
+      </p:sp>
+      <p:sp>
+        <p:nvSpPr>
+          <p:cNvPr id="26" name="TextBox 25"/>
+          <p:cNvSpPr txBox="1"/>
+          <p:nvPr/>
+        </p:nvSpPr>
+        <p:spPr>
+          <a:xfrm>
+            <a:off x="6784848" y="2825496"/>
+            <a:ext cx="4636007" cy="365760"/>
+          </a:xfrm>
+          <a:prstGeom prst="rect">
+            <a:avLst/>
+          </a:prstGeom>
+          <a:noFill/>
+        </p:spPr>
+        <p:txBody>
+          <a:bodyPr wrap="square" lIns="0" rIns="0" tIns="0" bIns="0" anchor="t">
+            <a:spAutoFit/>
+          </a:bodyPr>
+          <a:lstStyle/>
+          <a:p>
+            <a:pPr algn="l">
+              <a:lnSpc>
+                <a:spcPct val="110000"/>
+              </a:lnSpc>
+            </a:pPr>
+            <a:r>
+              <a:rPr sz="1050" b="0" i="0">
+                <a:solidFill>
+                  <a:srgbClr val="1F2937"/>
+                </a:solidFill>
+                <a:latin typeface="Calibri"/>
+              </a:rPr>
+              <a:t>書き換え可能な場所のプログラムをサービス登録して常駐</a:t>
+            </a:r>
+          </a:p>
+        </p:txBody>
+      </p:sp>
+      <p:sp>
+        <p:nvSpPr>
+          <p:cNvPr id="27" name="Oval 26"/>
+          <p:cNvSpPr/>
+          <p:nvPr/>
+        </p:nvSpPr>
+        <p:spPr>
+          <a:xfrm>
+            <a:off x="6565392" y="3273551"/>
+            <a:ext cx="109728" cy="109728"/>
+          </a:xfrm>
+          <a:prstGeom prst="ellipse">
+            <a:avLst/>
+          </a:prstGeom>
+          <a:solidFill>
+            <a:srgbClr val="EA580C"/>
+          </a:solidFill>
+          <a:ln>
+            <a:noFill/>
+          </a:ln>
+          <a:effectLst/>
+        </p:spPr>
+        <p:style>
+          <a:lnRef idx="1">
+            <a:schemeClr val="accent1"/>
+          </a:lnRef>
+          <a:fillRef idx="3">
+            <a:schemeClr val="accent1"/>
+          </a:fillRef>
+          <a:effectRef idx="2">
+            <a:schemeClr val="accent1"/>
+          </a:effectRef>
+          <a:fontRef idx="minor">
+            <a:schemeClr val="lt1"/>
+          </a:fontRef>
+        </p:style>
+        <p:txBody>
+          <a:bodyPr rtlCol="0" anchor="ctr"/>
+          <a:lstStyle/>
+          <a:p>
+            <a:pPr algn="ctr"/>
+          </a:p>
+        </p:txBody>
+      </p:sp>
+      <p:sp>
+        <p:nvSpPr>
+          <p:cNvPr id="28" name="TextBox 27"/>
+          <p:cNvSpPr txBox="1"/>
+          <p:nvPr/>
+        </p:nvSpPr>
+        <p:spPr>
+          <a:xfrm>
+            <a:off x="6784848" y="3209544"/>
+            <a:ext cx="4636007" cy="365760"/>
+          </a:xfrm>
+          <a:prstGeom prst="rect">
+            <a:avLst/>
+          </a:prstGeom>
+          <a:noFill/>
+        </p:spPr>
+        <p:txBody>
+          <a:bodyPr wrap="square" lIns="0" rIns="0" tIns="0" bIns="0" anchor="t">
+            <a:spAutoFit/>
+          </a:bodyPr>
+          <a:lstStyle/>
+          <a:p>
+            <a:pPr algn="l">
+              <a:lnSpc>
+                <a:spcPct val="110000"/>
+              </a:lnSpc>
+            </a:pPr>
+            <a:r>
+              <a:rPr sz="1050" b="0" i="0">
+                <a:solidFill>
+                  <a:srgbClr val="1F2937"/>
+                </a:solidFill>
+                <a:latin typeface="Calibri"/>
+              </a:rPr>
+              <a:t>WMI で「出来事をきっかけに自動起動」を仕込む</a:t>
+            </a:r>
+          </a:p>
+        </p:txBody>
+      </p:sp>
+      <p:sp>
+        <p:nvSpPr>
+          <p:cNvPr id="29" name="Rounded Rectangle 28"/>
+          <p:cNvSpPr/>
+          <p:nvPr/>
+        </p:nvSpPr>
+        <p:spPr>
+          <a:xfrm>
+            <a:off x="548640" y="4114800"/>
+            <a:ext cx="5349240" cy="2240280"/>
+          </a:xfrm>
+          <a:prstGeom prst="roundRect">
+            <a:avLst/>
+          </a:prstGeom>
+          <a:solidFill>
+            <a:srgbClr val="FFFFFF"/>
+          </a:solidFill>
+          <a:ln w="9525">
+            <a:solidFill>
+              <a:srgbClr val="DDE3EE"/>
+            </a:solidFill>
+          </a:ln>
+          <a:effectLst/>
+        </p:spPr>
+        <p:style>
+          <a:lnRef idx="1">
+            <a:schemeClr val="accent1"/>
+          </a:lnRef>
+          <a:fillRef idx="3">
+            <a:schemeClr val="accent1"/>
+          </a:fillRef>
+          <a:effectRef idx="2">
+            <a:schemeClr val="accent1"/>
+          </a:effectRef>
+          <a:fontRef idx="minor">
+            <a:schemeClr val="lt1"/>
+          </a:fontRef>
+        </p:style>
+        <p:txBody>
+          <a:bodyPr rtlCol="0" anchor="ctr"/>
+          <a:lstStyle/>
+          <a:p>
+            <a:pPr algn="ctr"/>
+          </a:p>
+        </p:txBody>
+      </p:sp>
+      <p:sp>
+        <p:nvSpPr>
+          <p:cNvPr id="30" name="Rectangle 29"/>
+          <p:cNvSpPr/>
+          <p:nvPr/>
+        </p:nvSpPr>
+        <p:spPr>
+          <a:xfrm>
+            <a:off x="548640" y="4114800"/>
+            <a:ext cx="73152" cy="2240280"/>
+          </a:xfrm>
+          <a:prstGeom prst="rect">
+            <a:avLst/>
+          </a:prstGeom>
+          <a:solidFill>
+            <a:srgbClr val="2563EB"/>
+          </a:solidFill>
+          <a:ln>
+            <a:noFill/>
+          </a:ln>
+          <a:effectLst/>
+        </p:spPr>
+        <p:style>
+          <a:lnRef idx="1">
+            <a:schemeClr val="accent1"/>
+          </a:lnRef>
+          <a:fillRef idx="3">
+            <a:schemeClr val="accent1"/>
+          </a:fillRef>
+          <a:effectRef idx="2">
+            <a:schemeClr val="accent1"/>
+          </a:effectRef>
+          <a:fontRef idx="minor">
+            <a:schemeClr val="lt1"/>
+          </a:fontRef>
+        </p:style>
+        <p:txBody>
+          <a:bodyPr rtlCol="0" anchor="ctr"/>
+          <a:lstStyle/>
+          <a:p>
+            <a:pPr algn="ctr"/>
+          </a:p>
+        </p:txBody>
+      </p:sp>
+      <p:sp>
+        <p:nvSpPr>
+          <p:cNvPr id="31" name="TextBox 30"/>
+          <p:cNvSpPr txBox="1"/>
+          <p:nvPr/>
+        </p:nvSpPr>
+        <p:spPr>
+          <a:xfrm>
+            <a:off x="804672" y="4261104"/>
+            <a:ext cx="4937759" cy="411480"/>
+          </a:xfrm>
+          <a:prstGeom prst="rect">
+            <a:avLst/>
+          </a:prstGeom>
+          <a:noFill/>
+        </p:spPr>
+        <p:txBody>
+          <a:bodyPr wrap="square" lIns="0" rIns="0" tIns="0" bIns="0" anchor="t">
+            <a:spAutoFit/>
+          </a:bodyPr>
+          <a:lstStyle/>
+          <a:p>
+            <a:pPr algn="l">
+              <a:lnSpc>
+                <a:spcPct val="130000"/>
+              </a:lnSpc>
+            </a:pPr>
+            <a:r>
+              <a:rPr sz="1400" b="1" i="0">
+                <a:solidFill>
+                  <a:srgbClr val="1D4ED8"/>
+                </a:solidFill>
+                <a:latin typeface="Cambria"/>
+              </a:rPr>
+              <a:t>③ 監視を無力化する</a:t>
+            </a:r>
+          </a:p>
+        </p:txBody>
+      </p:sp>
+      <p:sp>
+        <p:nvSpPr>
+          <p:cNvPr id="32" name="Oval 31"/>
+          <p:cNvSpPr/>
+          <p:nvPr/>
+        </p:nvSpPr>
+        <p:spPr>
+          <a:xfrm>
+            <a:off x="822959" y="4837176"/>
+            <a:ext cx="109728" cy="109728"/>
+          </a:xfrm>
+          <a:prstGeom prst="ellipse">
+            <a:avLst/>
+          </a:prstGeom>
+          <a:solidFill>
+            <a:srgbClr val="EA580C"/>
+          </a:solidFill>
+          <a:ln>
+            <a:noFill/>
+          </a:ln>
+          <a:effectLst/>
+        </p:spPr>
+        <p:style>
+          <a:lnRef idx="1">
+            <a:schemeClr val="accent1"/>
+          </a:lnRef>
+          <a:fillRef idx="3">
+            <a:schemeClr val="accent1"/>
+          </a:fillRef>
+          <a:effectRef idx="2">
+            <a:schemeClr val="accent1"/>
+          </a:effectRef>
+          <a:fontRef idx="minor">
+            <a:schemeClr val="lt1"/>
+          </a:fontRef>
+        </p:style>
+        <p:txBody>
+          <a:bodyPr rtlCol="0" anchor="ctr"/>
+          <a:lstStyle/>
+          <a:p>
+            <a:pPr algn="ctr"/>
+          </a:p>
+        </p:txBody>
+      </p:sp>
+      <p:sp>
+        <p:nvSpPr>
+          <p:cNvPr id="33" name="TextBox 32"/>
+          <p:cNvSpPr txBox="1"/>
+          <p:nvPr/>
+        </p:nvSpPr>
+        <p:spPr>
+          <a:xfrm>
+            <a:off x="1042416" y="4773168"/>
+            <a:ext cx="4636007" cy="365760"/>
+          </a:xfrm>
+          <a:prstGeom prst="rect">
+            <a:avLst/>
+          </a:prstGeom>
+          <a:noFill/>
+        </p:spPr>
+        <p:txBody>
+          <a:bodyPr wrap="square" lIns="0" rIns="0" tIns="0" bIns="0" anchor="t">
+            <a:spAutoFit/>
+          </a:bodyPr>
+          <a:lstStyle/>
+          <a:p>
+            <a:pPr algn="l">
+              <a:lnSpc>
+                <a:spcPct val="110000"/>
+              </a:lnSpc>
+            </a:pPr>
+            <a:r>
+              <a:rPr sz="1050" b="0" i="0">
+                <a:solidFill>
+                  <a:srgbClr val="1F2937"/>
+                </a:solidFill>
+                <a:latin typeface="Calibri"/>
+              </a:rPr>
+              <a:t>PowerShell のウイルス検査 (AMSI) を無力化</a:t>
+            </a:r>
+          </a:p>
+        </p:txBody>
+      </p:sp>
+      <p:sp>
+        <p:nvSpPr>
+          <p:cNvPr id="34" name="Oval 33"/>
+          <p:cNvSpPr/>
+          <p:nvPr/>
+        </p:nvSpPr>
+        <p:spPr>
+          <a:xfrm>
+            <a:off x="822959" y="5221224"/>
+            <a:ext cx="109728" cy="109728"/>
+          </a:xfrm>
+          <a:prstGeom prst="ellipse">
+            <a:avLst/>
+          </a:prstGeom>
+          <a:solidFill>
+            <a:srgbClr val="DC2626"/>
+          </a:solidFill>
+          <a:ln>
+            <a:noFill/>
+          </a:ln>
+          <a:effectLst/>
+        </p:spPr>
+        <p:style>
+          <a:lnRef idx="1">
+            <a:schemeClr val="accent1"/>
+          </a:lnRef>
+          <a:fillRef idx="3">
+            <a:schemeClr val="accent1"/>
+          </a:fillRef>
+          <a:effectRef idx="2">
+            <a:schemeClr val="accent1"/>
+          </a:effectRef>
+          <a:fontRef idx="minor">
+            <a:schemeClr val="lt1"/>
+          </a:fontRef>
+        </p:style>
+        <p:txBody>
+          <a:bodyPr rtlCol="0" anchor="ctr"/>
+          <a:lstStyle/>
+          <a:p>
+            <a:pPr algn="ctr"/>
+          </a:p>
+        </p:txBody>
+      </p:sp>
+      <p:sp>
+        <p:nvSpPr>
+          <p:cNvPr id="35" name="TextBox 34"/>
+          <p:cNvSpPr txBox="1"/>
+          <p:nvPr/>
+        </p:nvSpPr>
+        <p:spPr>
+          <a:xfrm>
+            <a:off x="1042416" y="5157216"/>
+            <a:ext cx="4636007" cy="365760"/>
+          </a:xfrm>
+          <a:prstGeom prst="rect">
+            <a:avLst/>
+          </a:prstGeom>
+          <a:noFill/>
+        </p:spPr>
+        <p:txBody>
+          <a:bodyPr wrap="square" lIns="0" rIns="0" tIns="0" bIns="0" anchor="t">
+            <a:spAutoFit/>
+          </a:bodyPr>
+          <a:lstStyle/>
+          <a:p>
+            <a:pPr algn="l">
+              <a:lnSpc>
+                <a:spcPct val="110000"/>
+              </a:lnSpc>
+            </a:pPr>
+            <a:r>
+              <a:rPr sz="1050" b="0" i="0">
+                <a:solidFill>
+                  <a:srgbClr val="1F2937"/>
+                </a:solidFill>
+                <a:latin typeface="Calibri"/>
+              </a:rPr>
+              <a:t>ログ記録サービスそのものを停止・無効化</a:t>
+            </a:r>
+          </a:p>
+        </p:txBody>
+      </p:sp>
+      <p:sp>
+        <p:nvSpPr>
+          <p:cNvPr id="36" name="Oval 35"/>
+          <p:cNvSpPr/>
+          <p:nvPr/>
+        </p:nvSpPr>
+        <p:spPr>
+          <a:xfrm>
+            <a:off x="822959" y="5605272"/>
+            <a:ext cx="109728" cy="109728"/>
+          </a:xfrm>
+          <a:prstGeom prst="ellipse">
+            <a:avLst/>
+          </a:prstGeom>
+          <a:solidFill>
+            <a:srgbClr val="EA580C"/>
+          </a:solidFill>
+          <a:ln>
+            <a:noFill/>
+          </a:ln>
+          <a:effectLst/>
+        </p:spPr>
+        <p:style>
+          <a:lnRef idx="1">
+            <a:schemeClr val="accent1"/>
+          </a:lnRef>
+          <a:fillRef idx="3">
+            <a:schemeClr val="accent1"/>
+          </a:fillRef>
+          <a:effectRef idx="2">
+            <a:schemeClr val="accent1"/>
+          </a:effectRef>
+          <a:fontRef idx="minor">
+            <a:schemeClr val="lt1"/>
+          </a:fontRef>
+        </p:style>
+        <p:txBody>
+          <a:bodyPr rtlCol="0" anchor="ctr"/>
+          <a:lstStyle/>
+          <a:p>
+            <a:pPr algn="ctr"/>
+          </a:p>
+        </p:txBody>
+      </p:sp>
+      <p:sp>
+        <p:nvSpPr>
+          <p:cNvPr id="37" name="TextBox 36"/>
+          <p:cNvSpPr txBox="1"/>
+          <p:nvPr/>
+        </p:nvSpPr>
+        <p:spPr>
+          <a:xfrm>
+            <a:off x="1042416" y="5541264"/>
+            <a:ext cx="4636007" cy="365760"/>
+          </a:xfrm>
+          <a:prstGeom prst="rect">
+            <a:avLst/>
+          </a:prstGeom>
+          <a:noFill/>
+        </p:spPr>
+        <p:txBody>
+          <a:bodyPr wrap="square" lIns="0" rIns="0" tIns="0" bIns="0" anchor="t">
+            <a:spAutoFit/>
+          </a:bodyPr>
+          <a:lstStyle/>
+          <a:p>
+            <a:pPr algn="l">
+              <a:lnSpc>
+                <a:spcPct val="110000"/>
+              </a:lnSpc>
+            </a:pPr>
+            <a:r>
+              <a:rPr sz="1050" b="0" i="0">
+                <a:solidFill>
+                  <a:srgbClr val="1F2937"/>
+                </a:solidFill>
+                <a:latin typeface="Calibri"/>
+              </a:rPr>
+              <a:t>監査設定から記録項目を外して “見えなく” する</a:t>
+            </a:r>
+          </a:p>
+        </p:txBody>
+      </p:sp>
+      <p:sp>
+        <p:nvSpPr>
+          <p:cNvPr id="38" name="Rounded Rectangle 37"/>
+          <p:cNvSpPr/>
+          <p:nvPr/>
+        </p:nvSpPr>
+        <p:spPr>
+          <a:xfrm>
+            <a:off x="6291072" y="4114800"/>
+            <a:ext cx="5349240" cy="2240280"/>
+          </a:xfrm>
+          <a:prstGeom prst="roundRect">
+            <a:avLst/>
+          </a:prstGeom>
+          <a:solidFill>
+            <a:srgbClr val="FFFFFF"/>
+          </a:solidFill>
+          <a:ln w="9525">
+            <a:solidFill>
+              <a:srgbClr val="DDE3EE"/>
+            </a:solidFill>
+          </a:ln>
+          <a:effectLst/>
+        </p:spPr>
+        <p:style>
+          <a:lnRef idx="1">
+            <a:schemeClr val="accent1"/>
+          </a:lnRef>
+          <a:fillRef idx="3">
+            <a:schemeClr val="accent1"/>
+          </a:fillRef>
+          <a:effectRef idx="2">
+            <a:schemeClr val="accent1"/>
+          </a:effectRef>
+          <a:fontRef idx="minor">
+            <a:schemeClr val="lt1"/>
+          </a:fontRef>
+        </p:style>
+        <p:txBody>
+          <a:bodyPr rtlCol="0" anchor="ctr"/>
+          <a:lstStyle/>
+          <a:p>
+            <a:pPr algn="ctr"/>
+          </a:p>
+        </p:txBody>
+      </p:sp>
+      <p:sp>
+        <p:nvSpPr>
+          <p:cNvPr id="39" name="Rectangle 38"/>
+          <p:cNvSpPr/>
+          <p:nvPr/>
+        </p:nvSpPr>
+        <p:spPr>
+          <a:xfrm>
+            <a:off x="6291072" y="4114800"/>
+            <a:ext cx="73152" cy="2240280"/>
+          </a:xfrm>
+          <a:prstGeom prst="rect">
+            <a:avLst/>
+          </a:prstGeom>
+          <a:solidFill>
+            <a:srgbClr val="2563EB"/>
+          </a:solidFill>
+          <a:ln>
+            <a:noFill/>
+          </a:ln>
+          <a:effectLst/>
+        </p:spPr>
+        <p:style>
+          <a:lnRef idx="1">
+            <a:schemeClr val="accent1"/>
+          </a:lnRef>
+          <a:fillRef idx="3">
+            <a:schemeClr val="accent1"/>
+          </a:fillRef>
+          <a:effectRef idx="2">
+            <a:schemeClr val="accent1"/>
+          </a:effectRef>
+          <a:fontRef idx="minor">
+            <a:schemeClr val="lt1"/>
+          </a:fontRef>
+        </p:style>
+        <p:txBody>
+          <a:bodyPr rtlCol="0" anchor="ctr"/>
+          <a:lstStyle/>
+          <a:p>
+            <a:pPr algn="ctr"/>
+          </a:p>
+        </p:txBody>
+      </p:sp>
+      <p:sp>
+        <p:nvSpPr>
+          <p:cNvPr id="40" name="TextBox 39"/>
+          <p:cNvSpPr txBox="1"/>
+          <p:nvPr/>
+        </p:nvSpPr>
+        <p:spPr>
+          <a:xfrm>
+            <a:off x="6547104" y="4261104"/>
+            <a:ext cx="4937759" cy="411480"/>
+          </a:xfrm>
+          <a:prstGeom prst="rect">
+            <a:avLst/>
+          </a:prstGeom>
+          <a:noFill/>
+        </p:spPr>
+        <p:txBody>
+          <a:bodyPr wrap="square" lIns="0" rIns="0" tIns="0" bIns="0" anchor="t">
+            <a:spAutoFit/>
+          </a:bodyPr>
+          <a:lstStyle/>
+          <a:p>
+            <a:pPr algn="l">
+              <a:lnSpc>
+                <a:spcPct val="130000"/>
+              </a:lnSpc>
+            </a:pPr>
+            <a:r>
+              <a:rPr sz="1400" b="1" i="0">
+                <a:solidFill>
+                  <a:srgbClr val="1D4ED8"/>
+                </a:solidFill>
+                <a:latin typeface="Cambria"/>
+              </a:rPr>
+              <a:t>④ 証拠を消す</a:t>
+            </a:r>
+          </a:p>
+        </p:txBody>
+      </p:sp>
+      <p:sp>
+        <p:nvSpPr>
+          <p:cNvPr id="41" name="Oval 40"/>
+          <p:cNvSpPr/>
+          <p:nvPr/>
+        </p:nvSpPr>
+        <p:spPr>
+          <a:xfrm>
+            <a:off x="6565392" y="4837176"/>
+            <a:ext cx="109728" cy="109728"/>
+          </a:xfrm>
+          <a:prstGeom prst="ellipse">
+            <a:avLst/>
+          </a:prstGeom>
+          <a:solidFill>
+            <a:srgbClr val="EA580C"/>
+          </a:solidFill>
+          <a:ln>
+            <a:noFill/>
+          </a:ln>
+          <a:effectLst/>
+        </p:spPr>
+        <p:style>
+          <a:lnRef idx="1">
+            <a:schemeClr val="accent1"/>
+          </a:lnRef>
+          <a:fillRef idx="3">
+            <a:schemeClr val="accent1"/>
+          </a:fillRef>
+          <a:effectRef idx="2">
+            <a:schemeClr val="accent1"/>
+          </a:effectRef>
+          <a:fontRef idx="minor">
+            <a:schemeClr val="lt1"/>
+          </a:fontRef>
+        </p:style>
+        <p:txBody>
+          <a:bodyPr rtlCol="0" anchor="ctr"/>
+          <a:lstStyle/>
+          <a:p>
+            <a:pPr algn="ctr"/>
+          </a:p>
+        </p:txBody>
+      </p:sp>
+      <p:sp>
+        <p:nvSpPr>
+          <p:cNvPr id="42" name="TextBox 41"/>
+          <p:cNvSpPr txBox="1"/>
+          <p:nvPr/>
+        </p:nvSpPr>
+        <p:spPr>
+          <a:xfrm>
+            <a:off x="6784848" y="4773168"/>
+            <a:ext cx="4636007" cy="365760"/>
+          </a:xfrm>
+          <a:prstGeom prst="rect">
+            <a:avLst/>
+          </a:prstGeom>
+          <a:noFill/>
+        </p:spPr>
+        <p:txBody>
+          <a:bodyPr wrap="square" lIns="0" rIns="0" tIns="0" bIns="0" anchor="t">
+            <a:spAutoFit/>
+          </a:bodyPr>
+          <a:lstStyle/>
+          <a:p>
+            <a:pPr algn="l">
+              <a:lnSpc>
+                <a:spcPct val="110000"/>
+              </a:lnSpc>
+            </a:pPr>
+            <a:r>
+              <a:rPr sz="1050" b="0" i="0">
+                <a:solidFill>
+                  <a:srgbClr val="1F2937"/>
+                </a:solidFill>
+                <a:latin typeface="Calibri"/>
+              </a:rPr>
+              <a:t>wevtutil などでイベントログをまるごと消去</a:t>
+            </a:r>
+          </a:p>
+        </p:txBody>
+      </p:sp>
+      <p:sp>
+        <p:nvSpPr>
+          <p:cNvPr id="43" name="Oval 42"/>
+          <p:cNvSpPr/>
+          <p:nvPr/>
+        </p:nvSpPr>
+        <p:spPr>
+          <a:xfrm>
+            <a:off x="6565392" y="5221224"/>
+            <a:ext cx="109728" cy="109728"/>
+          </a:xfrm>
+          <a:prstGeom prst="ellipse">
+            <a:avLst/>
+          </a:prstGeom>
+          <a:solidFill>
+            <a:srgbClr val="DC2626"/>
+          </a:solidFill>
+          <a:ln>
+            <a:noFill/>
+          </a:ln>
+          <a:effectLst/>
+        </p:spPr>
+        <p:style>
+          <a:lnRef idx="1">
+            <a:schemeClr val="accent1"/>
+          </a:lnRef>
+          <a:fillRef idx="3">
+            <a:schemeClr val="accent1"/>
+          </a:fillRef>
+          <a:effectRef idx="2">
+            <a:schemeClr val="accent1"/>
+          </a:effectRef>
+          <a:fontRef idx="minor">
+            <a:schemeClr val="lt1"/>
+          </a:fontRef>
+        </p:style>
+        <p:txBody>
+          <a:bodyPr rtlCol="0" anchor="ctr"/>
+          <a:lstStyle/>
+          <a:p>
+            <a:pPr algn="ctr"/>
+          </a:p>
+        </p:txBody>
+      </p:sp>
+      <p:sp>
+        <p:nvSpPr>
+          <p:cNvPr id="44" name="TextBox 43"/>
+          <p:cNvSpPr txBox="1"/>
+          <p:nvPr/>
+        </p:nvSpPr>
+        <p:spPr>
+          <a:xfrm>
+            <a:off x="6784848" y="5157216"/>
+            <a:ext cx="4636007" cy="365760"/>
+          </a:xfrm>
+          <a:prstGeom prst="rect">
+            <a:avLst/>
+          </a:prstGeom>
+          <a:noFill/>
+        </p:spPr>
+        <p:txBody>
+          <a:bodyPr wrap="square" lIns="0" rIns="0" tIns="0" bIns="0" anchor="t">
+            <a:spAutoFit/>
+          </a:bodyPr>
+          <a:lstStyle/>
+          <a:p>
+            <a:pPr algn="l">
+              <a:lnSpc>
+                <a:spcPct val="110000"/>
+              </a:lnSpc>
+            </a:pPr>
+            <a:r>
+              <a:rPr sz="1050" b="0" i="0">
+                <a:solidFill>
+                  <a:srgbClr val="1F2937"/>
+                </a:solidFill>
+                <a:latin typeface="Calibri"/>
+              </a:rPr>
+              <a:t>監査を変えた直後にログ消去、という “合わせ技”</a:t>
+            </a:r>
+          </a:p>
+        </p:txBody>
+      </p:sp>
+      <p:sp>
+        <p:nvSpPr>
+          <p:cNvPr id="45" name="Oval 44"/>
+          <p:cNvSpPr/>
+          <p:nvPr/>
+        </p:nvSpPr>
+        <p:spPr>
+          <a:xfrm>
+            <a:off x="6565392" y="5605272"/>
+            <a:ext cx="109728" cy="109728"/>
+          </a:xfrm>
+          <a:prstGeom prst="ellipse">
+            <a:avLst/>
+          </a:prstGeom>
+          <a:solidFill>
+            <a:srgbClr val="DC2626"/>
+          </a:solidFill>
+          <a:ln>
+            <a:noFill/>
+          </a:ln>
+          <a:effectLst/>
+        </p:spPr>
+        <p:style>
+          <a:lnRef idx="1">
+            <a:schemeClr val="accent1"/>
+          </a:lnRef>
+          <a:fillRef idx="3">
+            <a:schemeClr val="accent1"/>
+          </a:fillRef>
+          <a:effectRef idx="2">
+            <a:schemeClr val="accent1"/>
+          </a:effectRef>
+          <a:fontRef idx="minor">
+            <a:schemeClr val="lt1"/>
+          </a:fontRef>
+        </p:style>
+        <p:txBody>
+          <a:bodyPr rtlCol="0" anchor="ctr"/>
+          <a:lstStyle/>
+          <a:p>
+            <a:pPr algn="ctr"/>
+          </a:p>
+        </p:txBody>
+      </p:sp>
+      <p:sp>
+        <p:nvSpPr>
+          <p:cNvPr id="46" name="TextBox 45"/>
+          <p:cNvSpPr txBox="1"/>
+          <p:nvPr/>
+        </p:nvSpPr>
+        <p:spPr>
+          <a:xfrm>
+            <a:off x="6784848" y="5541264"/>
+            <a:ext cx="4636007" cy="365760"/>
+          </a:xfrm>
+          <a:prstGeom prst="rect">
+            <a:avLst/>
+          </a:prstGeom>
+          <a:noFill/>
+        </p:spPr>
+        <p:txBody>
+          <a:bodyPr wrap="square" lIns="0" rIns="0" tIns="0" bIns="0" anchor="t">
+            <a:spAutoFit/>
+          </a:bodyPr>
+          <a:lstStyle/>
+          <a:p>
+            <a:pPr algn="l">
+              <a:lnSpc>
+                <a:spcPct val="110000"/>
+              </a:lnSpc>
+            </a:pPr>
+            <a:r>
+              <a:rPr sz="1050" b="0" i="0">
+                <a:solidFill>
+                  <a:srgbClr val="1F2937"/>
+                </a:solidFill>
+                <a:latin typeface="Calibri"/>
+              </a:rPr>
+              <a:t>復元用スナップショットの削除 (ランサムの前兆)</a:t>
+            </a:r>
+          </a:p>
+        </p:txBody>
+      </p:sp>
+      <p:sp>
+        <p:nvSpPr>
+          <p:cNvPr id="47" name="TextBox 46"/>
+          <p:cNvSpPr txBox="1"/>
+          <p:nvPr/>
+        </p:nvSpPr>
+        <p:spPr>
+          <a:xfrm>
+            <a:off x="10972800" y="6446520"/>
+            <a:ext cx="914400" cy="274320"/>
+          </a:xfrm>
+          <a:prstGeom prst="rect">
+            <a:avLst/>
+          </a:prstGeom>
+          <a:noFill/>
+        </p:spPr>
+        <p:txBody>
+          <a:bodyPr wrap="square" lIns="0" rIns="0" tIns="0" bIns="0" anchor="t">
+            <a:spAutoFit/>
+          </a:bodyPr>
+          <a:lstStyle/>
+          <a:p>
+            <a:pPr algn="r">
+              <a:lnSpc>
+                <a:spcPct val="130000"/>
+              </a:lnSpc>
+            </a:pPr>
+            <a:r>
+              <a:rPr sz="900" b="0" i="0">
+                <a:solidFill>
+                  <a:srgbClr val="5B6472"/>
+                </a:solidFill>
+                <a:latin typeface="Calibri"/>
+              </a:rPr>
+              <a:t>付録</a:t>
             </a:r>
           </a:p>
         </p:txBody>

</xml_diff>

<commit_message>
docs(slides): embed demo video into the demo slide (13)
slide_demo now embeds docs/demo/hayabusa-plus-demo.mp4 (poster = dashboard
screenshot) so it plays on click during the talk — a fallback if the live
demo misbehaves. Falls back to the text divider when the video is absent.
Speaker note updated to mention it. Deck pptx now ~1.7MB (video embedded).

Co-Authored-By: Claude Fable 5 <noreply@anthropic.com>
</commit_message>
<xml_diff>
--- a/docs/presentation/pptx/hayabusa-plus.pptx
+++ b/docs/presentation/pptx/hayabusa-plus.pptx
@@ -848,6 +848,11 @@
           <a:p>
             <a:r>
               <a:t>(デモ: スキャン実行 → ダッシュボードで全体把握 → 検知の日本語解説 → ホスト別の危険度ランキング、の順に見せる)</a:t>
+            </a:r>
+          </a:p>
+          <a:p>
+            <a:r>
+              <a:t>※ ライブが不調なときは、スライド中央の動画をクリックすれば同じ流れの録画 (約 38 秒・字幕つき) が再生されます。</a:t>
             </a:r>
           </a:p>
         </p:txBody>
@@ -9245,8 +9250,8 @@
         </p:nvSpPr>
         <p:spPr>
           <a:xfrm>
-            <a:off x="548640" y="1737360"/>
-            <a:ext cx="10972800" cy="1463040"/>
+            <a:off x="548640" y="502920"/>
+            <a:ext cx="10972800" cy="822960"/>
           </a:xfrm>
           <a:prstGeom prst="rect">
             <a:avLst/>
@@ -9265,7 +9270,7 @@
               </a:lnSpc>
             </a:pPr>
             <a:r>
-              <a:rPr sz="11000" b="1" i="0">
+              <a:rPr sz="4400" b="1" i="0">
                 <a:solidFill>
                   <a:srgbClr val="FFFFFF"/>
                 </a:solidFill>
@@ -9276,16 +9281,54 @@
           </a:p>
         </p:txBody>
       </p:sp>
-      <p:sp>
-        <p:nvSpPr>
-          <p:cNvPr id="4" name="TextBox 3"/>
-          <p:cNvSpPr txBox="1"/>
-          <p:nvPr/>
-        </p:nvSpPr>
-        <p:spPr>
-          <a:xfrm>
-            <a:off x="548640" y="3977639"/>
-            <a:ext cx="10972800" cy="548640"/>
+      <p:pic>
+        <p:nvPicPr>
+          <p:cNvPr id="4" name="hayabusa-plus-demo.mp4">
+            <a:hlinkClick r:id="" action="ppaction://media"/>
+          </p:cNvPr>
+          <p:cNvPicPr>
+            <a:picLocks noChangeAspect="1"/>
+          </p:cNvPicPr>
+          <p:nvPr>
+            <a:videoFile r:link="rId3"/>
+            <p:extLst>
+              <p:ext uri="{DAA4B4D4-6D71-4841-9C94-3DE7FCFB9230}">
+                <p14:media xmlns:p14="http://schemas.microsoft.com/office/powerpoint/2010/main" r:embed="rId2"/>
+              </p:ext>
+            </p:extLst>
+          </p:nvPr>
+        </p:nvPicPr>
+        <p:blipFill>
+          <a:blip r:embed="rId4"/>
+          <a:stretch>
+            <a:fillRect/>
+          </a:stretch>
+        </p:blipFill>
+        <p:spPr>
+          <a:xfrm>
+            <a:off x="2255367" y="1417320"/>
+            <a:ext cx="7680960" cy="4320540"/>
+          </a:xfrm>
+          <a:prstGeom prst="rect">
+            <a:avLst/>
+          </a:prstGeom>
+          <a:ln w="12700">
+            <a:solidFill>
+              <a:srgbClr val="CADCFC"/>
+            </a:solidFill>
+          </a:ln>
+        </p:spPr>
+      </p:pic>
+      <p:sp>
+        <p:nvSpPr>
+          <p:cNvPr id="5" name="TextBox 4"/>
+          <p:cNvSpPr txBox="1"/>
+          <p:nvPr/>
+        </p:nvSpPr>
+        <p:spPr>
+          <a:xfrm>
+            <a:off x="548640" y="5943600"/>
+            <a:ext cx="10972800" cy="457200"/>
           </a:xfrm>
           <a:prstGeom prst="rect">
             <a:avLst/>
@@ -9304,52 +9347,13 @@
               </a:lnSpc>
             </a:pPr>
             <a:r>
-              <a:rPr sz="2400" b="0" i="1">
+              <a:rPr sz="1500" b="0" i="1">
                 <a:solidFill>
                   <a:srgbClr val="CADCFC"/>
                 </a:solidFill>
                 <a:latin typeface="Calibri"/>
               </a:rPr>
-              <a:t>実際の画面で動かしてみます</a:t>
-            </a:r>
-          </a:p>
-        </p:txBody>
-      </p:sp>
-      <p:sp>
-        <p:nvSpPr>
-          <p:cNvPr id="5" name="TextBox 4"/>
-          <p:cNvSpPr txBox="1"/>
-          <p:nvPr/>
-        </p:nvSpPr>
-        <p:spPr>
-          <a:xfrm>
-            <a:off x="548640" y="4709160"/>
-            <a:ext cx="10972800" cy="457200"/>
-          </a:xfrm>
-          <a:prstGeom prst="rect">
-            <a:avLst/>
-          </a:prstGeom>
-          <a:noFill/>
-        </p:spPr>
-        <p:txBody>
-          <a:bodyPr wrap="square" lIns="0" rIns="0" tIns="0" bIns="0" anchor="t">
-            <a:spAutoFit/>
-          </a:bodyPr>
-          <a:lstStyle/>
-          <a:p>
-            <a:pPr algn="ctr">
-              <a:lnSpc>
-                <a:spcPct val="130000"/>
-              </a:lnSpc>
-            </a:pPr>
-            <a:r>
-              <a:rPr sz="1500" b="0" i="0">
-                <a:solidFill>
-                  <a:srgbClr val="CADCFC"/>
-                </a:solidFill>
-                <a:latin typeface="Calibri"/>
-              </a:rPr>
-              <a:t>サンプルログを読み込み、調査の流れを見ていただきます。</a:t>
+              <a:t>▶ クリックで再生 — 実際の画面の録画 (約 38 秒・字幕つき)</a:t>
             </a:r>
           </a:p>
         </p:txBody>
@@ -9398,6 +9402,28 @@
   <p:clrMapOvr>
     <a:masterClrMapping/>
   </p:clrMapOvr>
+  <p:timing>
+    <p:tnLst>
+      <p:par>
+        <p:cTn id="1" dur="indefinite" restart="never" nodeType="tmRoot">
+          <p:childTnLst>
+            <p:video>
+              <p:cMediaNode vol="80000">
+                <p:cTn id="2" fill="hold" display="0">
+                  <p:stCondLst>
+                    <p:cond delay="indefinite"/>
+                  </p:stCondLst>
+                </p:cTn>
+                <p:tgtEl>
+                  <p:spTgt spid="4"/>
+                </p:tgtEl>
+              </p:cMediaNode>
+            </p:video>
+          </p:childTnLst>
+        </p:cTn>
+      </p:par>
+    </p:tnLst>
+  </p:timing>
 </p:sld>
 </file>
 

</xml_diff>

<commit_message>
docs(slides): add Q&A backup slides; de-emphasize GUI line count
Add three appendix Q&A slides for likely audience questions — positioning
vs upstream Hayabusa / SIEM / Sigma, accuracy+performance+IoC freshness,
and safety+zero-day+roadmap — each 3 Q&A cards, footer marked 付録 so the
main 1-15 numbering is untouched. Per request, stop emphasizing the GUI's
~8,000 line count: removed it from the title, overview, dev-GUI kicker,
summary stat card (now 'GUI / ゼロから開発'), and two speaker notes.

Co-Authored-By: Claude Fable 5 <noreply@anthropic.com>
</commit_message>
<xml_diff>
--- a/docs/presentation/pptx/hayabusa-plus.pptx
+++ b/docs/presentation/pptx/hayabusa-plus.pptx
@@ -21,6 +21,9 @@
     <p:sldId id="269" r:id="rId20"/>
     <p:sldId id="270" r:id="rId21"/>
     <p:sldId id="271" r:id="rId22"/>
+    <p:sldId id="272" r:id="rId23"/>
+    <p:sldId id="273" r:id="rId24"/>
+    <p:sldId id="274" r:id="rId25"/>
   </p:sldIdLst>
   <p:sldSz cx="12191695" cy="6858000" type="screen4x3"/>
   <p:notesSz cx="6858000" cy="9144000"/>
@@ -922,7 +925,7 @@
           <a:lstStyle/>
           <a:p>
             <a:r>
-              <a:t>まとめます。エンジンに lookup という新しい文法を追加し、検知ルールを 13 本自作、結果を読み解く GUI を約 8,000 行で開発し、悪いものリスト約 8 万件を自動で取り込んで照合できるようにしました。</a:t>
+              <a:t>まとめます。エンジンに lookup という新しい文法を追加し、検知ルールを 13 本自作、結果を読み解く GUI を新たに開発し、悪いものリスト約 8 万件を自動で取り込んで照合できるようにしました。</a:t>
             </a:r>
           </a:p>
           <a:p>
@@ -1467,7 +1470,7 @@
           </a:p>
           <a:p>
             <a:r>
-              <a:t>ログがエンジンで解析され、GUI を通して人が読む、という流れ。エンジンには中身を改造して新機能を追加し、下から「自作の検知ルール 13 本」と「悪いものリスト約 8 万件」を注ぎ込んでいます。GUI はゼロから約 8,000 行で作りました。</a:t>
+              <a:t>ログがエンジンで解析され、GUI を通して人が読む、という流れ。エンジンには中身を改造して新機能を追加し、下から「自作の検知ルール 13 本」と「悪いものリスト約 8 万件」を注ぎ込んでいます。GUI はゼロから自作しました。</a:t>
             </a:r>
           </a:p>
           <a:p>
@@ -5042,7 +5045,7 @@
                 </a:solidFill>
                 <a:latin typeface="Calibri"/>
               </a:rPr>
-              <a:t>🖥️ 結果を読み解ける GUI をゼロから開発 (約 8,000 行)</a:t>
+              <a:t>🖥️ 結果を読み解ける GUI をゼロから開発</a:t>
             </a:r>
           </a:p>
         </p:txBody>
@@ -6950,7 +6953,7 @@
                 </a:solidFill>
                 <a:latin typeface="Calibri"/>
               </a:rPr>
-              <a:t>開発内容 3 / 3   (Python + JavaScript 約 8,000 行)</a:t>
+              <a:t>開発内容 3 / 3   (Python + JavaScript)</a:t>
             </a:r>
           </a:p>
         </p:txBody>
@@ -10099,7 +10102,7 @@
                 </a:solidFill>
                 <a:latin typeface="Cambria"/>
               </a:rPr>
-              <a:t>約8,000</a:t>
+              <a:t>GUI</a:t>
             </a:r>
           </a:p>
         </p:txBody>
@@ -10138,7 +10141,7 @@
                 </a:solidFill>
                 <a:latin typeface="Cambria"/>
               </a:rPr>
-              <a:t>行</a:t>
+              <a:t>ゼロから開発</a:t>
             </a:r>
           </a:p>
         </p:txBody>
@@ -10177,8 +10180,8 @@
                 </a:solidFill>
                 <a:latin typeface="Calibri"/>
               </a:rPr>
-              <a:t>結果を読み解く GUI を
-ゼロから開発</a:t>
+              <a:t>結果を日本語で読み解く
+調査画面を自作</a:t>
             </a:r>
           </a:p>
         </p:txBody>
@@ -12844,6 +12847,2055 @@
 </p:sld>
 </file>
 
+<file path=ppt/slides/slide17.xml><?xml version="1.0" encoding="utf-8"?>
+<p:sld xmlns:a="http://schemas.openxmlformats.org/drawingml/2006/main" xmlns:p="http://schemas.openxmlformats.org/presentationml/2006/main" xmlns:r="http://schemas.openxmlformats.org/officeDocument/2006/relationships">
+  <p:cSld>
+    <p:spTree>
+      <p:nvGrpSpPr>
+        <p:cNvPr id="1" name=""/>
+        <p:cNvGrpSpPr/>
+        <p:nvPr/>
+      </p:nvGrpSpPr>
+      <p:grpSpPr/>
+      <p:sp>
+        <p:nvSpPr>
+          <p:cNvPr id="2" name="Rectangle 1"/>
+          <p:cNvSpPr/>
+          <p:nvPr/>
+        </p:nvSpPr>
+        <p:spPr>
+          <a:xfrm>
+            <a:off x="0" y="0"/>
+            <a:ext cx="12191695" cy="6858000"/>
+          </a:xfrm>
+          <a:prstGeom prst="rect">
+            <a:avLst/>
+          </a:prstGeom>
+          <a:solidFill>
+            <a:srgbClr val="F4F6FA"/>
+          </a:solidFill>
+          <a:ln>
+            <a:noFill/>
+          </a:ln>
+          <a:effectLst/>
+        </p:spPr>
+        <p:style>
+          <a:lnRef idx="1">
+            <a:schemeClr val="accent1"/>
+          </a:lnRef>
+          <a:fillRef idx="3">
+            <a:schemeClr val="accent1"/>
+          </a:fillRef>
+          <a:effectRef idx="2">
+            <a:schemeClr val="accent1"/>
+          </a:effectRef>
+          <a:fontRef idx="minor">
+            <a:schemeClr val="lt1"/>
+          </a:fontRef>
+        </p:style>
+        <p:txBody>
+          <a:bodyPr rtlCol="0" anchor="ctr"/>
+          <a:lstStyle/>
+          <a:p>
+            <a:pPr algn="ctr"/>
+          </a:p>
+        </p:txBody>
+      </p:sp>
+      <p:sp>
+        <p:nvSpPr>
+          <p:cNvPr id="3" name="TextBox 2"/>
+          <p:cNvSpPr txBox="1"/>
+          <p:nvPr/>
+        </p:nvSpPr>
+        <p:spPr>
+          <a:xfrm>
+            <a:off x="548640" y="347472"/>
+            <a:ext cx="10972800" cy="274320"/>
+          </a:xfrm>
+          <a:prstGeom prst="rect">
+            <a:avLst/>
+          </a:prstGeom>
+          <a:noFill/>
+        </p:spPr>
+        <p:txBody>
+          <a:bodyPr wrap="square" lIns="0" rIns="0" tIns="0" bIns="0" anchor="t">
+            <a:spAutoFit/>
+          </a:bodyPr>
+          <a:lstStyle/>
+          <a:p>
+            <a:pPr algn="l">
+              <a:lnSpc>
+                <a:spcPct val="130000"/>
+              </a:lnSpc>
+            </a:pPr>
+            <a:r>
+              <a:rPr sz="1100" b="1" i="0">
+                <a:solidFill>
+                  <a:srgbClr val="2563EB"/>
+                </a:solidFill>
+                <a:latin typeface="Calibri"/>
+              </a:rPr>
+              <a:t>付録 — 想定問答 (Q&amp;A)</a:t>
+            </a:r>
+          </a:p>
+        </p:txBody>
+      </p:sp>
+      <p:sp>
+        <p:nvSpPr>
+          <p:cNvPr id="4" name="TextBox 3"/>
+          <p:cNvSpPr txBox="1"/>
+          <p:nvPr/>
+        </p:nvSpPr>
+        <p:spPr>
+          <a:xfrm>
+            <a:off x="548640" y="621792"/>
+            <a:ext cx="11155680" cy="640080"/>
+          </a:xfrm>
+          <a:prstGeom prst="rect">
+            <a:avLst/>
+          </a:prstGeom>
+          <a:noFill/>
+        </p:spPr>
+        <p:txBody>
+          <a:bodyPr wrap="square" lIns="0" rIns="0" tIns="0" bIns="0" anchor="t">
+            <a:spAutoFit/>
+          </a:bodyPr>
+          <a:lstStyle/>
+          <a:p>
+            <a:pPr algn="l">
+              <a:lnSpc>
+                <a:spcPct val="130000"/>
+              </a:lnSpc>
+            </a:pPr>
+            <a:r>
+              <a:rPr sz="2800" b="1" i="0">
+                <a:solidFill>
+                  <a:srgbClr val="1F2937"/>
+                </a:solidFill>
+                <a:latin typeface="Cambria"/>
+              </a:rPr>
+              <a:t>よくある質問 ①  立ち位置・差分</a:t>
+            </a:r>
+          </a:p>
+        </p:txBody>
+      </p:sp>
+      <p:sp>
+        <p:nvSpPr>
+          <p:cNvPr id="5" name="Rounded Rectangle 4"/>
+          <p:cNvSpPr/>
+          <p:nvPr/>
+        </p:nvSpPr>
+        <p:spPr>
+          <a:xfrm>
+            <a:off x="548640" y="1783080"/>
+            <a:ext cx="11091672" cy="1386840"/>
+          </a:xfrm>
+          <a:prstGeom prst="roundRect">
+            <a:avLst/>
+          </a:prstGeom>
+          <a:solidFill>
+            <a:srgbClr val="FFFFFF"/>
+          </a:solidFill>
+          <a:ln w="9525">
+            <a:solidFill>
+              <a:srgbClr val="DDE3EE"/>
+            </a:solidFill>
+          </a:ln>
+          <a:effectLst/>
+        </p:spPr>
+        <p:style>
+          <a:lnRef idx="1">
+            <a:schemeClr val="accent1"/>
+          </a:lnRef>
+          <a:fillRef idx="3">
+            <a:schemeClr val="accent1"/>
+          </a:fillRef>
+          <a:effectRef idx="2">
+            <a:schemeClr val="accent1"/>
+          </a:effectRef>
+          <a:fontRef idx="minor">
+            <a:schemeClr val="lt1"/>
+          </a:fontRef>
+        </p:style>
+        <p:txBody>
+          <a:bodyPr rtlCol="0" anchor="ctr"/>
+          <a:lstStyle/>
+          <a:p>
+            <a:pPr algn="ctr"/>
+          </a:p>
+        </p:txBody>
+      </p:sp>
+      <p:sp>
+        <p:nvSpPr>
+          <p:cNvPr id="6" name="Rectangle 5"/>
+          <p:cNvSpPr/>
+          <p:nvPr/>
+        </p:nvSpPr>
+        <p:spPr>
+          <a:xfrm>
+            <a:off x="548640" y="1783080"/>
+            <a:ext cx="73152" cy="1386840"/>
+          </a:xfrm>
+          <a:prstGeom prst="rect">
+            <a:avLst/>
+          </a:prstGeom>
+          <a:solidFill>
+            <a:srgbClr val="2563EB"/>
+          </a:solidFill>
+          <a:ln>
+            <a:noFill/>
+          </a:ln>
+          <a:effectLst/>
+        </p:spPr>
+        <p:style>
+          <a:lnRef idx="1">
+            <a:schemeClr val="accent1"/>
+          </a:lnRef>
+          <a:fillRef idx="3">
+            <a:schemeClr val="accent1"/>
+          </a:fillRef>
+          <a:effectRef idx="2">
+            <a:schemeClr val="accent1"/>
+          </a:effectRef>
+          <a:fontRef idx="minor">
+            <a:schemeClr val="lt1"/>
+          </a:fontRef>
+        </p:style>
+        <p:txBody>
+          <a:bodyPr rtlCol="0" anchor="ctr"/>
+          <a:lstStyle/>
+          <a:p>
+            <a:pPr algn="ctr"/>
+          </a:p>
+        </p:txBody>
+      </p:sp>
+      <p:sp>
+        <p:nvSpPr>
+          <p:cNvPr id="7" name="TextBox 6"/>
+          <p:cNvSpPr txBox="1"/>
+          <p:nvPr/>
+        </p:nvSpPr>
+        <p:spPr>
+          <a:xfrm>
+            <a:off x="868680" y="1929384"/>
+            <a:ext cx="10515600" cy="457200"/>
+          </a:xfrm>
+          <a:prstGeom prst="rect">
+            <a:avLst/>
+          </a:prstGeom>
+          <a:noFill/>
+        </p:spPr>
+        <p:txBody>
+          <a:bodyPr wrap="square" lIns="0" rIns="0" tIns="0" bIns="0" anchor="t">
+            <a:spAutoFit/>
+          </a:bodyPr>
+          <a:lstStyle/>
+          <a:p>
+            <a:pPr algn="l">
+              <a:lnSpc>
+                <a:spcPct val="130000"/>
+              </a:lnSpc>
+            </a:pPr>
+            <a:r>
+              <a:rPr sz="1500" b="1" i="0">
+                <a:solidFill>
+                  <a:srgbClr val="1F2937"/>
+                </a:solidFill>
+                <a:latin typeface="Cambria"/>
+              </a:rPr>
+              <a:t>Q.  既存の Hayabusa と何が違うの?</a:t>
+            </a:r>
+          </a:p>
+        </p:txBody>
+      </p:sp>
+      <p:sp>
+        <p:nvSpPr>
+          <p:cNvPr id="8" name="TextBox 7"/>
+          <p:cNvSpPr txBox="1"/>
+          <p:nvPr/>
+        </p:nvSpPr>
+        <p:spPr>
+          <a:xfrm>
+            <a:off x="868680" y="2386584"/>
+            <a:ext cx="10469880" cy="673608"/>
+          </a:xfrm>
+          <a:prstGeom prst="rect">
+            <a:avLst/>
+          </a:prstGeom>
+          <a:noFill/>
+        </p:spPr>
+        <p:txBody>
+          <a:bodyPr wrap="square" lIns="0" rIns="0" tIns="0" bIns="0" anchor="t">
+            <a:spAutoFit/>
+          </a:bodyPr>
+          <a:lstStyle/>
+          <a:p>
+            <a:pPr algn="l">
+              <a:lnSpc>
+                <a:spcPct val="132000"/>
+              </a:lnSpc>
+            </a:pPr>
+            <a:r>
+              <a:rPr sz="1250" b="0" i="0">
+                <a:solidFill>
+                  <a:srgbClr val="5B6472"/>
+                </a:solidFill>
+                <a:latin typeface="Calibri"/>
+              </a:rPr>
+              <a:t>A.  検知エンジンに lookup 文法を追加し、攻撃を見抜くルールを 13 本自作。さらに結果を日本語で読み解く GUI、振る舞い分析、IoC の自動取り込みを足した。土台の検知力は活かしつつ「専門家でなくても使える形」にしたのが差分。</a:t>
+            </a:r>
+          </a:p>
+        </p:txBody>
+      </p:sp>
+      <p:sp>
+        <p:nvSpPr>
+          <p:cNvPr id="9" name="Rounded Rectangle 8"/>
+          <p:cNvSpPr/>
+          <p:nvPr/>
+        </p:nvSpPr>
+        <p:spPr>
+          <a:xfrm>
+            <a:off x="548640" y="3316224"/>
+            <a:ext cx="11091672" cy="1386840"/>
+          </a:xfrm>
+          <a:prstGeom prst="roundRect">
+            <a:avLst/>
+          </a:prstGeom>
+          <a:solidFill>
+            <a:srgbClr val="FFFFFF"/>
+          </a:solidFill>
+          <a:ln w="9525">
+            <a:solidFill>
+              <a:srgbClr val="DDE3EE"/>
+            </a:solidFill>
+          </a:ln>
+          <a:effectLst/>
+        </p:spPr>
+        <p:style>
+          <a:lnRef idx="1">
+            <a:schemeClr val="accent1"/>
+          </a:lnRef>
+          <a:fillRef idx="3">
+            <a:schemeClr val="accent1"/>
+          </a:fillRef>
+          <a:effectRef idx="2">
+            <a:schemeClr val="accent1"/>
+          </a:effectRef>
+          <a:fontRef idx="minor">
+            <a:schemeClr val="lt1"/>
+          </a:fontRef>
+        </p:style>
+        <p:txBody>
+          <a:bodyPr rtlCol="0" anchor="ctr"/>
+          <a:lstStyle/>
+          <a:p>
+            <a:pPr algn="ctr"/>
+          </a:p>
+        </p:txBody>
+      </p:sp>
+      <p:sp>
+        <p:nvSpPr>
+          <p:cNvPr id="10" name="Rectangle 9"/>
+          <p:cNvSpPr/>
+          <p:nvPr/>
+        </p:nvSpPr>
+        <p:spPr>
+          <a:xfrm>
+            <a:off x="548640" y="3316224"/>
+            <a:ext cx="73152" cy="1386840"/>
+          </a:xfrm>
+          <a:prstGeom prst="rect">
+            <a:avLst/>
+          </a:prstGeom>
+          <a:solidFill>
+            <a:srgbClr val="2563EB"/>
+          </a:solidFill>
+          <a:ln>
+            <a:noFill/>
+          </a:ln>
+          <a:effectLst/>
+        </p:spPr>
+        <p:style>
+          <a:lnRef idx="1">
+            <a:schemeClr val="accent1"/>
+          </a:lnRef>
+          <a:fillRef idx="3">
+            <a:schemeClr val="accent1"/>
+          </a:fillRef>
+          <a:effectRef idx="2">
+            <a:schemeClr val="accent1"/>
+          </a:effectRef>
+          <a:fontRef idx="minor">
+            <a:schemeClr val="lt1"/>
+          </a:fontRef>
+        </p:style>
+        <p:txBody>
+          <a:bodyPr rtlCol="0" anchor="ctr"/>
+          <a:lstStyle/>
+          <a:p>
+            <a:pPr algn="ctr"/>
+          </a:p>
+        </p:txBody>
+      </p:sp>
+      <p:sp>
+        <p:nvSpPr>
+          <p:cNvPr id="11" name="TextBox 10"/>
+          <p:cNvSpPr txBox="1"/>
+          <p:nvPr/>
+        </p:nvSpPr>
+        <p:spPr>
+          <a:xfrm>
+            <a:off x="868680" y="3462528"/>
+            <a:ext cx="10515600" cy="457200"/>
+          </a:xfrm>
+          <a:prstGeom prst="rect">
+            <a:avLst/>
+          </a:prstGeom>
+          <a:noFill/>
+        </p:spPr>
+        <p:txBody>
+          <a:bodyPr wrap="square" lIns="0" rIns="0" tIns="0" bIns="0" anchor="t">
+            <a:spAutoFit/>
+          </a:bodyPr>
+          <a:lstStyle/>
+          <a:p>
+            <a:pPr algn="l">
+              <a:lnSpc>
+                <a:spcPct val="130000"/>
+              </a:lnSpc>
+            </a:pPr>
+            <a:r>
+              <a:rPr sz="1500" b="1" i="0">
+                <a:solidFill>
+                  <a:srgbClr val="1F2937"/>
+                </a:solidFill>
+                <a:latin typeface="Cambria"/>
+              </a:rPr>
+              <a:t>Q.  SIEM や商用 EDR と何が違うの?</a:t>
+            </a:r>
+          </a:p>
+        </p:txBody>
+      </p:sp>
+      <p:sp>
+        <p:nvSpPr>
+          <p:cNvPr id="12" name="TextBox 11"/>
+          <p:cNvSpPr txBox="1"/>
+          <p:nvPr/>
+        </p:nvSpPr>
+        <p:spPr>
+          <a:xfrm>
+            <a:off x="868680" y="3919728"/>
+            <a:ext cx="10469880" cy="673608"/>
+          </a:xfrm>
+          <a:prstGeom prst="rect">
+            <a:avLst/>
+          </a:prstGeom>
+          <a:noFill/>
+        </p:spPr>
+        <p:txBody>
+          <a:bodyPr wrap="square" lIns="0" rIns="0" tIns="0" bIns="0" anchor="t">
+            <a:spAutoFit/>
+          </a:bodyPr>
+          <a:lstStyle/>
+          <a:p>
+            <a:pPr algn="l">
+              <a:lnSpc>
+                <a:spcPct val="132000"/>
+              </a:lnSpc>
+            </a:pPr>
+            <a:r>
+              <a:rPr sz="1250" b="0" i="0">
+                <a:solidFill>
+                  <a:srgbClr val="5B6472"/>
+                </a:solidFill>
+                <a:latin typeface="Calibri"/>
+              </a:rPr>
+              <a:t>A.  導入ゼロ・オフライン・無料で、PC 1 台に展開すればすぐ動く。大規模な常時監視ではなく「インシデント時に手元で素早く調べる」用途に振り切っている。</a:t>
+            </a:r>
+          </a:p>
+        </p:txBody>
+      </p:sp>
+      <p:sp>
+        <p:nvSpPr>
+          <p:cNvPr id="13" name="Rounded Rectangle 12"/>
+          <p:cNvSpPr/>
+          <p:nvPr/>
+        </p:nvSpPr>
+        <p:spPr>
+          <a:xfrm>
+            <a:off x="548640" y="4849368"/>
+            <a:ext cx="11091672" cy="1386840"/>
+          </a:xfrm>
+          <a:prstGeom prst="roundRect">
+            <a:avLst/>
+          </a:prstGeom>
+          <a:solidFill>
+            <a:srgbClr val="FFFFFF"/>
+          </a:solidFill>
+          <a:ln w="9525">
+            <a:solidFill>
+              <a:srgbClr val="DDE3EE"/>
+            </a:solidFill>
+          </a:ln>
+          <a:effectLst/>
+        </p:spPr>
+        <p:style>
+          <a:lnRef idx="1">
+            <a:schemeClr val="accent1"/>
+          </a:lnRef>
+          <a:fillRef idx="3">
+            <a:schemeClr val="accent1"/>
+          </a:fillRef>
+          <a:effectRef idx="2">
+            <a:schemeClr val="accent1"/>
+          </a:effectRef>
+          <a:fontRef idx="minor">
+            <a:schemeClr val="lt1"/>
+          </a:fontRef>
+        </p:style>
+        <p:txBody>
+          <a:bodyPr rtlCol="0" anchor="ctr"/>
+          <a:lstStyle/>
+          <a:p>
+            <a:pPr algn="ctr"/>
+          </a:p>
+        </p:txBody>
+      </p:sp>
+      <p:sp>
+        <p:nvSpPr>
+          <p:cNvPr id="14" name="Rectangle 13"/>
+          <p:cNvSpPr/>
+          <p:nvPr/>
+        </p:nvSpPr>
+        <p:spPr>
+          <a:xfrm>
+            <a:off x="548640" y="4849368"/>
+            <a:ext cx="73152" cy="1386840"/>
+          </a:xfrm>
+          <a:prstGeom prst="rect">
+            <a:avLst/>
+          </a:prstGeom>
+          <a:solidFill>
+            <a:srgbClr val="2563EB"/>
+          </a:solidFill>
+          <a:ln>
+            <a:noFill/>
+          </a:ln>
+          <a:effectLst/>
+        </p:spPr>
+        <p:style>
+          <a:lnRef idx="1">
+            <a:schemeClr val="accent1"/>
+          </a:lnRef>
+          <a:fillRef idx="3">
+            <a:schemeClr val="accent1"/>
+          </a:fillRef>
+          <a:effectRef idx="2">
+            <a:schemeClr val="accent1"/>
+          </a:effectRef>
+          <a:fontRef idx="minor">
+            <a:schemeClr val="lt1"/>
+          </a:fontRef>
+        </p:style>
+        <p:txBody>
+          <a:bodyPr rtlCol="0" anchor="ctr"/>
+          <a:lstStyle/>
+          <a:p>
+            <a:pPr algn="ctr"/>
+          </a:p>
+        </p:txBody>
+      </p:sp>
+      <p:sp>
+        <p:nvSpPr>
+          <p:cNvPr id="15" name="TextBox 14"/>
+          <p:cNvSpPr txBox="1"/>
+          <p:nvPr/>
+        </p:nvSpPr>
+        <p:spPr>
+          <a:xfrm>
+            <a:off x="868680" y="4995672"/>
+            <a:ext cx="10515600" cy="457200"/>
+          </a:xfrm>
+          <a:prstGeom prst="rect">
+            <a:avLst/>
+          </a:prstGeom>
+          <a:noFill/>
+        </p:spPr>
+        <p:txBody>
+          <a:bodyPr wrap="square" lIns="0" rIns="0" tIns="0" bIns="0" anchor="t">
+            <a:spAutoFit/>
+          </a:bodyPr>
+          <a:lstStyle/>
+          <a:p>
+            <a:pPr algn="l">
+              <a:lnSpc>
+                <a:spcPct val="130000"/>
+              </a:lnSpc>
+            </a:pPr>
+            <a:r>
+              <a:rPr sz="1500" b="1" i="0">
+                <a:solidFill>
+                  <a:srgbClr val="1F2937"/>
+                </a:solidFill>
+                <a:latin typeface="Cambria"/>
+              </a:rPr>
+              <a:t>Q.  Sigma ルールはそのまま使える? 独自拡張で互換は壊れない?</a:t>
+            </a:r>
+          </a:p>
+        </p:txBody>
+      </p:sp>
+      <p:sp>
+        <p:nvSpPr>
+          <p:cNvPr id="16" name="TextBox 15"/>
+          <p:cNvSpPr txBox="1"/>
+          <p:nvPr/>
+        </p:nvSpPr>
+        <p:spPr>
+          <a:xfrm>
+            <a:off x="868680" y="5452872"/>
+            <a:ext cx="10469880" cy="673608"/>
+          </a:xfrm>
+          <a:prstGeom prst="rect">
+            <a:avLst/>
+          </a:prstGeom>
+          <a:noFill/>
+        </p:spPr>
+        <p:txBody>
+          <a:bodyPr wrap="square" lIns="0" rIns="0" tIns="0" bIns="0" anchor="t">
+            <a:spAutoFit/>
+          </a:bodyPr>
+          <a:lstStyle/>
+          <a:p>
+            <a:pPr algn="l">
+              <a:lnSpc>
+                <a:spcPct val="132000"/>
+              </a:lnSpc>
+            </a:pPr>
+            <a:r>
+              <a:rPr sz="1250" b="0" i="0">
+                <a:solidFill>
+                  <a:srgbClr val="5B6472"/>
+                </a:solidFill>
+                <a:latin typeface="Calibri"/>
+              </a:rPr>
+              <a:t>A.  世界共通の Sigma 約 5,000 本に加え、自作 13 本が使える。lookup は独自拡張だが、上流の Hayabusa は知らない記法を無視するだけなので互換は壊れない。</a:t>
+            </a:r>
+          </a:p>
+        </p:txBody>
+      </p:sp>
+      <p:sp>
+        <p:nvSpPr>
+          <p:cNvPr id="17" name="TextBox 16"/>
+          <p:cNvSpPr txBox="1"/>
+          <p:nvPr/>
+        </p:nvSpPr>
+        <p:spPr>
+          <a:xfrm>
+            <a:off x="10972800" y="6446520"/>
+            <a:ext cx="914400" cy="274320"/>
+          </a:xfrm>
+          <a:prstGeom prst="rect">
+            <a:avLst/>
+          </a:prstGeom>
+          <a:noFill/>
+        </p:spPr>
+        <p:txBody>
+          <a:bodyPr wrap="square" lIns="0" rIns="0" tIns="0" bIns="0" anchor="t">
+            <a:spAutoFit/>
+          </a:bodyPr>
+          <a:lstStyle/>
+          <a:p>
+            <a:pPr algn="r">
+              <a:lnSpc>
+                <a:spcPct val="130000"/>
+              </a:lnSpc>
+            </a:pPr>
+            <a:r>
+              <a:rPr sz="900" b="0" i="0">
+                <a:solidFill>
+                  <a:srgbClr val="5B6472"/>
+                </a:solidFill>
+                <a:latin typeface="Calibri"/>
+              </a:rPr>
+              <a:t>付録</a:t>
+            </a:r>
+          </a:p>
+        </p:txBody>
+      </p:sp>
+    </p:spTree>
+  </p:cSld>
+  <p:clrMapOvr>
+    <a:masterClrMapping/>
+  </p:clrMapOvr>
+</p:sld>
+</file>
+
+<file path=ppt/slides/slide18.xml><?xml version="1.0" encoding="utf-8"?>
+<p:sld xmlns:a="http://schemas.openxmlformats.org/drawingml/2006/main" xmlns:p="http://schemas.openxmlformats.org/presentationml/2006/main" xmlns:r="http://schemas.openxmlformats.org/officeDocument/2006/relationships">
+  <p:cSld>
+    <p:spTree>
+      <p:nvGrpSpPr>
+        <p:cNvPr id="1" name=""/>
+        <p:cNvGrpSpPr/>
+        <p:nvPr/>
+      </p:nvGrpSpPr>
+      <p:grpSpPr/>
+      <p:sp>
+        <p:nvSpPr>
+          <p:cNvPr id="2" name="Rectangle 1"/>
+          <p:cNvSpPr/>
+          <p:nvPr/>
+        </p:nvSpPr>
+        <p:spPr>
+          <a:xfrm>
+            <a:off x="0" y="0"/>
+            <a:ext cx="12191695" cy="6858000"/>
+          </a:xfrm>
+          <a:prstGeom prst="rect">
+            <a:avLst/>
+          </a:prstGeom>
+          <a:solidFill>
+            <a:srgbClr val="F4F6FA"/>
+          </a:solidFill>
+          <a:ln>
+            <a:noFill/>
+          </a:ln>
+          <a:effectLst/>
+        </p:spPr>
+        <p:style>
+          <a:lnRef idx="1">
+            <a:schemeClr val="accent1"/>
+          </a:lnRef>
+          <a:fillRef idx="3">
+            <a:schemeClr val="accent1"/>
+          </a:fillRef>
+          <a:effectRef idx="2">
+            <a:schemeClr val="accent1"/>
+          </a:effectRef>
+          <a:fontRef idx="minor">
+            <a:schemeClr val="lt1"/>
+          </a:fontRef>
+        </p:style>
+        <p:txBody>
+          <a:bodyPr rtlCol="0" anchor="ctr"/>
+          <a:lstStyle/>
+          <a:p>
+            <a:pPr algn="ctr"/>
+          </a:p>
+        </p:txBody>
+      </p:sp>
+      <p:sp>
+        <p:nvSpPr>
+          <p:cNvPr id="3" name="TextBox 2"/>
+          <p:cNvSpPr txBox="1"/>
+          <p:nvPr/>
+        </p:nvSpPr>
+        <p:spPr>
+          <a:xfrm>
+            <a:off x="548640" y="347472"/>
+            <a:ext cx="10972800" cy="274320"/>
+          </a:xfrm>
+          <a:prstGeom prst="rect">
+            <a:avLst/>
+          </a:prstGeom>
+          <a:noFill/>
+        </p:spPr>
+        <p:txBody>
+          <a:bodyPr wrap="square" lIns="0" rIns="0" tIns="0" bIns="0" anchor="t">
+            <a:spAutoFit/>
+          </a:bodyPr>
+          <a:lstStyle/>
+          <a:p>
+            <a:pPr algn="l">
+              <a:lnSpc>
+                <a:spcPct val="130000"/>
+              </a:lnSpc>
+            </a:pPr>
+            <a:r>
+              <a:rPr sz="1100" b="1" i="0">
+                <a:solidFill>
+                  <a:srgbClr val="2563EB"/>
+                </a:solidFill>
+                <a:latin typeface="Calibri"/>
+              </a:rPr>
+              <a:t>付録 — 想定問答 (Q&amp;A)</a:t>
+            </a:r>
+          </a:p>
+        </p:txBody>
+      </p:sp>
+      <p:sp>
+        <p:nvSpPr>
+          <p:cNvPr id="4" name="TextBox 3"/>
+          <p:cNvSpPr txBox="1"/>
+          <p:nvPr/>
+        </p:nvSpPr>
+        <p:spPr>
+          <a:xfrm>
+            <a:off x="548640" y="621792"/>
+            <a:ext cx="11155680" cy="640080"/>
+          </a:xfrm>
+          <a:prstGeom prst="rect">
+            <a:avLst/>
+          </a:prstGeom>
+          <a:noFill/>
+        </p:spPr>
+        <p:txBody>
+          <a:bodyPr wrap="square" lIns="0" rIns="0" tIns="0" bIns="0" anchor="t">
+            <a:spAutoFit/>
+          </a:bodyPr>
+          <a:lstStyle/>
+          <a:p>
+            <a:pPr algn="l">
+              <a:lnSpc>
+                <a:spcPct val="130000"/>
+              </a:lnSpc>
+            </a:pPr>
+            <a:r>
+              <a:rPr sz="2800" b="1" i="0">
+                <a:solidFill>
+                  <a:srgbClr val="1F2937"/>
+                </a:solidFill>
+                <a:latin typeface="Cambria"/>
+              </a:rPr>
+              <a:t>よくある質問 ②  精度・性能・運用</a:t>
+            </a:r>
+          </a:p>
+        </p:txBody>
+      </p:sp>
+      <p:sp>
+        <p:nvSpPr>
+          <p:cNvPr id="5" name="Rounded Rectangle 4"/>
+          <p:cNvSpPr/>
+          <p:nvPr/>
+        </p:nvSpPr>
+        <p:spPr>
+          <a:xfrm>
+            <a:off x="548640" y="1783080"/>
+            <a:ext cx="11091672" cy="1386840"/>
+          </a:xfrm>
+          <a:prstGeom prst="roundRect">
+            <a:avLst/>
+          </a:prstGeom>
+          <a:solidFill>
+            <a:srgbClr val="FFFFFF"/>
+          </a:solidFill>
+          <a:ln w="9525">
+            <a:solidFill>
+              <a:srgbClr val="DDE3EE"/>
+            </a:solidFill>
+          </a:ln>
+          <a:effectLst/>
+        </p:spPr>
+        <p:style>
+          <a:lnRef idx="1">
+            <a:schemeClr val="accent1"/>
+          </a:lnRef>
+          <a:fillRef idx="3">
+            <a:schemeClr val="accent1"/>
+          </a:fillRef>
+          <a:effectRef idx="2">
+            <a:schemeClr val="accent1"/>
+          </a:effectRef>
+          <a:fontRef idx="minor">
+            <a:schemeClr val="lt1"/>
+          </a:fontRef>
+        </p:style>
+        <p:txBody>
+          <a:bodyPr rtlCol="0" anchor="ctr"/>
+          <a:lstStyle/>
+          <a:p>
+            <a:pPr algn="ctr"/>
+          </a:p>
+        </p:txBody>
+      </p:sp>
+      <p:sp>
+        <p:nvSpPr>
+          <p:cNvPr id="6" name="Rectangle 5"/>
+          <p:cNvSpPr/>
+          <p:nvPr/>
+        </p:nvSpPr>
+        <p:spPr>
+          <a:xfrm>
+            <a:off x="548640" y="1783080"/>
+            <a:ext cx="73152" cy="1386840"/>
+          </a:xfrm>
+          <a:prstGeom prst="rect">
+            <a:avLst/>
+          </a:prstGeom>
+          <a:solidFill>
+            <a:srgbClr val="2563EB"/>
+          </a:solidFill>
+          <a:ln>
+            <a:noFill/>
+          </a:ln>
+          <a:effectLst/>
+        </p:spPr>
+        <p:style>
+          <a:lnRef idx="1">
+            <a:schemeClr val="accent1"/>
+          </a:lnRef>
+          <a:fillRef idx="3">
+            <a:schemeClr val="accent1"/>
+          </a:fillRef>
+          <a:effectRef idx="2">
+            <a:schemeClr val="accent1"/>
+          </a:effectRef>
+          <a:fontRef idx="minor">
+            <a:schemeClr val="lt1"/>
+          </a:fontRef>
+        </p:style>
+        <p:txBody>
+          <a:bodyPr rtlCol="0" anchor="ctr"/>
+          <a:lstStyle/>
+          <a:p>
+            <a:pPr algn="ctr"/>
+          </a:p>
+        </p:txBody>
+      </p:sp>
+      <p:sp>
+        <p:nvSpPr>
+          <p:cNvPr id="7" name="TextBox 6"/>
+          <p:cNvSpPr txBox="1"/>
+          <p:nvPr/>
+        </p:nvSpPr>
+        <p:spPr>
+          <a:xfrm>
+            <a:off x="868680" y="1929384"/>
+            <a:ext cx="10515600" cy="457200"/>
+          </a:xfrm>
+          <a:prstGeom prst="rect">
+            <a:avLst/>
+          </a:prstGeom>
+          <a:noFill/>
+        </p:spPr>
+        <p:txBody>
+          <a:bodyPr wrap="square" lIns="0" rIns="0" tIns="0" bIns="0" anchor="t">
+            <a:spAutoFit/>
+          </a:bodyPr>
+          <a:lstStyle/>
+          <a:p>
+            <a:pPr algn="l">
+              <a:lnSpc>
+                <a:spcPct val="130000"/>
+              </a:lnSpc>
+            </a:pPr>
+            <a:r>
+              <a:rPr sz="1500" b="1" i="0">
+                <a:solidFill>
+                  <a:srgbClr val="1F2937"/>
+                </a:solidFill>
+                <a:latin typeface="Cambria"/>
+              </a:rPr>
+              <a:t>Q.  誤検知は多くならないの?</a:t>
+            </a:r>
+          </a:p>
+        </p:txBody>
+      </p:sp>
+      <p:sp>
+        <p:nvSpPr>
+          <p:cNvPr id="8" name="TextBox 7"/>
+          <p:cNvSpPr txBox="1"/>
+          <p:nvPr/>
+        </p:nvSpPr>
+        <p:spPr>
+          <a:xfrm>
+            <a:off x="868680" y="2386584"/>
+            <a:ext cx="10469880" cy="673608"/>
+          </a:xfrm>
+          <a:prstGeom prst="rect">
+            <a:avLst/>
+          </a:prstGeom>
+          <a:noFill/>
+        </p:spPr>
+        <p:txBody>
+          <a:bodyPr wrap="square" lIns="0" rIns="0" tIns="0" bIns="0" anchor="t">
+            <a:spAutoFit/>
+          </a:bodyPr>
+          <a:lstStyle/>
+          <a:p>
+            <a:pPr algn="l">
+              <a:lnSpc>
+                <a:spcPct val="132000"/>
+              </a:lnSpc>
+            </a:pPr>
+            <a:r>
+              <a:rPr sz="1250" b="0" i="0">
+                <a:solidFill>
+                  <a:srgbClr val="5B6472"/>
+                </a:solidFill>
+                <a:latin typeface="Calibri"/>
+              </a:rPr>
+              <a:t>A.  単一の特徴では鳴らさず複数条件の AND で判定。各ルールに誤検知例を明記し、ゴールデンイメージの許可リストや、GUI 上での TP/FP 判定・抑制で運用しながら絞り込める。</a:t>
+            </a:r>
+          </a:p>
+        </p:txBody>
+      </p:sp>
+      <p:sp>
+        <p:nvSpPr>
+          <p:cNvPr id="9" name="Rounded Rectangle 8"/>
+          <p:cNvSpPr/>
+          <p:nvPr/>
+        </p:nvSpPr>
+        <p:spPr>
+          <a:xfrm>
+            <a:off x="548640" y="3316224"/>
+            <a:ext cx="11091672" cy="1386840"/>
+          </a:xfrm>
+          <a:prstGeom prst="roundRect">
+            <a:avLst/>
+          </a:prstGeom>
+          <a:solidFill>
+            <a:srgbClr val="FFFFFF"/>
+          </a:solidFill>
+          <a:ln w="9525">
+            <a:solidFill>
+              <a:srgbClr val="DDE3EE"/>
+            </a:solidFill>
+          </a:ln>
+          <a:effectLst/>
+        </p:spPr>
+        <p:style>
+          <a:lnRef idx="1">
+            <a:schemeClr val="accent1"/>
+          </a:lnRef>
+          <a:fillRef idx="3">
+            <a:schemeClr val="accent1"/>
+          </a:fillRef>
+          <a:effectRef idx="2">
+            <a:schemeClr val="accent1"/>
+          </a:effectRef>
+          <a:fontRef idx="minor">
+            <a:schemeClr val="lt1"/>
+          </a:fontRef>
+        </p:style>
+        <p:txBody>
+          <a:bodyPr rtlCol="0" anchor="ctr"/>
+          <a:lstStyle/>
+          <a:p>
+            <a:pPr algn="ctr"/>
+          </a:p>
+        </p:txBody>
+      </p:sp>
+      <p:sp>
+        <p:nvSpPr>
+          <p:cNvPr id="10" name="Rectangle 9"/>
+          <p:cNvSpPr/>
+          <p:nvPr/>
+        </p:nvSpPr>
+        <p:spPr>
+          <a:xfrm>
+            <a:off x="548640" y="3316224"/>
+            <a:ext cx="73152" cy="1386840"/>
+          </a:xfrm>
+          <a:prstGeom prst="rect">
+            <a:avLst/>
+          </a:prstGeom>
+          <a:solidFill>
+            <a:srgbClr val="2563EB"/>
+          </a:solidFill>
+          <a:ln>
+            <a:noFill/>
+          </a:ln>
+          <a:effectLst/>
+        </p:spPr>
+        <p:style>
+          <a:lnRef idx="1">
+            <a:schemeClr val="accent1"/>
+          </a:lnRef>
+          <a:fillRef idx="3">
+            <a:schemeClr val="accent1"/>
+          </a:fillRef>
+          <a:effectRef idx="2">
+            <a:schemeClr val="accent1"/>
+          </a:effectRef>
+          <a:fontRef idx="minor">
+            <a:schemeClr val="lt1"/>
+          </a:fontRef>
+        </p:style>
+        <p:txBody>
+          <a:bodyPr rtlCol="0" anchor="ctr"/>
+          <a:lstStyle/>
+          <a:p>
+            <a:pPr algn="ctr"/>
+          </a:p>
+        </p:txBody>
+      </p:sp>
+      <p:sp>
+        <p:nvSpPr>
+          <p:cNvPr id="11" name="TextBox 10"/>
+          <p:cNvSpPr txBox="1"/>
+          <p:nvPr/>
+        </p:nvSpPr>
+        <p:spPr>
+          <a:xfrm>
+            <a:off x="868680" y="3462528"/>
+            <a:ext cx="10515600" cy="457200"/>
+          </a:xfrm>
+          <a:prstGeom prst="rect">
+            <a:avLst/>
+          </a:prstGeom>
+          <a:noFill/>
+        </p:spPr>
+        <p:txBody>
+          <a:bodyPr wrap="square" lIns="0" rIns="0" tIns="0" bIns="0" anchor="t">
+            <a:spAutoFit/>
+          </a:bodyPr>
+          <a:lstStyle/>
+          <a:p>
+            <a:pPr algn="l">
+              <a:lnSpc>
+                <a:spcPct val="130000"/>
+              </a:lnSpc>
+            </a:pPr>
+            <a:r>
+              <a:rPr sz="1500" b="1" i="0">
+                <a:solidFill>
+                  <a:srgbClr val="1F2937"/>
+                </a:solidFill>
+                <a:latin typeface="Cambria"/>
+              </a:rPr>
+              <a:t>Q.  速度や扱える規模は?</a:t>
+            </a:r>
+          </a:p>
+        </p:txBody>
+      </p:sp>
+      <p:sp>
+        <p:nvSpPr>
+          <p:cNvPr id="12" name="TextBox 11"/>
+          <p:cNvSpPr txBox="1"/>
+          <p:nvPr/>
+        </p:nvSpPr>
+        <p:spPr>
+          <a:xfrm>
+            <a:off x="868680" y="3919728"/>
+            <a:ext cx="10469880" cy="673608"/>
+          </a:xfrm>
+          <a:prstGeom prst="rect">
+            <a:avLst/>
+          </a:prstGeom>
+          <a:noFill/>
+        </p:spPr>
+        <p:txBody>
+          <a:bodyPr wrap="square" lIns="0" rIns="0" tIns="0" bIns="0" anchor="t">
+            <a:spAutoFit/>
+          </a:bodyPr>
+          <a:lstStyle/>
+          <a:p>
+            <a:pPr algn="l">
+              <a:lnSpc>
+                <a:spcPct val="132000"/>
+              </a:lnSpc>
+            </a:pPr>
+            <a:r>
+              <a:rPr sz="1250" b="0" i="0">
+                <a:solidFill>
+                  <a:srgbClr val="5B6472"/>
+                </a:solidFill>
+                <a:latin typeface="Calibri"/>
+              </a:rPr>
+              <a:t>A.  Rust 製で数万件を数十秒。lookup は起動時に 1 回だけリストを読み込み O(1) で照合するため、リストが増えても速度はほぼ一定（本デモでも 1.2 万件超を処理）。</a:t>
+            </a:r>
+          </a:p>
+        </p:txBody>
+      </p:sp>
+      <p:sp>
+        <p:nvSpPr>
+          <p:cNvPr id="13" name="Rounded Rectangle 12"/>
+          <p:cNvSpPr/>
+          <p:nvPr/>
+        </p:nvSpPr>
+        <p:spPr>
+          <a:xfrm>
+            <a:off x="548640" y="4849368"/>
+            <a:ext cx="11091672" cy="1386840"/>
+          </a:xfrm>
+          <a:prstGeom prst="roundRect">
+            <a:avLst/>
+          </a:prstGeom>
+          <a:solidFill>
+            <a:srgbClr val="FFFFFF"/>
+          </a:solidFill>
+          <a:ln w="9525">
+            <a:solidFill>
+              <a:srgbClr val="DDE3EE"/>
+            </a:solidFill>
+          </a:ln>
+          <a:effectLst/>
+        </p:spPr>
+        <p:style>
+          <a:lnRef idx="1">
+            <a:schemeClr val="accent1"/>
+          </a:lnRef>
+          <a:fillRef idx="3">
+            <a:schemeClr val="accent1"/>
+          </a:fillRef>
+          <a:effectRef idx="2">
+            <a:schemeClr val="accent1"/>
+          </a:effectRef>
+          <a:fontRef idx="minor">
+            <a:schemeClr val="lt1"/>
+          </a:fontRef>
+        </p:style>
+        <p:txBody>
+          <a:bodyPr rtlCol="0" anchor="ctr"/>
+          <a:lstStyle/>
+          <a:p>
+            <a:pPr algn="ctr"/>
+          </a:p>
+        </p:txBody>
+      </p:sp>
+      <p:sp>
+        <p:nvSpPr>
+          <p:cNvPr id="14" name="Rectangle 13"/>
+          <p:cNvSpPr/>
+          <p:nvPr/>
+        </p:nvSpPr>
+        <p:spPr>
+          <a:xfrm>
+            <a:off x="548640" y="4849368"/>
+            <a:ext cx="73152" cy="1386840"/>
+          </a:xfrm>
+          <a:prstGeom prst="rect">
+            <a:avLst/>
+          </a:prstGeom>
+          <a:solidFill>
+            <a:srgbClr val="2563EB"/>
+          </a:solidFill>
+          <a:ln>
+            <a:noFill/>
+          </a:ln>
+          <a:effectLst/>
+        </p:spPr>
+        <p:style>
+          <a:lnRef idx="1">
+            <a:schemeClr val="accent1"/>
+          </a:lnRef>
+          <a:fillRef idx="3">
+            <a:schemeClr val="accent1"/>
+          </a:fillRef>
+          <a:effectRef idx="2">
+            <a:schemeClr val="accent1"/>
+          </a:effectRef>
+          <a:fontRef idx="minor">
+            <a:schemeClr val="lt1"/>
+          </a:fontRef>
+        </p:style>
+        <p:txBody>
+          <a:bodyPr rtlCol="0" anchor="ctr"/>
+          <a:lstStyle/>
+          <a:p>
+            <a:pPr algn="ctr"/>
+          </a:p>
+        </p:txBody>
+      </p:sp>
+      <p:sp>
+        <p:nvSpPr>
+          <p:cNvPr id="15" name="TextBox 14"/>
+          <p:cNvSpPr txBox="1"/>
+          <p:nvPr/>
+        </p:nvSpPr>
+        <p:spPr>
+          <a:xfrm>
+            <a:off x="868680" y="4995672"/>
+            <a:ext cx="10515600" cy="457200"/>
+          </a:xfrm>
+          <a:prstGeom prst="rect">
+            <a:avLst/>
+          </a:prstGeom>
+          <a:noFill/>
+        </p:spPr>
+        <p:txBody>
+          <a:bodyPr wrap="square" lIns="0" rIns="0" tIns="0" bIns="0" anchor="t">
+            <a:spAutoFit/>
+          </a:bodyPr>
+          <a:lstStyle/>
+          <a:p>
+            <a:pPr algn="l">
+              <a:lnSpc>
+                <a:spcPct val="130000"/>
+              </a:lnSpc>
+            </a:pPr>
+            <a:r>
+              <a:rPr sz="1500" b="1" i="0">
+                <a:solidFill>
+                  <a:srgbClr val="1F2937"/>
+                </a:solidFill>
+                <a:latin typeface="Cambria"/>
+              </a:rPr>
+              <a:t>Q.  IoC リストはどうやって最新に保つ?</a:t>
+            </a:r>
+          </a:p>
+        </p:txBody>
+      </p:sp>
+      <p:sp>
+        <p:nvSpPr>
+          <p:cNvPr id="16" name="TextBox 15"/>
+          <p:cNvSpPr txBox="1"/>
+          <p:nvPr/>
+        </p:nvSpPr>
+        <p:spPr>
+          <a:xfrm>
+            <a:off x="868680" y="5452872"/>
+            <a:ext cx="10469880" cy="673608"/>
+          </a:xfrm>
+          <a:prstGeom prst="rect">
+            <a:avLst/>
+          </a:prstGeom>
+          <a:noFill/>
+        </p:spPr>
+        <p:txBody>
+          <a:bodyPr wrap="square" lIns="0" rIns="0" tIns="0" bIns="0" anchor="t">
+            <a:spAutoFit/>
+          </a:bodyPr>
+          <a:lstStyle/>
+          <a:p>
+            <a:pPr algn="l">
+              <a:lnSpc>
+                <a:spcPct val="132000"/>
+              </a:lnSpc>
+            </a:pPr>
+            <a:r>
+              <a:rPr sz="1250" b="0" i="0">
+                <a:solidFill>
+                  <a:srgbClr val="5B6472"/>
+                </a:solidFill>
+                <a:latin typeface="Calibri"/>
+              </a:rPr>
+              <a:t>A.  feeds.yml に宣言し、ボタン 1 つで取得・正規化 (loldrivers / MalwareBazaar / URLhaus / Feodo)。取得失敗時は前回分を保持し、カバレッジを空にしない設計。</a:t>
+            </a:r>
+          </a:p>
+        </p:txBody>
+      </p:sp>
+      <p:sp>
+        <p:nvSpPr>
+          <p:cNvPr id="17" name="TextBox 16"/>
+          <p:cNvSpPr txBox="1"/>
+          <p:nvPr/>
+        </p:nvSpPr>
+        <p:spPr>
+          <a:xfrm>
+            <a:off x="10972800" y="6446520"/>
+            <a:ext cx="914400" cy="274320"/>
+          </a:xfrm>
+          <a:prstGeom prst="rect">
+            <a:avLst/>
+          </a:prstGeom>
+          <a:noFill/>
+        </p:spPr>
+        <p:txBody>
+          <a:bodyPr wrap="square" lIns="0" rIns="0" tIns="0" bIns="0" anchor="t">
+            <a:spAutoFit/>
+          </a:bodyPr>
+          <a:lstStyle/>
+          <a:p>
+            <a:pPr algn="r">
+              <a:lnSpc>
+                <a:spcPct val="130000"/>
+              </a:lnSpc>
+            </a:pPr>
+            <a:r>
+              <a:rPr sz="900" b="0" i="0">
+                <a:solidFill>
+                  <a:srgbClr val="5B6472"/>
+                </a:solidFill>
+                <a:latin typeface="Calibri"/>
+              </a:rPr>
+              <a:t>付録</a:t>
+            </a:r>
+          </a:p>
+        </p:txBody>
+      </p:sp>
+    </p:spTree>
+  </p:cSld>
+  <p:clrMapOvr>
+    <a:masterClrMapping/>
+  </p:clrMapOvr>
+</p:sld>
+</file>
+
+<file path=ppt/slides/slide19.xml><?xml version="1.0" encoding="utf-8"?>
+<p:sld xmlns:a="http://schemas.openxmlformats.org/drawingml/2006/main" xmlns:p="http://schemas.openxmlformats.org/presentationml/2006/main" xmlns:r="http://schemas.openxmlformats.org/officeDocument/2006/relationships">
+  <p:cSld>
+    <p:spTree>
+      <p:nvGrpSpPr>
+        <p:cNvPr id="1" name=""/>
+        <p:cNvGrpSpPr/>
+        <p:nvPr/>
+      </p:nvGrpSpPr>
+      <p:grpSpPr/>
+      <p:sp>
+        <p:nvSpPr>
+          <p:cNvPr id="2" name="Rectangle 1"/>
+          <p:cNvSpPr/>
+          <p:nvPr/>
+        </p:nvSpPr>
+        <p:spPr>
+          <a:xfrm>
+            <a:off x="0" y="0"/>
+            <a:ext cx="12191695" cy="6858000"/>
+          </a:xfrm>
+          <a:prstGeom prst="rect">
+            <a:avLst/>
+          </a:prstGeom>
+          <a:solidFill>
+            <a:srgbClr val="F4F6FA"/>
+          </a:solidFill>
+          <a:ln>
+            <a:noFill/>
+          </a:ln>
+          <a:effectLst/>
+        </p:spPr>
+        <p:style>
+          <a:lnRef idx="1">
+            <a:schemeClr val="accent1"/>
+          </a:lnRef>
+          <a:fillRef idx="3">
+            <a:schemeClr val="accent1"/>
+          </a:fillRef>
+          <a:effectRef idx="2">
+            <a:schemeClr val="accent1"/>
+          </a:effectRef>
+          <a:fontRef idx="minor">
+            <a:schemeClr val="lt1"/>
+          </a:fontRef>
+        </p:style>
+        <p:txBody>
+          <a:bodyPr rtlCol="0" anchor="ctr"/>
+          <a:lstStyle/>
+          <a:p>
+            <a:pPr algn="ctr"/>
+          </a:p>
+        </p:txBody>
+      </p:sp>
+      <p:sp>
+        <p:nvSpPr>
+          <p:cNvPr id="3" name="TextBox 2"/>
+          <p:cNvSpPr txBox="1"/>
+          <p:nvPr/>
+        </p:nvSpPr>
+        <p:spPr>
+          <a:xfrm>
+            <a:off x="548640" y="347472"/>
+            <a:ext cx="10972800" cy="274320"/>
+          </a:xfrm>
+          <a:prstGeom prst="rect">
+            <a:avLst/>
+          </a:prstGeom>
+          <a:noFill/>
+        </p:spPr>
+        <p:txBody>
+          <a:bodyPr wrap="square" lIns="0" rIns="0" tIns="0" bIns="0" anchor="t">
+            <a:spAutoFit/>
+          </a:bodyPr>
+          <a:lstStyle/>
+          <a:p>
+            <a:pPr algn="l">
+              <a:lnSpc>
+                <a:spcPct val="130000"/>
+              </a:lnSpc>
+            </a:pPr>
+            <a:r>
+              <a:rPr sz="1100" b="1" i="0">
+                <a:solidFill>
+                  <a:srgbClr val="2563EB"/>
+                </a:solidFill>
+                <a:latin typeface="Calibri"/>
+              </a:rPr>
+              <a:t>付録 — 想定問答 (Q&amp;A)</a:t>
+            </a:r>
+          </a:p>
+        </p:txBody>
+      </p:sp>
+      <p:sp>
+        <p:nvSpPr>
+          <p:cNvPr id="4" name="TextBox 3"/>
+          <p:cNvSpPr txBox="1"/>
+          <p:nvPr/>
+        </p:nvSpPr>
+        <p:spPr>
+          <a:xfrm>
+            <a:off x="548640" y="621792"/>
+            <a:ext cx="11155680" cy="640080"/>
+          </a:xfrm>
+          <a:prstGeom prst="rect">
+            <a:avLst/>
+          </a:prstGeom>
+          <a:noFill/>
+        </p:spPr>
+        <p:txBody>
+          <a:bodyPr wrap="square" lIns="0" rIns="0" tIns="0" bIns="0" anchor="t">
+            <a:spAutoFit/>
+          </a:bodyPr>
+          <a:lstStyle/>
+          <a:p>
+            <a:pPr algn="l">
+              <a:lnSpc>
+                <a:spcPct val="130000"/>
+              </a:lnSpc>
+            </a:pPr>
+            <a:r>
+              <a:rPr sz="2800" b="1" i="0">
+                <a:solidFill>
+                  <a:srgbClr val="1F2937"/>
+                </a:solidFill>
+                <a:latin typeface="Cambria"/>
+              </a:rPr>
+              <a:t>よくある質問 ③  安全性・未知の攻撃・今後</a:t>
+            </a:r>
+          </a:p>
+        </p:txBody>
+      </p:sp>
+      <p:sp>
+        <p:nvSpPr>
+          <p:cNvPr id="5" name="Rounded Rectangle 4"/>
+          <p:cNvSpPr/>
+          <p:nvPr/>
+        </p:nvSpPr>
+        <p:spPr>
+          <a:xfrm>
+            <a:off x="548640" y="1783080"/>
+            <a:ext cx="11091672" cy="1386840"/>
+          </a:xfrm>
+          <a:prstGeom prst="roundRect">
+            <a:avLst/>
+          </a:prstGeom>
+          <a:solidFill>
+            <a:srgbClr val="FFFFFF"/>
+          </a:solidFill>
+          <a:ln w="9525">
+            <a:solidFill>
+              <a:srgbClr val="DDE3EE"/>
+            </a:solidFill>
+          </a:ln>
+          <a:effectLst/>
+        </p:spPr>
+        <p:style>
+          <a:lnRef idx="1">
+            <a:schemeClr val="accent1"/>
+          </a:lnRef>
+          <a:fillRef idx="3">
+            <a:schemeClr val="accent1"/>
+          </a:fillRef>
+          <a:effectRef idx="2">
+            <a:schemeClr val="accent1"/>
+          </a:effectRef>
+          <a:fontRef idx="minor">
+            <a:schemeClr val="lt1"/>
+          </a:fontRef>
+        </p:style>
+        <p:txBody>
+          <a:bodyPr rtlCol="0" anchor="ctr"/>
+          <a:lstStyle/>
+          <a:p>
+            <a:pPr algn="ctr"/>
+          </a:p>
+        </p:txBody>
+      </p:sp>
+      <p:sp>
+        <p:nvSpPr>
+          <p:cNvPr id="6" name="Rectangle 5"/>
+          <p:cNvSpPr/>
+          <p:nvPr/>
+        </p:nvSpPr>
+        <p:spPr>
+          <a:xfrm>
+            <a:off x="548640" y="1783080"/>
+            <a:ext cx="73152" cy="1386840"/>
+          </a:xfrm>
+          <a:prstGeom prst="rect">
+            <a:avLst/>
+          </a:prstGeom>
+          <a:solidFill>
+            <a:srgbClr val="2563EB"/>
+          </a:solidFill>
+          <a:ln>
+            <a:noFill/>
+          </a:ln>
+          <a:effectLst/>
+        </p:spPr>
+        <p:style>
+          <a:lnRef idx="1">
+            <a:schemeClr val="accent1"/>
+          </a:lnRef>
+          <a:fillRef idx="3">
+            <a:schemeClr val="accent1"/>
+          </a:fillRef>
+          <a:effectRef idx="2">
+            <a:schemeClr val="accent1"/>
+          </a:effectRef>
+          <a:fontRef idx="minor">
+            <a:schemeClr val="lt1"/>
+          </a:fontRef>
+        </p:style>
+        <p:txBody>
+          <a:bodyPr rtlCol="0" anchor="ctr"/>
+          <a:lstStyle/>
+          <a:p>
+            <a:pPr algn="ctr"/>
+          </a:p>
+        </p:txBody>
+      </p:sp>
+      <p:sp>
+        <p:nvSpPr>
+          <p:cNvPr id="7" name="TextBox 6"/>
+          <p:cNvSpPr txBox="1"/>
+          <p:nvPr/>
+        </p:nvSpPr>
+        <p:spPr>
+          <a:xfrm>
+            <a:off x="868680" y="1929384"/>
+            <a:ext cx="10515600" cy="457200"/>
+          </a:xfrm>
+          <a:prstGeom prst="rect">
+            <a:avLst/>
+          </a:prstGeom>
+          <a:noFill/>
+        </p:spPr>
+        <p:txBody>
+          <a:bodyPr wrap="square" lIns="0" rIns="0" tIns="0" bIns="0" anchor="t">
+            <a:spAutoFit/>
+          </a:bodyPr>
+          <a:lstStyle/>
+          <a:p>
+            <a:pPr algn="l">
+              <a:lnSpc>
+                <a:spcPct val="130000"/>
+              </a:lnSpc>
+            </a:pPr>
+            <a:r>
+              <a:rPr sz="1500" b="1" i="0">
+                <a:solidFill>
+                  <a:srgbClr val="1F2937"/>
+                </a:solidFill>
+                <a:latin typeface="Cambria"/>
+              </a:rPr>
+              <a:t>Q.  データは外部に送られない? 安全?</a:t>
+            </a:r>
+          </a:p>
+        </p:txBody>
+      </p:sp>
+      <p:sp>
+        <p:nvSpPr>
+          <p:cNvPr id="8" name="TextBox 7"/>
+          <p:cNvSpPr txBox="1"/>
+          <p:nvPr/>
+        </p:nvSpPr>
+        <p:spPr>
+          <a:xfrm>
+            <a:off x="868680" y="2386584"/>
+            <a:ext cx="10469880" cy="673608"/>
+          </a:xfrm>
+          <a:prstGeom prst="rect">
+            <a:avLst/>
+          </a:prstGeom>
+          <a:noFill/>
+        </p:spPr>
+        <p:txBody>
+          <a:bodyPr wrap="square" lIns="0" rIns="0" tIns="0" bIns="0" anchor="t">
+            <a:spAutoFit/>
+          </a:bodyPr>
+          <a:lstStyle/>
+          <a:p>
+            <a:pPr algn="l">
+              <a:lnSpc>
+                <a:spcPct val="132000"/>
+              </a:lnSpc>
+            </a:pPr>
+            <a:r>
+              <a:rPr sz="1250" b="0" i="0">
+                <a:solidFill>
+                  <a:srgbClr val="5B6472"/>
+                </a:solidFill>
+                <a:latin typeface="Calibri"/>
+              </a:rPr>
+              <a:t>A.  localhost 限定バインドで外部送信なし、追加ソフトも不要。自 PC のライブ解析は管理者権限＋明示チェック時のみ。DNS リバインドや CSRF への対策も実装済み。</a:t>
+            </a:r>
+          </a:p>
+        </p:txBody>
+      </p:sp>
+      <p:sp>
+        <p:nvSpPr>
+          <p:cNvPr id="9" name="Rounded Rectangle 8"/>
+          <p:cNvSpPr/>
+          <p:nvPr/>
+        </p:nvSpPr>
+        <p:spPr>
+          <a:xfrm>
+            <a:off x="548640" y="3316224"/>
+            <a:ext cx="11091672" cy="1386840"/>
+          </a:xfrm>
+          <a:prstGeom prst="roundRect">
+            <a:avLst/>
+          </a:prstGeom>
+          <a:solidFill>
+            <a:srgbClr val="FFFFFF"/>
+          </a:solidFill>
+          <a:ln w="9525">
+            <a:solidFill>
+              <a:srgbClr val="DDE3EE"/>
+            </a:solidFill>
+          </a:ln>
+          <a:effectLst/>
+        </p:spPr>
+        <p:style>
+          <a:lnRef idx="1">
+            <a:schemeClr val="accent1"/>
+          </a:lnRef>
+          <a:fillRef idx="3">
+            <a:schemeClr val="accent1"/>
+          </a:fillRef>
+          <a:effectRef idx="2">
+            <a:schemeClr val="accent1"/>
+          </a:effectRef>
+          <a:fontRef idx="minor">
+            <a:schemeClr val="lt1"/>
+          </a:fontRef>
+        </p:style>
+        <p:txBody>
+          <a:bodyPr rtlCol="0" anchor="ctr"/>
+          <a:lstStyle/>
+          <a:p>
+            <a:pPr algn="ctr"/>
+          </a:p>
+        </p:txBody>
+      </p:sp>
+      <p:sp>
+        <p:nvSpPr>
+          <p:cNvPr id="10" name="Rectangle 9"/>
+          <p:cNvSpPr/>
+          <p:nvPr/>
+        </p:nvSpPr>
+        <p:spPr>
+          <a:xfrm>
+            <a:off x="548640" y="3316224"/>
+            <a:ext cx="73152" cy="1386840"/>
+          </a:xfrm>
+          <a:prstGeom prst="rect">
+            <a:avLst/>
+          </a:prstGeom>
+          <a:solidFill>
+            <a:srgbClr val="2563EB"/>
+          </a:solidFill>
+          <a:ln>
+            <a:noFill/>
+          </a:ln>
+          <a:effectLst/>
+        </p:spPr>
+        <p:style>
+          <a:lnRef idx="1">
+            <a:schemeClr val="accent1"/>
+          </a:lnRef>
+          <a:fillRef idx="3">
+            <a:schemeClr val="accent1"/>
+          </a:fillRef>
+          <a:effectRef idx="2">
+            <a:schemeClr val="accent1"/>
+          </a:effectRef>
+          <a:fontRef idx="minor">
+            <a:schemeClr val="lt1"/>
+          </a:fontRef>
+        </p:style>
+        <p:txBody>
+          <a:bodyPr rtlCol="0" anchor="ctr"/>
+          <a:lstStyle/>
+          <a:p>
+            <a:pPr algn="ctr"/>
+          </a:p>
+        </p:txBody>
+      </p:sp>
+      <p:sp>
+        <p:nvSpPr>
+          <p:cNvPr id="11" name="TextBox 10"/>
+          <p:cNvSpPr txBox="1"/>
+          <p:nvPr/>
+        </p:nvSpPr>
+        <p:spPr>
+          <a:xfrm>
+            <a:off x="868680" y="3462528"/>
+            <a:ext cx="10515600" cy="457200"/>
+          </a:xfrm>
+          <a:prstGeom prst="rect">
+            <a:avLst/>
+          </a:prstGeom>
+          <a:noFill/>
+        </p:spPr>
+        <p:txBody>
+          <a:bodyPr wrap="square" lIns="0" rIns="0" tIns="0" bIns="0" anchor="t">
+            <a:spAutoFit/>
+          </a:bodyPr>
+          <a:lstStyle/>
+          <a:p>
+            <a:pPr algn="l">
+              <a:lnSpc>
+                <a:spcPct val="130000"/>
+              </a:lnSpc>
+            </a:pPr>
+            <a:r>
+              <a:rPr sz="1500" b="1" i="0">
+                <a:solidFill>
+                  <a:srgbClr val="1F2937"/>
+                </a:solidFill>
+                <a:latin typeface="Cambria"/>
+              </a:rPr>
+              <a:t>Q.  未知の攻撃 (ゼロデイ) は検知できる?</a:t>
+            </a:r>
+          </a:p>
+        </p:txBody>
+      </p:sp>
+      <p:sp>
+        <p:nvSpPr>
+          <p:cNvPr id="12" name="TextBox 11"/>
+          <p:cNvSpPr txBox="1"/>
+          <p:nvPr/>
+        </p:nvSpPr>
+        <p:spPr>
+          <a:xfrm>
+            <a:off x="868680" y="3919728"/>
+            <a:ext cx="10469880" cy="673608"/>
+          </a:xfrm>
+          <a:prstGeom prst="rect">
+            <a:avLst/>
+          </a:prstGeom>
+          <a:noFill/>
+        </p:spPr>
+        <p:txBody>
+          <a:bodyPr wrap="square" lIns="0" rIns="0" tIns="0" bIns="0" anchor="t">
+            <a:spAutoFit/>
+          </a:bodyPr>
+          <a:lstStyle/>
+          <a:p>
+            <a:pPr algn="l">
+              <a:lnSpc>
+                <a:spcPct val="132000"/>
+              </a:lnSpc>
+            </a:pPr>
+            <a:r>
+              <a:rPr sz="1250" b="0" i="0">
+                <a:solidFill>
+                  <a:srgbClr val="5B6472"/>
+                </a:solidFill>
+                <a:latin typeface="Calibri"/>
+              </a:rPr>
+              <a:t>A.  ルールは既知の手口に強い。未知は振る舞い分析（急増・拡散・沈黙・時間外）で「いつもと違う」を拾う、という二段構えでカバーする。</a:t>
+            </a:r>
+          </a:p>
+        </p:txBody>
+      </p:sp>
+      <p:sp>
+        <p:nvSpPr>
+          <p:cNvPr id="13" name="Rounded Rectangle 12"/>
+          <p:cNvSpPr/>
+          <p:nvPr/>
+        </p:nvSpPr>
+        <p:spPr>
+          <a:xfrm>
+            <a:off x="548640" y="4849368"/>
+            <a:ext cx="11091672" cy="1386840"/>
+          </a:xfrm>
+          <a:prstGeom prst="roundRect">
+            <a:avLst/>
+          </a:prstGeom>
+          <a:solidFill>
+            <a:srgbClr val="FFFFFF"/>
+          </a:solidFill>
+          <a:ln w="9525">
+            <a:solidFill>
+              <a:srgbClr val="DDE3EE"/>
+            </a:solidFill>
+          </a:ln>
+          <a:effectLst/>
+        </p:spPr>
+        <p:style>
+          <a:lnRef idx="1">
+            <a:schemeClr val="accent1"/>
+          </a:lnRef>
+          <a:fillRef idx="3">
+            <a:schemeClr val="accent1"/>
+          </a:fillRef>
+          <a:effectRef idx="2">
+            <a:schemeClr val="accent1"/>
+          </a:effectRef>
+          <a:fontRef idx="minor">
+            <a:schemeClr val="lt1"/>
+          </a:fontRef>
+        </p:style>
+        <p:txBody>
+          <a:bodyPr rtlCol="0" anchor="ctr"/>
+          <a:lstStyle/>
+          <a:p>
+            <a:pPr algn="ctr"/>
+          </a:p>
+        </p:txBody>
+      </p:sp>
+      <p:sp>
+        <p:nvSpPr>
+          <p:cNvPr id="14" name="Rectangle 13"/>
+          <p:cNvSpPr/>
+          <p:nvPr/>
+        </p:nvSpPr>
+        <p:spPr>
+          <a:xfrm>
+            <a:off x="548640" y="4849368"/>
+            <a:ext cx="73152" cy="1386840"/>
+          </a:xfrm>
+          <a:prstGeom prst="rect">
+            <a:avLst/>
+          </a:prstGeom>
+          <a:solidFill>
+            <a:srgbClr val="2563EB"/>
+          </a:solidFill>
+          <a:ln>
+            <a:noFill/>
+          </a:ln>
+          <a:effectLst/>
+        </p:spPr>
+        <p:style>
+          <a:lnRef idx="1">
+            <a:schemeClr val="accent1"/>
+          </a:lnRef>
+          <a:fillRef idx="3">
+            <a:schemeClr val="accent1"/>
+          </a:fillRef>
+          <a:effectRef idx="2">
+            <a:schemeClr val="accent1"/>
+          </a:effectRef>
+          <a:fontRef idx="minor">
+            <a:schemeClr val="lt1"/>
+          </a:fontRef>
+        </p:style>
+        <p:txBody>
+          <a:bodyPr rtlCol="0" anchor="ctr"/>
+          <a:lstStyle/>
+          <a:p>
+            <a:pPr algn="ctr"/>
+          </a:p>
+        </p:txBody>
+      </p:sp>
+      <p:sp>
+        <p:nvSpPr>
+          <p:cNvPr id="15" name="TextBox 14"/>
+          <p:cNvSpPr txBox="1"/>
+          <p:nvPr/>
+        </p:nvSpPr>
+        <p:spPr>
+          <a:xfrm>
+            <a:off x="868680" y="4995672"/>
+            <a:ext cx="10515600" cy="457200"/>
+          </a:xfrm>
+          <a:prstGeom prst="rect">
+            <a:avLst/>
+          </a:prstGeom>
+          <a:noFill/>
+        </p:spPr>
+        <p:txBody>
+          <a:bodyPr wrap="square" lIns="0" rIns="0" tIns="0" bIns="0" anchor="t">
+            <a:spAutoFit/>
+          </a:bodyPr>
+          <a:lstStyle/>
+          <a:p>
+            <a:pPr algn="l">
+              <a:lnSpc>
+                <a:spcPct val="130000"/>
+              </a:lnSpc>
+            </a:pPr>
+            <a:r>
+              <a:rPr sz="1500" b="1" i="0">
+                <a:solidFill>
+                  <a:srgbClr val="1F2937"/>
+                </a:solidFill>
+                <a:latin typeface="Cambria"/>
+              </a:rPr>
+              <a:t>Q.  今後の発展は?</a:t>
+            </a:r>
+          </a:p>
+        </p:txBody>
+      </p:sp>
+      <p:sp>
+        <p:nvSpPr>
+          <p:cNvPr id="16" name="TextBox 15"/>
+          <p:cNvSpPr txBox="1"/>
+          <p:nvPr/>
+        </p:nvSpPr>
+        <p:spPr>
+          <a:xfrm>
+            <a:off x="868680" y="5452872"/>
+            <a:ext cx="10469880" cy="673608"/>
+          </a:xfrm>
+          <a:prstGeom prst="rect">
+            <a:avLst/>
+          </a:prstGeom>
+          <a:noFill/>
+        </p:spPr>
+        <p:txBody>
+          <a:bodyPr wrap="square" lIns="0" rIns="0" tIns="0" bIns="0" anchor="t">
+            <a:spAutoFit/>
+          </a:bodyPr>
+          <a:lstStyle/>
+          <a:p>
+            <a:pPr algn="l">
+              <a:lnSpc>
+                <a:spcPct val="132000"/>
+              </a:lnSpc>
+            </a:pPr>
+            <a:r>
+              <a:rPr sz="1250" b="0" i="0">
+                <a:solidFill>
+                  <a:srgbClr val="5B6472"/>
+                </a:solidFill>
+                <a:latin typeface="Calibri"/>
+              </a:rPr>
+              <a:t>A.  時間の流れを追った相関分析（「A の後に B が起きたら怪しい」）や、AI による検知ルールの自動生成へ。</a:t>
+            </a:r>
+          </a:p>
+        </p:txBody>
+      </p:sp>
+      <p:sp>
+        <p:nvSpPr>
+          <p:cNvPr id="17" name="TextBox 16"/>
+          <p:cNvSpPr txBox="1"/>
+          <p:nvPr/>
+        </p:nvSpPr>
+        <p:spPr>
+          <a:xfrm>
+            <a:off x="10972800" y="6446520"/>
+            <a:ext cx="914400" cy="274320"/>
+          </a:xfrm>
+          <a:prstGeom prst="rect">
+            <a:avLst/>
+          </a:prstGeom>
+          <a:noFill/>
+        </p:spPr>
+        <p:txBody>
+          <a:bodyPr wrap="square" lIns="0" rIns="0" tIns="0" bIns="0" anchor="t">
+            <a:spAutoFit/>
+          </a:bodyPr>
+          <a:lstStyle/>
+          <a:p>
+            <a:pPr algn="r">
+              <a:lnSpc>
+                <a:spcPct val="130000"/>
+              </a:lnSpc>
+            </a:pPr>
+            <a:r>
+              <a:rPr sz="900" b="0" i="0">
+                <a:solidFill>
+                  <a:srgbClr val="5B6472"/>
+                </a:solidFill>
+                <a:latin typeface="Calibri"/>
+              </a:rPr>
+              <a:t>付録</a:t>
+            </a:r>
+          </a:p>
+        </p:txBody>
+      </p:sp>
+    </p:spTree>
+  </p:cSld>
+  <p:clrMapOvr>
+    <a:masterClrMapping/>
+  </p:clrMapOvr>
+</p:sld>
+</file>
+
 <file path=ppt/slides/slide2.xml><?xml version="1.0" encoding="utf-8"?>
 <p:sld xmlns:a="http://schemas.openxmlformats.org/drawingml/2006/main" xmlns:p="http://schemas.openxmlformats.org/presentationml/2006/main" xmlns:r="http://schemas.openxmlformats.org/officeDocument/2006/relationships">
   <p:cSld>
@@ -17160,7 +19212,7 @@
                 </a:solidFill>
                 <a:latin typeface="Calibri"/>
               </a:rPr>
-              <a:t>ゼロから開発 (約 8,000 行)</a:t>
+              <a:t>ゼロから開発</a:t>
             </a:r>
           </a:p>
         </p:txBody>

</xml_diff>

<commit_message>
docs(slides): fix note/slide misalignment after eval insert; set presenter, drop date
Inserting the evaluation slide at 13 shifted the speaker notes by one, so
the 検証 slide showed the demo script and vice versa. Swap notes 13<->14
so each slide carries its own script again. Set the title presenter to
島崎朝日 / 小林研究室 and remove the date.

Co-Authored-By: Claude Fable 5 <noreply@anthropic.com>
</commit_message>
<xml_diff>
--- a/docs/presentation/pptx/hayabusa-plus.pptx
+++ b/docs/presentation/pptx/hayabusa-plus.pptx
@@ -846,17 +846,17 @@
           <a:lstStyle/>
           <a:p>
             <a:r>
-              <a:t>ここから実際の画面でお見せします。サンプルログを読み込んで、調査の流れを見ていただきます。</a:t>
-            </a:r>
-          </a:p>
-          <a:p>
-            <a:r>
-              <a:t>(デモ: スキャン実行 → ダッシュボードで全体把握 → 検知の日本語解説 → ホスト別の危険度ランキング、の順に見せる)</a:t>
-            </a:r>
-          </a:p>
-          <a:p>
-            <a:r>
-              <a:t>※ ライブが不調なときは、スライド中央の動画をクリックすれば同じ流れの録画 (約 38 秒・字幕つき) が再生されます。</a:t>
+              <a:t>研究として「で、効果は?」に答えるスライドです。</a:t>
+            </a:r>
+          </a:p>
+          <a:p>
+            <a:r>
+              <a:t>核心の自作 lookup 拡張は、既知の悪用ドライバのハッシュを仕込んだ検証用ログで critical 検知を確認できました ── ルール本文を変えずに外部リスト側だけで検知できる、という仕組みの実証です。</a:t>
+            </a:r>
+          </a:p>
+          <a:p>
+            <a:r>
+              <a:t>さらに公開されている攻撃サンプル 6 種を読み込ませると 5 種で脅威を検知。なおここでの発火は上流ルールと自作分の合算で、自作 13 ルールは対応する痕跡を含むログで鳴る設計、という点も正直に添えてあります。</a:t>
             </a:r>
           </a:p>
         </p:txBody>
@@ -926,17 +926,17 @@
           <a:lstStyle/>
           <a:p>
             <a:r>
-              <a:t>研究として「で、効果は?」に答えるスライドです。</a:t>
-            </a:r>
-          </a:p>
-          <a:p>
-            <a:r>
-              <a:t>核心の自作 lookup 拡張は、既知の悪用ドライバのハッシュを仕込んだ検証用ログで critical 検知を確認できました ── ルール本文を変えずに外部リスト側だけで検知できる、という仕組みの実証です。</a:t>
-            </a:r>
-          </a:p>
-          <a:p>
-            <a:r>
-              <a:t>さらに公開されている攻撃サンプル 6 種を読み込ませると 5 種で脅威を検知。なおここでの発火は上流ルールと自作分の合算で、自作 13 ルールは対応する痕跡を含むログで鳴る設計、という点も正直に添えてあります。</a:t>
+              <a:t>ここから実際の画面でお見せします。サンプルログを読み込んで、調査の流れを見ていただきます。</a:t>
+            </a:r>
+          </a:p>
+          <a:p>
+            <a:r>
+              <a:t>(デモ: スキャン実行 → ダッシュボードで全体把握 → 検知の日本語解説 → ホスト別の危険度ランキング、の順に見せる)</a:t>
+            </a:r>
+          </a:p>
+          <a:p>
+            <a:r>
+              <a:t>※ ライブが不調なときは、スライド中央の動画をクリックすれば同じ流れの録画 (約 38 秒・字幕つき) が再生されます。</a:t>
             </a:r>
           </a:p>
         </p:txBody>
@@ -5159,13 +5159,13 @@
               </a:lnSpc>
             </a:pPr>
             <a:r>
-              <a:rPr sz="1500" b="0" i="0">
+              <a:rPr sz="1600" b="0" i="0">
                 <a:solidFill>
                   <a:srgbClr val="FFFFFF"/>
                 </a:solidFill>
                 <a:latin typeface="Calibri"/>
               </a:rPr>
-              <a:t>発表者: （氏名）   ・   所属: （学科 / 研究室）   ・   2026-06-18</a:t>
+              <a:t>発表者: 島崎朝日   ・   所属: 小林研究室</a:t>
             </a:r>
           </a:p>
         </p:txBody>

</xml_diff>

<commit_message>
docs(slides): reword slide 13 note into spoken script
The evaluation slide's speaker note ended with a memo-style line ('…正直に
添えてあります') that describes the slide rather than something to say.
Rewrite it as a spoken script addressed to the audience. Demo/appendix
notes keep their parenthetical stage cues by design.

Co-Authored-By: Claude Fable 5 <noreply@anthropic.com>
</commit_message>
<xml_diff>
--- a/docs/presentation/pptx/hayabusa-plus.pptx
+++ b/docs/presentation/pptx/hayabusa-plus.pptx
@@ -846,17 +846,17 @@
           <a:lstStyle/>
           <a:p>
             <a:r>
-              <a:t>研究として「で、効果は?」に答えるスライドです。</a:t>
-            </a:r>
-          </a:p>
-          <a:p>
-            <a:r>
-              <a:t>核心の自作 lookup 拡張は、既知の悪用ドライバのハッシュを仕込んだ検証用ログで critical 検知を確認できました ── ルール本文を変えずに外部リスト側だけで検知できる、という仕組みの実証です。</a:t>
-            </a:r>
-          </a:p>
-          <a:p>
-            <a:r>
-              <a:t>さらに公開されている攻撃サンプル 6 種を読み込ませると 5 種で脅威を検知。なおここでの発火は上流ルールと自作分の合算で、自作 13 ルールは対応する痕跡を含むログで鳴る設計、という点も正直に添えてあります。</a:t>
+              <a:t>研究として大事な「で、効果は?」にお答えします。</a:t>
+            </a:r>
+          </a:p>
+          <a:p>
+            <a:r>
+              <a:t>まず核心の自作 lookup 拡張です。既知の悪用ドライバのハッシュを仕込んだ検証用ログを読み込ませると、critical で検知できました。ルール本文は 1 行も変えず、外部のリスト側だけで検知できる ── この仕組みが狙いどおり動くことを確認できた、ということです。</a:t>
+            </a:r>
+          </a:p>
+          <a:p>
+            <a:r>
+              <a:t>次に、公開されている攻撃サンプル 6 種で試すと、5 種で脅威を検知できました。ひとつ正直にお伝えすると、ここで鳴っているのは上流ルールと自作分の合算で、自作 13 ルールは対応する痕跡が出たときに鳴る設計です。ですので「すべてを自作ルールで捕まえた」とは申しません。</a:t>
             </a:r>
           </a:p>
         </p:txBody>

</xml_diff>

<commit_message>
docs(slides): soften slide 13 wording (note + footnote + caption)
Slide 13's explanation read too formal. Rewrite the speaker note in a
relaxed, conversational register, and plain-语 the stiffest on-slide text
(the ② footnote and the bottom caption).

Co-Authored-By: Claude Fable 5 <noreply@anthropic.com>
</commit_message>
<xml_diff>
--- a/docs/presentation/pptx/hayabusa-plus.pptx
+++ b/docs/presentation/pptx/hayabusa-plus.pptx
@@ -846,17 +846,17 @@
           <a:lstStyle/>
           <a:p>
             <a:r>
-              <a:t>研究として大事な「で、効果は?」にお答えします。</a:t>
-            </a:r>
-          </a:p>
-          <a:p>
-            <a:r>
-              <a:t>まず核心の自作 lookup 拡張です。既知の悪用ドライバのハッシュを仕込んだ検証用ログを読み込ませると、critical で検知できました。ルール本文は 1 行も変えず、外部のリスト側だけで検知できる ── この仕組みが狙いどおり動くことを確認できた、ということです。</a:t>
-            </a:r>
-          </a:p>
-          <a:p>
-            <a:r>
-              <a:t>次に、公開されている攻撃サンプル 6 種で試すと、5 種で脅威を検知できました。ひとつ正直にお伝えすると、ここで鳴っているのは上流ルールと自作分の合算で、自作 13 ルールは対応する痕跡が出たときに鳴る設計です。ですので「すべてを自作ルールで捕まえた」とは申しません。</a:t>
+              <a:t>ここは「で、結局ちゃんと効くの?」に答えるスライドです。</a:t>
+            </a:r>
+          </a:p>
+          <a:p>
+            <a:r>
+              <a:t>まず自作した lookup 拡張から。悪用ドライバの“指紋”をわざと仕込んだログを読ませてみたら、ちゃんと critical で引っかかりました。ルールは 1 行も書き換えず、リスト側を差し替えるだけ。狙いどおり動きました。</a:t>
+            </a:r>
+          </a:p>
+          <a:p>
+            <a:r>
+              <a:t>次に、公開されている攻撃サンプル 6 種で試したら、5 種で検知できました。ここだけ正直に言うと、鳴っているのは既存ルールと自作分の合わせ技で、自作の13 本は“その痕跡が出たとき”に鳴る作りです。なので「全部うちのルールで捕まえた」とまでは言いません。</a:t>
             </a:r>
           </a:p>
         </p:txBody>
@@ -10666,7 +10666,7 @@
                 </a:solidFill>
                 <a:latin typeface="Calibri"/>
               </a:rPr>
-              <a:t>※ ここでの発火は上流 Sigma ルールと自作分の合算。自作の 13 ルールは対応する痕跡（Sysmon EID 1 の wevtutil 等）を含むログで発火する設計。</a:t>
+              <a:t>※ ②で鳴ったのは既存ルールと自作分の合わせ技。自作の 13 本は、対応する痕跡（wevtutil 等）が出たログで鳴る作りです。</a:t>
             </a:r>
           </a:p>
         </p:txBody>
@@ -10705,7 +10705,7 @@
                 </a:solidFill>
                 <a:latin typeface="Calibri"/>
               </a:rPr>
-              <a:t>実際のログを読み込ませ、平文ではなく検知として浮かび上がることを確認。</a:t>
+              <a:t>実際のログを読ませて、危ない動きがちゃんと “検知” として浮かび上がるか確かめました。</a:t>
             </a:r>
           </a:p>
         </p:txBody>

</xml_diff>